<commit_message>
Reframe identification: total pandemic effect (not 'COVID per se'); honest about why peer-province design doesn't help
</commit_message>
<xml_diff>
--- a/slides.pptx
+++ b/slides.pptx
@@ -4029,29 +4029,29 @@
                 </a:solidFill>
                 <a:latin typeface="Helvetica Neue"/>
               </a:rPr>
-              <a:t>What we can claim</a:t>
-            </a:r>
-          </a:p>
-          <a:p>
-            <a:r>
-              <a:rPr sz="1400" b="0">
+              <a:t>What the estimate captures</a:t>
+            </a:r>
+          </a:p>
+          <a:p>
+            <a:r>
+              <a:rPr sz="1400" b="1">
                 <a:solidFill>
                   <a:srgbClr val="1A1A1A"/>
                 </a:solidFill>
                 <a:latin typeface="Helvetica Neue"/>
               </a:rPr>
-              <a:t>A sharp, large, robust break in Alberta opioid mortality at 2020 Q2.</a:t>
-            </a:r>
-          </a:p>
-          <a:p>
-            <a:r>
-              <a:rPr sz="1300" b="0">
+              <a:t>The total effect of the COVID-19 pandemic on Alberta opioid mortality.</a:t>
+            </a:r>
+          </a:p>
+          <a:p>
+            <a:r>
+              <a:rPr sz="1200" b="0">
                 <a:solidFill>
                   <a:srgbClr val="555555"/>
                 </a:solidFill>
                 <a:latin typeface="Helvetica Neue"/>
               </a:rPr>
-              <a:t>Pre-trend flat, placebos null, donut and NB cross-check consistent. This is a real shift in the data, not an artefact of specification choices.</a:t>
+              <a:t>Including the bundle of policy and social responses the pandemic produced: supply-chain disruption in the unregulated drug supply, reduced harm-reduction service capacity, mental-health service disruption, social isolation, economic shock. These are downstream of COVID, not parallel causes.</a:t>
             </a:r>
           </a:p>
         </p:txBody>
@@ -4064,7 +4064,7 @@
         </p:nvSpPr>
         <p:spPr>
           <a:xfrm>
-            <a:off x="548640" y="2834640"/>
+            <a:off x="548640" y="3017520"/>
             <a:ext cx="10972800" cy="365760"/>
           </a:xfrm>
           <a:prstGeom prst="rect">
@@ -4086,29 +4086,29 @@
                 </a:solidFill>
                 <a:latin typeface="Helvetica Neue"/>
               </a:rPr>
-              <a:t>What we cannot claim</a:t>
-            </a:r>
-          </a:p>
-          <a:p>
-            <a:r>
-              <a:rPr sz="1400" b="0">
+              <a:t>What it does not do</a:t>
+            </a:r>
+          </a:p>
+          <a:p>
+            <a:r>
+              <a:rPr sz="1400" b="1">
                 <a:solidFill>
                   <a:srgbClr val="1A1A1A"/>
                 </a:solidFill>
                 <a:latin typeface="Helvetica Neue"/>
               </a:rPr>
-              <a:t>That COVID-19 itself caused the jump.</a:t>
-            </a:r>
-          </a:p>
-          <a:p>
-            <a:r>
-              <a:rPr sz="1300" b="0">
+              <a:t>Decompose that total into its component channels.</a:t>
+            </a:r>
+          </a:p>
+          <a:p>
+            <a:r>
+              <a:rPr sz="1200" b="0">
                 <a:solidFill>
                   <a:srgbClr val="555555"/>
                 </a:solidFill>
                 <a:latin typeface="Helvetica Neue"/>
               </a:rPr>
-              <a:t>Many things moved at the same cutoff: the virus, public health emergency response, supply chain for the unregulated drug supply, harm reduction service capacity, mental health services, social isolation, and economic shock. ITS with a single cutoff cannot separate them.</a:t>
+              <a:t>The estimate cannot tell you what share came from supply toxicity vs. service capacity vs. isolation vs. economic shock. A peer-province comparison would not fix this — all provinces faced COVID and its policy response at essentially the same time, so the comparison identifies Alberta-specific deviation, not a clean COVID-only channel.</a:t>
             </a:r>
           </a:p>
         </p:txBody>
@@ -4121,7 +4121,7 @@
         </p:nvSpPr>
         <p:spPr>
           <a:xfrm>
-            <a:off x="548640" y="4572000"/>
+            <a:off x="548640" y="4937760"/>
             <a:ext cx="10972800" cy="365760"/>
           </a:xfrm>
           <a:prstGeom prst="rect">
@@ -4143,40 +4143,51 @@
                 </a:solidFill>
                 <a:latin typeface="Helvetica Neue"/>
               </a:rPr>
-              <a:t>Next steps to sharpen identification</a:t>
-            </a:r>
-          </a:p>
-          <a:p>
-            <a:r>
-              <a:rPr sz="1300" b="0">
+              <a:t>Realistic next steps</a:t>
+            </a:r>
+          </a:p>
+          <a:p>
+            <a:r>
+              <a:rPr sz="1200" b="0">
                 <a:solidFill>
                   <a:srgbClr val="1A1A1A"/>
                 </a:solidFill>
                 <a:latin typeface="Helvetica Neue"/>
               </a:rPr>
-              <a:t>1. Difference-in-discontinuities using other provinces with different pandemic-response timing</a:t>
-            </a:r>
-          </a:p>
-          <a:p>
-            <a:r>
-              <a:rPr sz="1300" b="0">
+              <a:t>1. Mechanism decomposition: triangulate supply-side, service-capacity, and outcome signals to attribute share</a:t>
+            </a:r>
+          </a:p>
+          <a:p>
+            <a:r>
+              <a:rPr sz="1200" b="0">
                 <a:solidFill>
                   <a:srgbClr val="1A1A1A"/>
                 </a:solidFill>
                 <a:latin typeface="Helvetica Neue"/>
               </a:rPr>
-              <a:t>2. Synthetic control to build a counterfactual Alberta without COVID</a:t>
-            </a:r>
-          </a:p>
-          <a:p>
-            <a:r>
-              <a:rPr sz="1300" b="0">
+              <a:t>2. Heterogeneity: by age, sex, zone, substance type — where the level shift concentrated</a:t>
+            </a:r>
+          </a:p>
+          <a:p>
+            <a:r>
+              <a:rPr sz="1200" b="0">
                 <a:solidFill>
                   <a:srgbClr val="1A1A1A"/>
                 </a:solidFill>
                 <a:latin typeface="Helvetica Neue"/>
               </a:rPr>
-              <a:t>3. Stratification by age, sex, zone, and substance type to localise where the shift concentrated</a:t>
+              <a:t>3. Post-period dynamics: explicitly model the rise-and-decline shape, not just the immediate level shift</a:t>
+            </a:r>
+          </a:p>
+          <a:p>
+            <a:r>
+              <a:rPr sz="1200" b="0">
+                <a:solidFill>
+                  <a:srgbClr val="1A1A1A"/>
+                </a:solidFill>
+                <a:latin typeface="Helvetica Neue"/>
+              </a:rPr>
+              <a:t>4. Cumulative excess deaths through end-of-sample as a policy-relevant quantity</a:t>
             </a:r>
           </a:p>
         </p:txBody>

</xml_diff>

<commit_message>
Rebuild deck and writeup in GoA-style: pyramid structure, B&W, bullet points only, no jargon in slide bodies
</commit_message>
<xml_diff>
--- a/slides.pptx
+++ b/slides.pptx
@@ -9,6 +9,13 @@
     <p:sldId id="257" r:id="rId8"/>
     <p:sldId id="258" r:id="rId9"/>
     <p:sldId id="259" r:id="rId10"/>
+    <p:sldId id="260" r:id="rId11"/>
+    <p:sldId id="261" r:id="rId12"/>
+    <p:sldId id="262" r:id="rId13"/>
+    <p:sldId id="263" r:id="rId14"/>
+    <p:sldId id="264" r:id="rId15"/>
+    <p:sldId id="265" r:id="rId16"/>
+    <p:sldId id="266" r:id="rId17"/>
   </p:sldIdLst>
   <p:sldSz cx="12188952" cy="6858000" type="screen4x3"/>
   <p:notesSz cx="6858000" cy="9144000"/>
@@ -3099,8 +3106,8 @@
         </p:nvSpPr>
         <p:spPr>
           <a:xfrm>
-            <a:off x="731520" y="2011680"/>
-            <a:ext cx="10972800" cy="1097280"/>
+            <a:off x="731520" y="2377440"/>
+            <a:ext cx="10698480" cy="1097280"/>
           </a:xfrm>
           <a:prstGeom prst="rect">
             <a:avLst/>
@@ -3108,20 +3115,19 @@
           <a:noFill/>
         </p:spPr>
         <p:txBody>
-          <a:bodyPr wrap="square">
+          <a:bodyPr wrap="none">
             <a:spAutoFit/>
           </a:bodyPr>
           <a:lstStyle/>
           <a:p>
-            <a:pPr algn="l"/>
-            <a:r>
-              <a:rPr sz="4000" b="1">
-                <a:solidFill>
-                  <a:srgbClr val="1A1A1A"/>
-                </a:solidFill>
-                <a:latin typeface="Helvetica Neue"/>
-              </a:rPr>
-              <a:t>Alberta opioid deaths around COVID-19</a:t>
+            <a:r>
+              <a:rPr sz="3600" b="1">
+                <a:solidFill>
+                  <a:srgbClr val="000000"/>
+                </a:solidFill>
+                <a:latin typeface="Calibri"/>
+              </a:rPr>
+              <a:t>Alberta Opioid Mortality Around the COVID-19 Onset</a:t>
             </a:r>
           </a:p>
         </p:txBody>
@@ -3134,8 +3140,8 @@
         </p:nvSpPr>
         <p:spPr>
           <a:xfrm>
-            <a:off x="731520" y="3108960"/>
-            <a:ext cx="10972800" cy="640080"/>
+            <a:off x="731520" y="3474720"/>
+            <a:ext cx="10698480" cy="457200"/>
           </a:xfrm>
           <a:prstGeom prst="rect">
             <a:avLst/>
@@ -3143,20 +3149,19 @@
           <a:noFill/>
         </p:spPr>
         <p:txBody>
-          <a:bodyPr wrap="square">
+          <a:bodyPr wrap="none">
             <a:spAutoFit/>
           </a:bodyPr>
           <a:lstStyle/>
           <a:p>
-            <a:pPr algn="l"/>
-            <a:r>
-              <a:rPr sz="2000" b="0">
+            <a:r>
+              <a:rPr sz="1800">
                 <a:solidFill>
                   <a:srgbClr val="555555"/>
                 </a:solidFill>
-                <a:latin typeface="Helvetica Neue"/>
-              </a:rPr>
-              <a:t>An interrupted time series with placebo and NB cross-checks</a:t>
+                <a:latin typeface="Calibri"/>
+              </a:rPr>
+              <a:t>An interrupted time series analysis using federal data</a:t>
             </a:r>
           </a:p>
         </p:txBody>
@@ -3169,8 +3174,8 @@
         </p:nvSpPr>
         <p:spPr>
           <a:xfrm>
-            <a:off x="731520" y="4206240"/>
-            <a:ext cx="10972800" cy="457200"/>
+            <a:off x="731520" y="4572000"/>
+            <a:ext cx="10698480" cy="1371600"/>
           </a:xfrm>
           <a:prstGeom prst="rect">
             <a:avLst/>
@@ -3178,20 +3183,52 @@
           <a:noFill/>
         </p:spPr>
         <p:txBody>
-          <a:bodyPr wrap="square">
+          <a:bodyPr wrap="none">
             <a:spAutoFit/>
           </a:bodyPr>
           <a:lstStyle/>
           <a:p>
-            <a:pPr algn="l"/>
-            <a:r>
-              <a:rPr sz="1400" b="0">
+            <a:r>
+              <a:rPr sz="1400">
+                <a:solidFill>
+                  <a:srgbClr val="000000"/>
+                </a:solidFill>
+                <a:latin typeface="Calibri"/>
+              </a:rPr>
+              <a:t>Adilbek Sultanov</a:t>
+            </a:r>
+          </a:p>
+          <a:p>
+            <a:r>
+              <a:rPr sz="1200">
                 <a:solidFill>
                   <a:srgbClr val="555555"/>
                 </a:solidFill>
-                <a:latin typeface="Helvetica Neue"/>
-              </a:rPr>
-              <a:t>Adilbek Sultanov  ·  personal learning project  ·  May 2026</a:t>
+                <a:latin typeface="Calibri"/>
+              </a:rPr>
+              <a:t>Independent project</a:t>
+            </a:r>
+          </a:p>
+          <a:p>
+            <a:r>
+              <a:rPr sz="1200">
+                <a:solidFill>
+                  <a:srgbClr val="555555"/>
+                </a:solidFill>
+                <a:latin typeface="Calibri"/>
+              </a:rPr>
+              <a:t>May 2026</a:t>
+            </a:r>
+          </a:p>
+          <a:p>
+            <a:r>
+              <a:rPr sz="1100">
+                <a:solidFill>
+                  <a:srgbClr val="555555"/>
+                </a:solidFill>
+                <a:latin typeface="Calibri"/>
+              </a:rPr>
+              <a:t>github.com/Adilbek123/alberta-substance-use-trends</a:t>
             </a:r>
           </a:p>
         </p:txBody>
@@ -3204,8 +3241,8 @@
         </p:nvSpPr>
         <p:spPr>
           <a:xfrm>
-            <a:off x="731520" y="4846320"/>
-            <a:ext cx="10972800" cy="457200"/>
+            <a:off x="11521440" y="6446520"/>
+            <a:ext cx="548640" cy="274320"/>
           </a:xfrm>
           <a:prstGeom prst="rect">
             <a:avLst/>
@@ -3213,34 +3250,52 @@
           <a:noFill/>
         </p:spPr>
         <p:txBody>
-          <a:bodyPr wrap="square">
+          <a:bodyPr wrap="none">
             <a:spAutoFit/>
           </a:bodyPr>
           <a:lstStyle/>
           <a:p>
-            <a:pPr algn="l"/>
-            <a:r>
-              <a:rPr sz="1200" b="0">
-                <a:solidFill>
-                  <a:srgbClr val="1F6FB4"/>
-                </a:solidFill>
-                <a:latin typeface="Helvetica Neue"/>
-              </a:rPr>
-              <a:t>github.com/Adilbek123/alberta-substance-use-trends</a:t>
-            </a:r>
-          </a:p>
-        </p:txBody>
-      </p:sp>
-      <p:sp>
-        <p:nvSpPr>
-          <p:cNvPr id="6" name="TextBox 5"/>
+            <a:pPr algn="r"/>
+            <a:r>
+              <a:rPr sz="1000">
+                <a:solidFill>
+                  <a:srgbClr val="999999"/>
+                </a:solidFill>
+                <a:latin typeface="Calibri"/>
+              </a:rPr>
+              <a:t>1</a:t>
+            </a:r>
+          </a:p>
+        </p:txBody>
+      </p:sp>
+    </p:spTree>
+  </p:cSld>
+  <p:clrMapOvr>
+    <a:masterClrMapping/>
+  </p:clrMapOvr>
+</p:sld>
+</file>
+
+<file path=ppt/slides/slide10.xml><?xml version="1.0" encoding="utf-8"?>
+<p:sld xmlns:a="http://schemas.openxmlformats.org/drawingml/2006/main" xmlns:p="http://schemas.openxmlformats.org/presentationml/2006/main" xmlns:r="http://schemas.openxmlformats.org/officeDocument/2006/relationships">
+  <p:cSld>
+    <p:spTree>
+      <p:nvGrpSpPr>
+        <p:cNvPr id="1" name=""/>
+        <p:cNvGrpSpPr/>
+        <p:nvPr/>
+      </p:nvGrpSpPr>
+      <p:grpSpPr/>
+      <p:sp>
+        <p:nvSpPr>
+          <p:cNvPr id="2" name="TextBox 1"/>
           <p:cNvSpPr txBox="1"/>
           <p:nvPr/>
         </p:nvSpPr>
         <p:spPr>
           <a:xfrm>
-            <a:off x="365760" y="6492240"/>
-            <a:ext cx="3657600" cy="274320"/>
+            <a:off x="548640" y="320040"/>
+            <a:ext cx="11064240" cy="640080"/>
           </a:xfrm>
           <a:prstGeom prst="rect">
             <a:avLst/>
@@ -3248,34 +3303,68 @@
           <a:noFill/>
         </p:spPr>
         <p:txBody>
-          <a:bodyPr wrap="square">
+          <a:bodyPr wrap="none">
             <a:spAutoFit/>
           </a:bodyPr>
           <a:lstStyle/>
           <a:p>
-            <a:pPr algn="l"/>
-            <a:r>
-              <a:rPr sz="900" b="0">
-                <a:solidFill>
-                  <a:srgbClr val="888888"/>
-                </a:solidFill>
-                <a:latin typeface="Helvetica Neue"/>
-              </a:rPr>
-              <a:t>Alberta opioid mortality and COVID-19  |  personal learning project</a:t>
-            </a:r>
-          </a:p>
-        </p:txBody>
-      </p:sp>
-      <p:sp>
-        <p:nvSpPr>
-          <p:cNvPr id="7" name="TextBox 6"/>
+            <a:r>
+              <a:rPr sz="2600" b="1">
+                <a:solidFill>
+                  <a:srgbClr val="000000"/>
+                </a:solidFill>
+                <a:latin typeface="Calibri"/>
+              </a:rPr>
+              <a:t>Next Steps</a:t>
+            </a:r>
+          </a:p>
+        </p:txBody>
+      </p:sp>
+      <p:cxnSp>
+        <p:nvCxnSpPr>
+          <p:cNvPr id="3" name="Connector 2"/>
+          <p:cNvCxnSpPr/>
+          <p:nvPr/>
+        </p:nvCxnSpPr>
+        <p:spPr>
+          <a:xfrm>
+            <a:off x="548640" y="960120"/>
+            <a:ext cx="11064240" cy="0"/>
+          </a:xfrm>
+          <a:prstGeom prst="line">
+            <a:avLst/>
+          </a:prstGeom>
+          <a:ln w="9525">
+            <a:solidFill>
+              <a:srgbClr val="000000"/>
+            </a:solidFill>
+          </a:ln>
+        </p:spPr>
+        <p:style>
+          <a:lnRef idx="2">
+            <a:schemeClr val="accent1"/>
+          </a:lnRef>
+          <a:fillRef idx="0">
+            <a:schemeClr val="accent1"/>
+          </a:fillRef>
+          <a:effectRef idx="1">
+            <a:schemeClr val="accent1"/>
+          </a:effectRef>
+          <a:fontRef idx="minor">
+            <a:schemeClr val="tx1"/>
+          </a:fontRef>
+        </p:style>
+      </p:cxnSp>
+      <p:sp>
+        <p:nvSpPr>
+          <p:cNvPr id="4" name="TextBox 3"/>
           <p:cNvSpPr txBox="1"/>
           <p:nvPr/>
         </p:nvSpPr>
         <p:spPr>
           <a:xfrm>
-            <a:off x="11612880" y="6492240"/>
-            <a:ext cx="457200" cy="274320"/>
+            <a:off x="640080" y="1371600"/>
+            <a:ext cx="10972800" cy="4572000"/>
           </a:xfrm>
           <a:prstGeom prst="rect">
             <a:avLst/>
@@ -3288,15 +3377,291 @@
           </a:bodyPr>
           <a:lstStyle/>
           <a:p>
+            <a:pPr/>
+            <a:r>
+              <a:rPr sz="1600">
+                <a:solidFill>
+                  <a:srgbClr val="1A1A1A"/>
+                </a:solidFill>
+                <a:latin typeface="Calibri"/>
+              </a:rPr>
+              <a:t>•  Mechanism decomposition</a:t>
+            </a:r>
+          </a:p>
+          <a:p>
+            <a:pPr lvl="1"/>
+            <a:r>
+              <a:rPr sz="1300">
+                <a:solidFill>
+                  <a:srgbClr val="555555"/>
+                </a:solidFill>
+                <a:latin typeface="Calibri"/>
+              </a:rPr>
+              <a:t>–  Bring in supply-side data, service-capacity data, and outcome data to estimate the share of the jump attributable to each channel</a:t>
+            </a:r>
+          </a:p>
+          <a:p>
+            <a:pPr/>
+            <a:r>
+              <a:rPr sz="1600">
+                <a:solidFill>
+                  <a:srgbClr val="1A1A1A"/>
+                </a:solidFill>
+                <a:latin typeface="Calibri"/>
+              </a:rPr>
+              <a:t>•  Heterogeneity</a:t>
+            </a:r>
+          </a:p>
+          <a:p>
+            <a:pPr lvl="1"/>
+            <a:r>
+              <a:rPr sz="1300">
+                <a:solidFill>
+                  <a:srgbClr val="555555"/>
+                </a:solidFill>
+                <a:latin typeface="Calibri"/>
+              </a:rPr>
+              <a:t>–  Break the result down by age, sex, geographic zone, and substance type (fentanyl, carfentanil, other)</a:t>
+            </a:r>
+          </a:p>
+          <a:p>
+            <a:pPr/>
+            <a:r>
+              <a:rPr sz="1600">
+                <a:solidFill>
+                  <a:srgbClr val="1A1A1A"/>
+                </a:solidFill>
+                <a:latin typeface="Calibri"/>
+              </a:rPr>
+              <a:t>•  Post-period dynamics</a:t>
+            </a:r>
+          </a:p>
+          <a:p>
+            <a:pPr lvl="1"/>
+            <a:r>
+              <a:rPr sz="1300">
+                <a:solidFill>
+                  <a:srgbClr val="555555"/>
+                </a:solidFill>
+                <a:latin typeface="Calibri"/>
+              </a:rPr>
+              <a:t>–  Model the rise-to-peak-and-decline shape directly, rather than collapsing it into a single level shift</a:t>
+            </a:r>
+          </a:p>
+          <a:p>
+            <a:pPr/>
+            <a:r>
+              <a:rPr sz="1600">
+                <a:solidFill>
+                  <a:srgbClr val="1A1A1A"/>
+                </a:solidFill>
+                <a:latin typeface="Calibri"/>
+              </a:rPr>
+              <a:t>•  Cumulative excess deaths</a:t>
+            </a:r>
+          </a:p>
+          <a:p>
+            <a:pPr lvl="1"/>
+            <a:r>
+              <a:rPr sz="1300">
+                <a:solidFill>
+                  <a:srgbClr val="555555"/>
+                </a:solidFill>
+                <a:latin typeface="Calibri"/>
+              </a:rPr>
+              <a:t>–  Report a policy-relevant total alongside the immediate level shift</a:t>
+            </a:r>
+          </a:p>
+        </p:txBody>
+      </p:sp>
+      <p:sp>
+        <p:nvSpPr>
+          <p:cNvPr id="5" name="TextBox 4"/>
+          <p:cNvSpPr txBox="1"/>
+          <p:nvPr/>
+        </p:nvSpPr>
+        <p:spPr>
+          <a:xfrm>
+            <a:off x="548640" y="6446520"/>
+            <a:ext cx="10058400" cy="274320"/>
+          </a:xfrm>
+          <a:prstGeom prst="rect">
+            <a:avLst/>
+          </a:prstGeom>
+          <a:noFill/>
+        </p:spPr>
+        <p:txBody>
+          <a:bodyPr wrap="none">
+            <a:spAutoFit/>
+          </a:bodyPr>
+          <a:lstStyle/>
+          <a:p>
+            <a:r>
+              <a:rPr sz="900">
+                <a:solidFill>
+                  <a:srgbClr val="999999"/>
+                </a:solidFill>
+                <a:latin typeface="Calibri"/>
+              </a:rPr>
+              <a:t>Alberta opioid mortality around COVID-19  |  independent project</a:t>
+            </a:r>
+          </a:p>
+        </p:txBody>
+      </p:sp>
+      <p:sp>
+        <p:nvSpPr>
+          <p:cNvPr id="6" name="TextBox 5"/>
+          <p:cNvSpPr txBox="1"/>
+          <p:nvPr/>
+        </p:nvSpPr>
+        <p:spPr>
+          <a:xfrm>
+            <a:off x="11521440" y="6446520"/>
+            <a:ext cx="548640" cy="274320"/>
+          </a:xfrm>
+          <a:prstGeom prst="rect">
+            <a:avLst/>
+          </a:prstGeom>
+          <a:noFill/>
+        </p:spPr>
+        <p:txBody>
+          <a:bodyPr wrap="none">
+            <a:spAutoFit/>
+          </a:bodyPr>
+          <a:lstStyle/>
+          <a:p>
             <a:pPr algn="r"/>
             <a:r>
-              <a:rPr sz="900" b="0">
-                <a:solidFill>
-                  <a:srgbClr val="888888"/>
-                </a:solidFill>
-                <a:latin typeface="Helvetica Neue"/>
-              </a:rPr>
-              <a:t>1 / 4</a:t>
+              <a:rPr sz="1000">
+                <a:solidFill>
+                  <a:srgbClr val="999999"/>
+                </a:solidFill>
+                <a:latin typeface="Calibri"/>
+              </a:rPr>
+              <a:t>10</a:t>
+            </a:r>
+          </a:p>
+        </p:txBody>
+      </p:sp>
+    </p:spTree>
+  </p:cSld>
+  <p:clrMapOvr>
+    <a:masterClrMapping/>
+  </p:clrMapOvr>
+</p:sld>
+</file>
+
+<file path=ppt/slides/slide11.xml><?xml version="1.0" encoding="utf-8"?>
+<p:sld xmlns:a="http://schemas.openxmlformats.org/drawingml/2006/main" xmlns:p="http://schemas.openxmlformats.org/presentationml/2006/main" xmlns:r="http://schemas.openxmlformats.org/officeDocument/2006/relationships">
+  <p:cSld>
+    <p:spTree>
+      <p:nvGrpSpPr>
+        <p:cNvPr id="1" name=""/>
+        <p:cNvGrpSpPr/>
+        <p:nvPr/>
+      </p:nvGrpSpPr>
+      <p:grpSpPr/>
+      <p:sp>
+        <p:nvSpPr>
+          <p:cNvPr id="2" name="TextBox 1"/>
+          <p:cNvSpPr txBox="1"/>
+          <p:nvPr/>
+        </p:nvSpPr>
+        <p:spPr>
+          <a:xfrm>
+            <a:off x="548640" y="2926080"/>
+            <a:ext cx="11064240" cy="914400"/>
+          </a:xfrm>
+          <a:prstGeom prst="rect">
+            <a:avLst/>
+          </a:prstGeom>
+          <a:noFill/>
+        </p:spPr>
+        <p:txBody>
+          <a:bodyPr wrap="none">
+            <a:spAutoFit/>
+          </a:bodyPr>
+          <a:lstStyle/>
+          <a:p>
+            <a:pPr algn="ctr"/>
+            <a:r>
+              <a:rPr sz="5400" b="1">
+                <a:solidFill>
+                  <a:srgbClr val="000000"/>
+                </a:solidFill>
+                <a:latin typeface="Calibri"/>
+              </a:rPr>
+              <a:t>Questions?</a:t>
+            </a:r>
+          </a:p>
+        </p:txBody>
+      </p:sp>
+      <p:sp>
+        <p:nvSpPr>
+          <p:cNvPr id="3" name="TextBox 2"/>
+          <p:cNvSpPr txBox="1"/>
+          <p:nvPr/>
+        </p:nvSpPr>
+        <p:spPr>
+          <a:xfrm>
+            <a:off x="548640" y="4114800"/>
+            <a:ext cx="11064240" cy="457200"/>
+          </a:xfrm>
+          <a:prstGeom prst="rect">
+            <a:avLst/>
+          </a:prstGeom>
+          <a:noFill/>
+        </p:spPr>
+        <p:txBody>
+          <a:bodyPr wrap="none">
+            <a:spAutoFit/>
+          </a:bodyPr>
+          <a:lstStyle/>
+          <a:p>
+            <a:pPr algn="ctr"/>
+            <a:r>
+              <a:rPr sz="1400">
+                <a:solidFill>
+                  <a:srgbClr val="555555"/>
+                </a:solidFill>
+                <a:latin typeface="Calibri"/>
+              </a:rPr>
+              <a:t>Code, data, and full documentation: github.com/Adilbek123/alberta-substance-use-trends</a:t>
+            </a:r>
+          </a:p>
+        </p:txBody>
+      </p:sp>
+      <p:sp>
+        <p:nvSpPr>
+          <p:cNvPr id="4" name="TextBox 3"/>
+          <p:cNvSpPr txBox="1"/>
+          <p:nvPr/>
+        </p:nvSpPr>
+        <p:spPr>
+          <a:xfrm>
+            <a:off x="11521440" y="6446520"/>
+            <a:ext cx="548640" cy="274320"/>
+          </a:xfrm>
+          <a:prstGeom prst="rect">
+            <a:avLst/>
+          </a:prstGeom>
+          <a:noFill/>
+        </p:spPr>
+        <p:txBody>
+          <a:bodyPr wrap="none">
+            <a:spAutoFit/>
+          </a:bodyPr>
+          <a:lstStyle/>
+          <a:p>
+            <a:pPr algn="r"/>
+            <a:r>
+              <a:rPr sz="1000">
+                <a:solidFill>
+                  <a:srgbClr val="999999"/>
+                </a:solidFill>
+                <a:latin typeface="Calibri"/>
+              </a:rPr>
+              <a:t>11</a:t>
             </a:r>
           </a:p>
         </p:txBody>
@@ -3327,8 +3692,8 @@
         </p:nvSpPr>
         <p:spPr>
           <a:xfrm>
-            <a:off x="548640" y="365760"/>
-            <a:ext cx="10972800" cy="548640"/>
+            <a:off x="548640" y="320040"/>
+            <a:ext cx="11064240" cy="640080"/>
           </a:xfrm>
           <a:prstGeom prst="rect">
             <a:avLst/>
@@ -3336,34 +3701,68 @@
           <a:noFill/>
         </p:spPr>
         <p:txBody>
-          <a:bodyPr wrap="square">
+          <a:bodyPr wrap="none">
             <a:spAutoFit/>
           </a:bodyPr>
           <a:lstStyle/>
           <a:p>
-            <a:pPr algn="l"/>
             <a:r>
               <a:rPr sz="2600" b="1">
                 <a:solidFill>
-                  <a:srgbClr val="1A1A1A"/>
-                </a:solidFill>
-                <a:latin typeface="Helvetica Neue"/>
-              </a:rPr>
-              <a:t>What I asked, and how I tried to answer it</a:t>
-            </a:r>
-          </a:p>
-        </p:txBody>
-      </p:sp>
-      <p:sp>
-        <p:nvSpPr>
-          <p:cNvPr id="3" name="TextBox 2"/>
+                  <a:srgbClr val="000000"/>
+                </a:solidFill>
+                <a:latin typeface="Calibri"/>
+              </a:rPr>
+              <a:t>Question to be Answered</a:t>
+            </a:r>
+          </a:p>
+        </p:txBody>
+      </p:sp>
+      <p:cxnSp>
+        <p:nvCxnSpPr>
+          <p:cNvPr id="3" name="Connector 2"/>
+          <p:cNvCxnSpPr/>
+          <p:nvPr/>
+        </p:nvCxnSpPr>
+        <p:spPr>
+          <a:xfrm>
+            <a:off x="548640" y="960120"/>
+            <a:ext cx="11064240" cy="0"/>
+          </a:xfrm>
+          <a:prstGeom prst="line">
+            <a:avLst/>
+          </a:prstGeom>
+          <a:ln w="9525">
+            <a:solidFill>
+              <a:srgbClr val="000000"/>
+            </a:solidFill>
+          </a:ln>
+        </p:spPr>
+        <p:style>
+          <a:lnRef idx="2">
+            <a:schemeClr val="accent1"/>
+          </a:lnRef>
+          <a:fillRef idx="0">
+            <a:schemeClr val="accent1"/>
+          </a:fillRef>
+          <a:effectRef idx="1">
+            <a:schemeClr val="accent1"/>
+          </a:effectRef>
+          <a:fontRef idx="minor">
+            <a:schemeClr val="tx1"/>
+          </a:fontRef>
+        </p:style>
+      </p:cxnSp>
+      <p:sp>
+        <p:nvSpPr>
+          <p:cNvPr id="4" name="TextBox 3"/>
           <p:cNvSpPr txBox="1"/>
           <p:nvPr/>
         </p:nvSpPr>
         <p:spPr>
           <a:xfrm>
-            <a:off x="548640" y="1280160"/>
-            <a:ext cx="10972800" cy="365760"/>
+            <a:off x="640080" y="1371600"/>
+            <a:ext cx="10972800" cy="4572000"/>
           </a:xfrm>
           <a:prstGeom prst="rect">
             <a:avLst/>
@@ -3376,40 +3775,89 @@
           </a:bodyPr>
           <a:lstStyle/>
           <a:p>
-            <a:pPr algn="l"/>
-            <a:r>
-              <a:rPr sz="1500" b="1">
-                <a:solidFill>
-                  <a:srgbClr val="1F6FB4"/>
-                </a:solidFill>
-                <a:latin typeface="Helvetica Neue"/>
-              </a:rPr>
-              <a:t>Question</a:t>
-            </a:r>
-          </a:p>
-          <a:p>
-            <a:r>
-              <a:rPr sz="1400" b="0">
+            <a:pPr/>
+            <a:r>
+              <a:rPr sz="1700">
                 <a:solidFill>
                   <a:srgbClr val="1A1A1A"/>
                 </a:solidFill>
-                <a:latin typeface="Helvetica Neue"/>
-              </a:rPr>
-              <a:t>Did Alberta's opioid death rate shift at a level higher than the pre-COVID trend can explain, starting from 2020 Q2 (first full quarter under the public health emergency)?</a:t>
-            </a:r>
-          </a:p>
-        </p:txBody>
-      </p:sp>
-      <p:sp>
-        <p:nvSpPr>
-          <p:cNvPr id="4" name="TextBox 3"/>
+                <a:latin typeface="Calibri"/>
+              </a:rPr>
+              <a:t>•  Did Alberta's opioid death rate shift sharply when COVID-19 hit, beyond what the prior trend explains?</a:t>
+            </a:r>
+          </a:p>
+          <a:p>
+            <a:pPr lvl="1"/>
+            <a:r>
+              <a:rPr sz="1300">
+                <a:solidFill>
+                  <a:srgbClr val="555555"/>
+                </a:solidFill>
+                <a:latin typeface="Calibri"/>
+              </a:rPr>
+              <a:t>–  Cutoff used: 2020 Q2, the first full quarter under Alberta's public health emergency</a:t>
+            </a:r>
+          </a:p>
+          <a:p>
+            <a:pPr lvl="1"/>
+            <a:r>
+              <a:rPr sz="1300">
+                <a:solidFill>
+                  <a:srgbClr val="555555"/>
+                </a:solidFill>
+                <a:latin typeface="Calibri"/>
+              </a:rPr>
+              <a:t>–  Outcome: opioid-related deaths per 100,000 Alberta residents per quarter</a:t>
+            </a:r>
+          </a:p>
+          <a:p>
+            <a:pPr/>
+            <a:r>
+              <a:rPr sz="1700">
+                <a:solidFill>
+                  <a:srgbClr val="1A1A1A"/>
+                </a:solidFill>
+                <a:latin typeface="Calibri"/>
+              </a:rPr>
+              <a:t>•  Why this matters for Mental Health and Addiction work</a:t>
+            </a:r>
+          </a:p>
+          <a:p>
+            <a:pPr lvl="1"/>
+            <a:r>
+              <a:rPr sz="1300">
+                <a:solidFill>
+                  <a:srgbClr val="555555"/>
+                </a:solidFill>
+                <a:latin typeface="Calibri"/>
+              </a:rPr>
+              <a:t>–  The post-COVID baseline shapes what we measure as 'success' under the Alberta Recovery Model</a:t>
+            </a:r>
+          </a:p>
+          <a:p>
+            <a:pPr lvl="1"/>
+            <a:r>
+              <a:rPr sz="1300">
+                <a:solidFill>
+                  <a:srgbClr val="555555"/>
+                </a:solidFill>
+                <a:latin typeface="Calibri"/>
+              </a:rPr>
+              <a:t>–  Understanding the size of the shift is a prerequisite for any decomposition or follow-up policy work</a:t>
+            </a:r>
+          </a:p>
+        </p:txBody>
+      </p:sp>
+      <p:sp>
+        <p:nvSpPr>
+          <p:cNvPr id="5" name="TextBox 4"/>
           <p:cNvSpPr txBox="1"/>
           <p:nvPr/>
         </p:nvSpPr>
         <p:spPr>
           <a:xfrm>
-            <a:off x="548640" y="2743200"/>
-            <a:ext cx="10972800" cy="365760"/>
+            <a:off x="548640" y="6446520"/>
+            <a:ext cx="10058400" cy="274320"/>
           </a:xfrm>
           <a:prstGeom prst="rect">
             <a:avLst/>
@@ -3417,45 +3865,33 @@
           <a:noFill/>
         </p:spPr>
         <p:txBody>
-          <a:bodyPr wrap="square">
+          <a:bodyPr wrap="none">
             <a:spAutoFit/>
           </a:bodyPr>
           <a:lstStyle/>
           <a:p>
-            <a:pPr algn="l"/>
-            <a:r>
-              <a:rPr sz="1500" b="1">
-                <a:solidFill>
-                  <a:srgbClr val="1F6FB4"/>
-                </a:solidFill>
-                <a:latin typeface="Helvetica Neue"/>
-              </a:rPr>
-              <a:t>Data</a:t>
-            </a:r>
-          </a:p>
-          <a:p>
-            <a:r>
-              <a:rPr sz="1400" b="0">
-                <a:solidFill>
-                  <a:srgbClr val="1A1A1A"/>
-                </a:solidFill>
-                <a:latin typeface="Helvetica Neue"/>
-              </a:rPr>
-              <a:t>PHAC Health Infobase substance-related harms data + StatCan Table 17-10-0009-01. 39 quarters of Alberta opioid deaths, 2016 Q1 to 2025 Q3, normalised to deaths per 100k residents.</a:t>
-            </a:r>
-          </a:p>
-        </p:txBody>
-      </p:sp>
-      <p:sp>
-        <p:nvSpPr>
-          <p:cNvPr id="5" name="TextBox 4"/>
+            <a:r>
+              <a:rPr sz="900">
+                <a:solidFill>
+                  <a:srgbClr val="999999"/>
+                </a:solidFill>
+                <a:latin typeface="Calibri"/>
+              </a:rPr>
+              <a:t>Alberta opioid mortality around COVID-19  |  independent project</a:t>
+            </a:r>
+          </a:p>
+        </p:txBody>
+      </p:sp>
+      <p:sp>
+        <p:nvSpPr>
+          <p:cNvPr id="6" name="TextBox 5"/>
           <p:cNvSpPr txBox="1"/>
           <p:nvPr/>
         </p:nvSpPr>
         <p:spPr>
           <a:xfrm>
-            <a:off x="548640" y="4206240"/>
-            <a:ext cx="10972800" cy="365760"/>
+            <a:off x="11521440" y="6446520"/>
+            <a:ext cx="548640" cy="274320"/>
           </a:xfrm>
           <a:prstGeom prst="rect">
             <a:avLst/>
@@ -3463,112 +3899,20 @@
           <a:noFill/>
         </p:spPr>
         <p:txBody>
-          <a:bodyPr wrap="square">
+          <a:bodyPr wrap="none">
             <a:spAutoFit/>
           </a:bodyPr>
           <a:lstStyle/>
           <a:p>
-            <a:pPr algn="l"/>
-            <a:r>
-              <a:rPr sz="1500" b="1">
-                <a:solidFill>
-                  <a:srgbClr val="1F6FB4"/>
-                </a:solidFill>
-                <a:latin typeface="Helvetica Neue"/>
-              </a:rPr>
-              <a:t>Method</a:t>
-            </a:r>
-          </a:p>
-          <a:p>
-            <a:r>
-              <a:rPr sz="1400" b="0">
-                <a:solidFill>
-                  <a:srgbClr val="1A1A1A"/>
-                </a:solidFill>
-                <a:latin typeface="Helvetica Neue"/>
-              </a:rPr>
-              <a:t>Interrupted time series with a level and slope change around 2020 Q2. Quarter fixed effects for seasonality. Newey-West HAC SE with small-sample correction.</a:t>
-            </a:r>
-          </a:p>
-          <a:p>
-            <a:r>
-              <a:rPr sz="1400" b="0">
-                <a:solidFill>
-                  <a:srgbClr val="1A1A1A"/>
-                </a:solidFill>
-                <a:latin typeface="Helvetica Neue"/>
-              </a:rPr>
-              <a:t>Robustness: HAC lag sensitivity, donut (drop 2020 Q1), seven placebo cutoffs in the pre-period, negative binomial cross-check with log-population offset.</a:t>
-            </a:r>
-          </a:p>
-        </p:txBody>
-      </p:sp>
-      <p:sp>
-        <p:nvSpPr>
-          <p:cNvPr id="6" name="TextBox 5"/>
-          <p:cNvSpPr txBox="1"/>
-          <p:nvPr/>
-        </p:nvSpPr>
-        <p:spPr>
-          <a:xfrm>
-            <a:off x="365760" y="6492240"/>
-            <a:ext cx="3657600" cy="274320"/>
-          </a:xfrm>
-          <a:prstGeom prst="rect">
-            <a:avLst/>
-          </a:prstGeom>
-          <a:noFill/>
-        </p:spPr>
-        <p:txBody>
-          <a:bodyPr wrap="square">
-            <a:spAutoFit/>
-          </a:bodyPr>
-          <a:lstStyle/>
-          <a:p>
-            <a:pPr algn="l"/>
-            <a:r>
-              <a:rPr sz="900" b="0">
-                <a:solidFill>
-                  <a:srgbClr val="888888"/>
-                </a:solidFill>
-                <a:latin typeface="Helvetica Neue"/>
-              </a:rPr>
-              <a:t>Alberta opioid mortality and COVID-19  |  personal learning project</a:t>
-            </a:r>
-          </a:p>
-        </p:txBody>
-      </p:sp>
-      <p:sp>
-        <p:nvSpPr>
-          <p:cNvPr id="7" name="TextBox 6"/>
-          <p:cNvSpPr txBox="1"/>
-          <p:nvPr/>
-        </p:nvSpPr>
-        <p:spPr>
-          <a:xfrm>
-            <a:off x="11612880" y="6492240"/>
-            <a:ext cx="457200" cy="274320"/>
-          </a:xfrm>
-          <a:prstGeom prst="rect">
-            <a:avLst/>
-          </a:prstGeom>
-          <a:noFill/>
-        </p:spPr>
-        <p:txBody>
-          <a:bodyPr wrap="square">
-            <a:spAutoFit/>
-          </a:bodyPr>
-          <a:lstStyle/>
-          <a:p>
             <a:pPr algn="r"/>
             <a:r>
-              <a:rPr sz="900" b="0">
-                <a:solidFill>
-                  <a:srgbClr val="888888"/>
-                </a:solidFill>
-                <a:latin typeface="Helvetica Neue"/>
-              </a:rPr>
-              <a:t>2 / 4</a:t>
+              <a:rPr sz="1000">
+                <a:solidFill>
+                  <a:srgbClr val="999999"/>
+                </a:solidFill>
+                <a:latin typeface="Calibri"/>
+              </a:rPr>
+              <a:t>2</a:t>
             </a:r>
           </a:p>
         </p:txBody>
@@ -3599,8 +3943,8 @@
         </p:nvSpPr>
         <p:spPr>
           <a:xfrm>
-            <a:off x="548640" y="365760"/>
-            <a:ext cx="10972800" cy="548640"/>
+            <a:off x="548640" y="320040"/>
+            <a:ext cx="11064240" cy="640080"/>
           </a:xfrm>
           <a:prstGeom prst="rect">
             <a:avLst/>
@@ -3608,48 +3952,58 @@
           <a:noFill/>
         </p:spPr>
         <p:txBody>
-          <a:bodyPr wrap="square">
+          <a:bodyPr wrap="none">
             <a:spAutoFit/>
           </a:bodyPr>
           <a:lstStyle/>
           <a:p>
-            <a:pPr algn="l"/>
             <a:r>
               <a:rPr sz="2600" b="1">
                 <a:solidFill>
-                  <a:srgbClr val="1A1A1A"/>
-                </a:solidFill>
-                <a:latin typeface="Helvetica Neue"/>
-              </a:rPr>
-              <a:t>Sharp, large, robust break at 2020 Q2</a:t>
-            </a:r>
-          </a:p>
-        </p:txBody>
-      </p:sp>
-      <p:pic>
-        <p:nvPicPr>
-          <p:cNvPr id="3" name="Picture 2" descr="rdit_opioid_deaths.png"/>
-          <p:cNvPicPr>
-            <a:picLocks noChangeAspect="1"/>
-          </p:cNvPicPr>
+                  <a:srgbClr val="000000"/>
+                </a:solidFill>
+                <a:latin typeface="Calibri"/>
+              </a:rPr>
+              <a:t>Background and Context</a:t>
+            </a:r>
+          </a:p>
+        </p:txBody>
+      </p:sp>
+      <p:cxnSp>
+        <p:nvCxnSpPr>
+          <p:cNvPr id="3" name="Connector 2"/>
+          <p:cNvCxnSpPr/>
           <p:nvPr/>
-        </p:nvPicPr>
-        <p:blipFill>
-          <a:blip r:embed="rId2"/>
-          <a:stretch>
-            <a:fillRect/>
-          </a:stretch>
-        </p:blipFill>
-        <p:spPr>
-          <a:xfrm>
-            <a:off x="457200" y="1188720"/>
-            <a:ext cx="7498079" cy="4538778"/>
-          </a:xfrm>
-          <a:prstGeom prst="rect">
+        </p:nvCxnSpPr>
+        <p:spPr>
+          <a:xfrm>
+            <a:off x="548640" y="960120"/>
+            <a:ext cx="11064240" cy="0"/>
+          </a:xfrm>
+          <a:prstGeom prst="line">
             <a:avLst/>
           </a:prstGeom>
-        </p:spPr>
-      </p:pic>
+          <a:ln w="9525">
+            <a:solidFill>
+              <a:srgbClr val="000000"/>
+            </a:solidFill>
+          </a:ln>
+        </p:spPr>
+        <p:style>
+          <a:lnRef idx="2">
+            <a:schemeClr val="accent1"/>
+          </a:lnRef>
+          <a:fillRef idx="0">
+            <a:schemeClr val="accent1"/>
+          </a:fillRef>
+          <a:effectRef idx="1">
+            <a:schemeClr val="accent1"/>
+          </a:effectRef>
+          <a:fontRef idx="minor">
+            <a:schemeClr val="tx1"/>
+          </a:fontRef>
+        </p:style>
+      </p:cxnSp>
       <p:sp>
         <p:nvSpPr>
           <p:cNvPr id="4" name="TextBox 3"/>
@@ -3658,8 +4012,8 @@
         </p:nvSpPr>
         <p:spPr>
           <a:xfrm>
-            <a:off x="8138160" y="1280160"/>
-            <a:ext cx="3840480" cy="365760"/>
+            <a:off x="640080" y="1371600"/>
+            <a:ext cx="10972800" cy="4572000"/>
           </a:xfrm>
           <a:prstGeom prst="rect">
             <a:avLst/>
@@ -3672,59 +4026,87 @@
           </a:bodyPr>
           <a:lstStyle/>
           <a:p>
-            <a:pPr algn="l"/>
-            <a:r>
-              <a:rPr sz="1400" b="1">
-                <a:solidFill>
-                  <a:srgbClr val="1F6FB4"/>
-                </a:solidFill>
-                <a:latin typeface="Helvetica Neue"/>
-              </a:rPr>
-              <a:t>Main spec</a:t>
-            </a:r>
-          </a:p>
-          <a:p>
-            <a:r>
-              <a:rPr sz="1200" b="0">
+            <a:pPr/>
+            <a:r>
+              <a:rPr sz="1600">
+                <a:solidFill>
+                  <a:srgbClr val="1A1A1A"/>
+                </a:solidFill>
+                <a:latin typeface="Calibri"/>
+              </a:rPr>
+              <a:t>•  Alberta opioid mortality from 2016 to early 2020</a:t>
+            </a:r>
+          </a:p>
+          <a:p>
+            <a:pPr lvl="1"/>
+            <a:r>
+              <a:rPr sz="1300">
                 <a:solidFill>
                   <a:srgbClr val="555555"/>
                 </a:solidFill>
-                <a:latin typeface="Helvetica Neue"/>
-              </a:rPr>
-              <a:t>Level shift at 2020 Q2:</a:t>
-            </a:r>
-          </a:p>
-          <a:p>
-            <a:r>
-              <a:rPr sz="1400" b="1">
+                <a:latin typeface="Calibri"/>
+              </a:rPr>
+              <a:t>–  Quarterly opioid death rate sat around 4 per 100,000</a:t>
+            </a:r>
+          </a:p>
+          <a:p>
+            <a:pPr lvl="1"/>
+            <a:r>
+              <a:rPr sz="1300">
+                <a:solidFill>
+                  <a:srgbClr val="555555"/>
+                </a:solidFill>
+                <a:latin typeface="Calibri"/>
+              </a:rPr>
+              <a:t>–  Flat trend over the five years prior to COVID — no sustained rise or fall</a:t>
+            </a:r>
+          </a:p>
+          <a:p>
+            <a:pPr/>
+            <a:r>
+              <a:rPr sz="1600">
                 <a:solidFill>
                   <a:srgbClr val="1A1A1A"/>
                 </a:solidFill>
-                <a:latin typeface="Helvetica Neue"/>
-              </a:rPr>
-              <a:t>+5.50 per 100k per quarter</a:t>
-            </a:r>
-          </a:p>
-          <a:p>
-            <a:r>
-              <a:rPr sz="1100" b="0">
+                <a:latin typeface="Calibri"/>
+              </a:rPr>
+              <a:t>•  March 2020: Alberta declares a public health emergency</a:t>
+            </a:r>
+          </a:p>
+          <a:p>
+            <a:pPr lvl="1"/>
+            <a:r>
+              <a:rPr sz="1300">
                 <a:solidFill>
                   <a:srgbClr val="555555"/>
                 </a:solidFill>
-                <a:latin typeface="Helvetica Neue"/>
-              </a:rPr>
-              <a:t>(95% CI +3.60, +7.39, p &lt; 0.001)</a:t>
-            </a:r>
-          </a:p>
-          <a:p>
-            <a:r>
-              <a:rPr sz="1100" b="0">
+                <a:latin typeface="Calibri"/>
+              </a:rPr>
+              <a:t>–  Many things changed at once — virus circulation, public health measures, harm reduction services, the unregulated drug supply, mental health services, social and economic conditions</a:t>
+            </a:r>
+          </a:p>
+          <a:p>
+            <a:pPr/>
+            <a:r>
+              <a:rPr sz="1600">
+                <a:solidFill>
+                  <a:srgbClr val="1A1A1A"/>
+                </a:solidFill>
+                <a:latin typeface="Calibri"/>
+              </a:rPr>
+              <a:t>•  Federal data shows opioid mortality rose sharply across Canada from 2020 onward</a:t>
+            </a:r>
+          </a:p>
+          <a:p>
+            <a:pPr lvl="1"/>
+            <a:r>
+              <a:rPr sz="1300">
                 <a:solidFill>
                   <a:srgbClr val="555555"/>
                 </a:solidFill>
-                <a:latin typeface="Helvetica Neue"/>
-              </a:rPr>
-              <a:t>At mean AB pop: ~+246 deaths/quarter</a:t>
+                <a:latin typeface="Calibri"/>
+              </a:rPr>
+              <a:t>–  This analysis quantifies the Alberta-specific change at the cutoff</a:t>
             </a:r>
           </a:p>
         </p:txBody>
@@ -3737,8 +4119,8 @@
         </p:nvSpPr>
         <p:spPr>
           <a:xfrm>
-            <a:off x="8138160" y="3108960"/>
-            <a:ext cx="3840480" cy="365760"/>
+            <a:off x="548640" y="6446520"/>
+            <a:ext cx="10058400" cy="274320"/>
           </a:xfrm>
           <a:prstGeom prst="rect">
             <a:avLst/>
@@ -3746,53 +4128,19 @@
           <a:noFill/>
         </p:spPr>
         <p:txBody>
-          <a:bodyPr wrap="square">
+          <a:bodyPr wrap="none">
             <a:spAutoFit/>
           </a:bodyPr>
           <a:lstStyle/>
           <a:p>
-            <a:pPr algn="l"/>
-            <a:r>
-              <a:rPr sz="1400" b="1">
-                <a:solidFill>
-                  <a:srgbClr val="1F6FB4"/>
-                </a:solidFill>
-                <a:latin typeface="Helvetica Neue"/>
-              </a:rPr>
-              <a:t>Robustness</a:t>
-            </a:r>
-          </a:p>
-          <a:p>
-            <a:r>
-              <a:rPr sz="1100" b="0">
-                <a:solidFill>
-                  <a:srgbClr val="1A1A1A"/>
-                </a:solidFill>
-                <a:latin typeface="Helvetica Neue"/>
-              </a:rPr>
-              <a:t>HAC L=1..6:  +5.50 (SE 0.79–0.98)</a:t>
-            </a:r>
-          </a:p>
-          <a:p>
-            <a:r>
-              <a:rPr sz="1100" b="0">
-                <a:solidFill>
-                  <a:srgbClr val="1A1A1A"/>
-                </a:solidFill>
-                <a:latin typeface="Helvetica Neue"/>
-              </a:rPr>
-              <a:t>Donut (drop 2020 Q1):  +5.34</a:t>
-            </a:r>
-          </a:p>
-          <a:p>
-            <a:r>
-              <a:rPr sz="1100" b="0">
-                <a:solidFill>
-                  <a:srgbClr val="1A1A1A"/>
-                </a:solidFill>
-                <a:latin typeface="Helvetica Neue"/>
-              </a:rPr>
-              <a:t>NB rate ratio:  2.43 (1.80, 3.26)</a:t>
+            <a:r>
+              <a:rPr sz="900">
+                <a:solidFill>
+                  <a:srgbClr val="999999"/>
+                </a:solidFill>
+                <a:latin typeface="Calibri"/>
+              </a:rPr>
+              <a:t>Alberta opioid mortality around COVID-19  |  independent project</a:t>
             </a:r>
           </a:p>
         </p:txBody>
@@ -3805,8 +4153,8 @@
         </p:nvSpPr>
         <p:spPr>
           <a:xfrm>
-            <a:off x="8138160" y="4389120"/>
-            <a:ext cx="3840480" cy="365760"/>
+            <a:off x="11521440" y="6446520"/>
+            <a:ext cx="548640" cy="274320"/>
           </a:xfrm>
           <a:prstGeom prst="rect">
             <a:avLst/>
@@ -3814,134 +4162,20 @@
           <a:noFill/>
         </p:spPr>
         <p:txBody>
-          <a:bodyPr wrap="square">
+          <a:bodyPr wrap="none">
             <a:spAutoFit/>
           </a:bodyPr>
           <a:lstStyle/>
           <a:p>
-            <a:pPr algn="l"/>
-            <a:r>
-              <a:rPr sz="1400" b="1">
-                <a:solidFill>
-                  <a:srgbClr val="1F6FB4"/>
-                </a:solidFill>
-                <a:latin typeface="Helvetica Neue"/>
-              </a:rPr>
-              <a:t>Placebo cutoffs</a:t>
-            </a:r>
-          </a:p>
-          <a:p>
-            <a:r>
-              <a:rPr sz="1100" b="0">
-                <a:solidFill>
-                  <a:srgbClr val="555555"/>
-                </a:solidFill>
-                <a:latin typeface="Helvetica Neue"/>
-              </a:rPr>
-              <a:t>Seven fake cutoffs in pre-period:</a:t>
-            </a:r>
-          </a:p>
-          <a:p>
-            <a:r>
-              <a:rPr sz="1100" b="0">
-                <a:solidFill>
-                  <a:srgbClr val="1A1A1A"/>
-                </a:solidFill>
-                <a:latin typeface="Helvetica Neue"/>
-              </a:rPr>
-              <a:t>All point opposite direction.</a:t>
-            </a:r>
-          </a:p>
-          <a:p>
-            <a:r>
-              <a:rPr sz="1100" b="0">
-                <a:solidFill>
-                  <a:srgbClr val="1A1A1A"/>
-                </a:solidFill>
-                <a:latin typeface="Helvetica Neue"/>
-              </a:rPr>
-              <a:t>Largest |placebo|: 1.86</a:t>
-            </a:r>
-          </a:p>
-          <a:p>
-            <a:r>
-              <a:rPr sz="1100" b="0">
-                <a:solidFill>
-                  <a:srgbClr val="1A1A1A"/>
-                </a:solidFill>
-                <a:latin typeface="Helvetica Neue"/>
-              </a:rPr>
-              <a:t>Real jump (+5.50) is ~3× larger.</a:t>
-            </a:r>
-          </a:p>
-        </p:txBody>
-      </p:sp>
-      <p:sp>
-        <p:nvSpPr>
-          <p:cNvPr id="7" name="TextBox 6"/>
-          <p:cNvSpPr txBox="1"/>
-          <p:nvPr/>
-        </p:nvSpPr>
-        <p:spPr>
-          <a:xfrm>
-            <a:off x="365760" y="6492240"/>
-            <a:ext cx="3657600" cy="274320"/>
-          </a:xfrm>
-          <a:prstGeom prst="rect">
-            <a:avLst/>
-          </a:prstGeom>
-          <a:noFill/>
-        </p:spPr>
-        <p:txBody>
-          <a:bodyPr wrap="square">
-            <a:spAutoFit/>
-          </a:bodyPr>
-          <a:lstStyle/>
-          <a:p>
-            <a:pPr algn="l"/>
-            <a:r>
-              <a:rPr sz="900" b="0">
-                <a:solidFill>
-                  <a:srgbClr val="888888"/>
-                </a:solidFill>
-                <a:latin typeface="Helvetica Neue"/>
-              </a:rPr>
-              <a:t>Alberta opioid mortality and COVID-19  |  personal learning project</a:t>
-            </a:r>
-          </a:p>
-        </p:txBody>
-      </p:sp>
-      <p:sp>
-        <p:nvSpPr>
-          <p:cNvPr id="8" name="TextBox 7"/>
-          <p:cNvSpPr txBox="1"/>
-          <p:nvPr/>
-        </p:nvSpPr>
-        <p:spPr>
-          <a:xfrm>
-            <a:off x="11612880" y="6492240"/>
-            <a:ext cx="457200" cy="274320"/>
-          </a:xfrm>
-          <a:prstGeom prst="rect">
-            <a:avLst/>
-          </a:prstGeom>
-          <a:noFill/>
-        </p:spPr>
-        <p:txBody>
-          <a:bodyPr wrap="square">
-            <a:spAutoFit/>
-          </a:bodyPr>
-          <a:lstStyle/>
-          <a:p>
             <a:pPr algn="r"/>
             <a:r>
-              <a:rPr sz="900" b="0">
-                <a:solidFill>
-                  <a:srgbClr val="888888"/>
-                </a:solidFill>
-                <a:latin typeface="Helvetica Neue"/>
-              </a:rPr>
-              <a:t>3 / 4</a:t>
+              <a:rPr sz="1000">
+                <a:solidFill>
+                  <a:srgbClr val="999999"/>
+                </a:solidFill>
+                <a:latin typeface="Calibri"/>
+              </a:rPr>
+              <a:t>3</a:t>
             </a:r>
           </a:p>
         </p:txBody>
@@ -3972,8 +4206,8 @@
         </p:nvSpPr>
         <p:spPr>
           <a:xfrm>
-            <a:off x="548640" y="365760"/>
-            <a:ext cx="10972800" cy="548640"/>
+            <a:off x="548640" y="320040"/>
+            <a:ext cx="11064240" cy="640080"/>
           </a:xfrm>
           <a:prstGeom prst="rect">
             <a:avLst/>
@@ -3981,34 +4215,68 @@
           <a:noFill/>
         </p:spPr>
         <p:txBody>
-          <a:bodyPr wrap="square">
+          <a:bodyPr wrap="none">
             <a:spAutoFit/>
           </a:bodyPr>
           <a:lstStyle/>
           <a:p>
-            <a:pPr algn="l"/>
             <a:r>
               <a:rPr sz="2600" b="1">
                 <a:solidFill>
-                  <a:srgbClr val="1A1A1A"/>
-                </a:solidFill>
-                <a:latin typeface="Helvetica Neue"/>
-              </a:rPr>
-              <a:t>What this identifies — and what it doesn't</a:t>
-            </a:r>
-          </a:p>
-        </p:txBody>
-      </p:sp>
-      <p:sp>
-        <p:nvSpPr>
-          <p:cNvPr id="3" name="TextBox 2"/>
+                  <a:srgbClr val="000000"/>
+                </a:solidFill>
+                <a:latin typeface="Calibri"/>
+              </a:rPr>
+              <a:t>Approach</a:t>
+            </a:r>
+          </a:p>
+        </p:txBody>
+      </p:sp>
+      <p:cxnSp>
+        <p:nvCxnSpPr>
+          <p:cNvPr id="3" name="Connector 2"/>
+          <p:cNvCxnSpPr/>
+          <p:nvPr/>
+        </p:nvCxnSpPr>
+        <p:spPr>
+          <a:xfrm>
+            <a:off x="548640" y="960120"/>
+            <a:ext cx="11064240" cy="0"/>
+          </a:xfrm>
+          <a:prstGeom prst="line">
+            <a:avLst/>
+          </a:prstGeom>
+          <a:ln w="9525">
+            <a:solidFill>
+              <a:srgbClr val="000000"/>
+            </a:solidFill>
+          </a:ln>
+        </p:spPr>
+        <p:style>
+          <a:lnRef idx="2">
+            <a:schemeClr val="accent1"/>
+          </a:lnRef>
+          <a:fillRef idx="0">
+            <a:schemeClr val="accent1"/>
+          </a:fillRef>
+          <a:effectRef idx="1">
+            <a:schemeClr val="accent1"/>
+          </a:effectRef>
+          <a:fontRef idx="minor">
+            <a:schemeClr val="tx1"/>
+          </a:fontRef>
+        </p:style>
+      </p:cxnSp>
+      <p:sp>
+        <p:nvSpPr>
+          <p:cNvPr id="4" name="TextBox 3"/>
           <p:cNvSpPr txBox="1"/>
           <p:nvPr/>
         </p:nvSpPr>
         <p:spPr>
           <a:xfrm>
-            <a:off x="548640" y="1280160"/>
-            <a:ext cx="10972800" cy="365760"/>
+            <a:off x="640080" y="1371600"/>
+            <a:ext cx="10972800" cy="4572000"/>
           </a:xfrm>
           <a:prstGeom prst="rect">
             <a:avLst/>
@@ -4021,51 +4289,137 @@
           </a:bodyPr>
           <a:lstStyle/>
           <a:p>
-            <a:pPr algn="l"/>
-            <a:r>
-              <a:rPr sz="1500" b="1">
-                <a:solidFill>
-                  <a:srgbClr val="1F6FB4"/>
-                </a:solidFill>
-                <a:latin typeface="Helvetica Neue"/>
-              </a:rPr>
-              <a:t>What the estimate captures</a:t>
-            </a:r>
-          </a:p>
-          <a:p>
-            <a:r>
-              <a:rPr sz="1400" b="1">
+            <a:pPr/>
+            <a:r>
+              <a:rPr sz="1600">
                 <a:solidFill>
                   <a:srgbClr val="1A1A1A"/>
                 </a:solidFill>
-                <a:latin typeface="Helvetica Neue"/>
-              </a:rPr>
-              <a:t>The total effect of the COVID-19 pandemic on Alberta opioid mortality.</a:t>
-            </a:r>
-          </a:p>
-          <a:p>
-            <a:r>
-              <a:rPr sz="1200" b="0">
+                <a:latin typeface="Calibri"/>
+              </a:rPr>
+              <a:t>•  Interrupted time series</a:t>
+            </a:r>
+          </a:p>
+          <a:p>
+            <a:pPr lvl="1"/>
+            <a:r>
+              <a:rPr sz="1300">
                 <a:solidFill>
                   <a:srgbClr val="555555"/>
                 </a:solidFill>
-                <a:latin typeface="Helvetica Neue"/>
-              </a:rPr>
-              <a:t>Including the bundle of policy and social responses the pandemic produced: supply-chain disruption in the unregulated drug supply, reduced harm-reduction service capacity, mental-health service disruption, social isolation, economic shock. These are downstream of COVID, not parallel causes.</a:t>
-            </a:r>
-          </a:p>
-        </p:txBody>
-      </p:sp>
-      <p:sp>
-        <p:nvSpPr>
-          <p:cNvPr id="4" name="TextBox 3"/>
+                <a:latin typeface="Calibri"/>
+              </a:rPr>
+              <a:t>–  Compare the trend in the years before the cutoff to the trend in the years after</a:t>
+            </a:r>
+          </a:p>
+          <a:p>
+            <a:pPr lvl="1"/>
+            <a:r>
+              <a:rPr sz="1300">
+                <a:solidFill>
+                  <a:srgbClr val="555555"/>
+                </a:solidFill>
+                <a:latin typeface="Calibri"/>
+              </a:rPr>
+              <a:t>–  Measure the gap between them at the cutoff itself</a:t>
+            </a:r>
+          </a:p>
+          <a:p>
+            <a:pPr/>
+            <a:r>
+              <a:rPr sz="1600">
+                <a:solidFill>
+                  <a:srgbClr val="1A1A1A"/>
+                </a:solidFill>
+                <a:latin typeface="Calibri"/>
+              </a:rPr>
+              <a:t>•  Adjustments to keep the comparison fair</a:t>
+            </a:r>
+          </a:p>
+          <a:p>
+            <a:pPr lvl="1"/>
+            <a:r>
+              <a:rPr sz="1300">
+                <a:solidFill>
+                  <a:srgbClr val="555555"/>
+                </a:solidFill>
+                <a:latin typeface="Calibri"/>
+              </a:rPr>
+              <a:t>–  Use a rate per 100,000 residents (not raw counts), so population growth does not drive the result</a:t>
+            </a:r>
+          </a:p>
+          <a:p>
+            <a:pPr lvl="1"/>
+            <a:r>
+              <a:rPr sz="1300">
+                <a:solidFill>
+                  <a:srgbClr val="555555"/>
+                </a:solidFill>
+                <a:latin typeface="Calibri"/>
+              </a:rPr>
+              <a:t>–  Adjust for seasonality — opioid mortality has a predictable quarter-by-quarter pattern</a:t>
+            </a:r>
+          </a:p>
+          <a:p>
+            <a:pPr/>
+            <a:r>
+              <a:rPr sz="1600">
+                <a:solidFill>
+                  <a:srgbClr val="1A1A1A"/>
+                </a:solidFill>
+                <a:latin typeface="Calibri"/>
+              </a:rPr>
+              <a:t>•  Robustness checks to ensure the result is not fragile</a:t>
+            </a:r>
+          </a:p>
+          <a:p>
+            <a:pPr lvl="1"/>
+            <a:r>
+              <a:rPr sz="1300">
+                <a:solidFill>
+                  <a:srgbClr val="555555"/>
+                </a:solidFill>
+                <a:latin typeface="Calibri"/>
+              </a:rPr>
+              <a:t>–  Move the cutoff back into the pre-period as a placebo — should produce no jump</a:t>
+            </a:r>
+          </a:p>
+          <a:p>
+            <a:pPr lvl="1"/>
+            <a:r>
+              <a:rPr sz="1300">
+                <a:solidFill>
+                  <a:srgbClr val="555555"/>
+                </a:solidFill>
+                <a:latin typeface="Calibri"/>
+              </a:rPr>
+              <a:t>–  Drop the quarter that straddles the cutoff and refit</a:t>
+            </a:r>
+          </a:p>
+          <a:p>
+            <a:pPr lvl="1"/>
+            <a:r>
+              <a:rPr sz="1300">
+                <a:solidFill>
+                  <a:srgbClr val="555555"/>
+                </a:solidFill>
+                <a:latin typeface="Calibri"/>
+              </a:rPr>
+              <a:t>–  Re-fit using a count model with population offset as a cross-check</a:t>
+            </a:r>
+          </a:p>
+        </p:txBody>
+      </p:sp>
+      <p:sp>
+        <p:nvSpPr>
+          <p:cNvPr id="5" name="TextBox 4"/>
           <p:cNvSpPr txBox="1"/>
           <p:nvPr/>
         </p:nvSpPr>
         <p:spPr>
           <a:xfrm>
-            <a:off x="548640" y="3017520"/>
-            <a:ext cx="10972800" cy="365760"/>
+            <a:off x="548640" y="6446520"/>
+            <a:ext cx="10058400" cy="274320"/>
           </a:xfrm>
           <a:prstGeom prst="rect">
             <a:avLst/>
@@ -4073,56 +4427,33 @@
           <a:noFill/>
         </p:spPr>
         <p:txBody>
-          <a:bodyPr wrap="square">
+          <a:bodyPr wrap="none">
             <a:spAutoFit/>
           </a:bodyPr>
           <a:lstStyle/>
           <a:p>
-            <a:pPr algn="l"/>
-            <a:r>
-              <a:rPr sz="1500" b="1">
-                <a:solidFill>
-                  <a:srgbClr val="C0392B"/>
-                </a:solidFill>
-                <a:latin typeface="Helvetica Neue"/>
-              </a:rPr>
-              <a:t>What it does not do</a:t>
-            </a:r>
-          </a:p>
-          <a:p>
-            <a:r>
-              <a:rPr sz="1400" b="1">
-                <a:solidFill>
-                  <a:srgbClr val="1A1A1A"/>
-                </a:solidFill>
-                <a:latin typeface="Helvetica Neue"/>
-              </a:rPr>
-              <a:t>Decompose that total into its component channels.</a:t>
-            </a:r>
-          </a:p>
-          <a:p>
-            <a:r>
-              <a:rPr sz="1200" b="0">
-                <a:solidFill>
-                  <a:srgbClr val="555555"/>
-                </a:solidFill>
-                <a:latin typeface="Helvetica Neue"/>
-              </a:rPr>
-              <a:t>The estimate cannot tell you what share came from supply toxicity vs. service capacity vs. isolation vs. economic shock. A peer-province comparison would not fix this — all provinces faced COVID and its policy response at essentially the same time, so the comparison identifies Alberta-specific deviation, not a clean COVID-only channel.</a:t>
-            </a:r>
-          </a:p>
-        </p:txBody>
-      </p:sp>
-      <p:sp>
-        <p:nvSpPr>
-          <p:cNvPr id="5" name="TextBox 4"/>
+            <a:r>
+              <a:rPr sz="900">
+                <a:solidFill>
+                  <a:srgbClr val="999999"/>
+                </a:solidFill>
+                <a:latin typeface="Calibri"/>
+              </a:rPr>
+              <a:t>Alberta opioid mortality around COVID-19  |  independent project</a:t>
+            </a:r>
+          </a:p>
+        </p:txBody>
+      </p:sp>
+      <p:sp>
+        <p:nvSpPr>
+          <p:cNvPr id="6" name="TextBox 5"/>
           <p:cNvSpPr txBox="1"/>
           <p:nvPr/>
         </p:nvSpPr>
         <p:spPr>
           <a:xfrm>
-            <a:off x="548640" y="4937760"/>
-            <a:ext cx="10972800" cy="365760"/>
+            <a:off x="11521440" y="6446520"/>
+            <a:ext cx="548640" cy="274320"/>
           </a:xfrm>
           <a:prstGeom prst="rect">
             <a:avLst/>
@@ -4130,78 +4461,52 @@
           <a:noFill/>
         </p:spPr>
         <p:txBody>
-          <a:bodyPr wrap="square">
+          <a:bodyPr wrap="none">
             <a:spAutoFit/>
           </a:bodyPr>
           <a:lstStyle/>
           <a:p>
-            <a:pPr algn="l"/>
-            <a:r>
-              <a:rPr sz="1500" b="1">
-                <a:solidFill>
-                  <a:srgbClr val="1F6FB4"/>
-                </a:solidFill>
-                <a:latin typeface="Helvetica Neue"/>
-              </a:rPr>
-              <a:t>Realistic next steps</a:t>
-            </a:r>
-          </a:p>
-          <a:p>
-            <a:r>
-              <a:rPr sz="1200" b="0">
-                <a:solidFill>
-                  <a:srgbClr val="1A1A1A"/>
-                </a:solidFill>
-                <a:latin typeface="Helvetica Neue"/>
-              </a:rPr>
-              <a:t>1. Mechanism decomposition: triangulate supply-side, service-capacity, and outcome signals to attribute share</a:t>
-            </a:r>
-          </a:p>
-          <a:p>
-            <a:r>
-              <a:rPr sz="1200" b="0">
-                <a:solidFill>
-                  <a:srgbClr val="1A1A1A"/>
-                </a:solidFill>
-                <a:latin typeface="Helvetica Neue"/>
-              </a:rPr>
-              <a:t>2. Heterogeneity: by age, sex, zone, substance type — where the level shift concentrated</a:t>
-            </a:r>
-          </a:p>
-          <a:p>
-            <a:r>
-              <a:rPr sz="1200" b="0">
-                <a:solidFill>
-                  <a:srgbClr val="1A1A1A"/>
-                </a:solidFill>
-                <a:latin typeface="Helvetica Neue"/>
-              </a:rPr>
-              <a:t>3. Post-period dynamics: explicitly model the rise-and-decline shape, not just the immediate level shift</a:t>
-            </a:r>
-          </a:p>
-          <a:p>
-            <a:r>
-              <a:rPr sz="1200" b="0">
-                <a:solidFill>
-                  <a:srgbClr val="1A1A1A"/>
-                </a:solidFill>
-                <a:latin typeface="Helvetica Neue"/>
-              </a:rPr>
-              <a:t>4. Cumulative excess deaths through end-of-sample as a policy-relevant quantity</a:t>
-            </a:r>
-          </a:p>
-        </p:txBody>
-      </p:sp>
-      <p:sp>
-        <p:nvSpPr>
-          <p:cNvPr id="6" name="TextBox 5"/>
+            <a:pPr algn="r"/>
+            <a:r>
+              <a:rPr sz="1000">
+                <a:solidFill>
+                  <a:srgbClr val="999999"/>
+                </a:solidFill>
+                <a:latin typeface="Calibri"/>
+              </a:rPr>
+              <a:t>4</a:t>
+            </a:r>
+          </a:p>
+        </p:txBody>
+      </p:sp>
+    </p:spTree>
+  </p:cSld>
+  <p:clrMapOvr>
+    <a:masterClrMapping/>
+  </p:clrMapOvr>
+</p:sld>
+</file>
+
+<file path=ppt/slides/slide5.xml><?xml version="1.0" encoding="utf-8"?>
+<p:sld xmlns:a="http://schemas.openxmlformats.org/drawingml/2006/main" xmlns:p="http://schemas.openxmlformats.org/presentationml/2006/main" xmlns:r="http://schemas.openxmlformats.org/officeDocument/2006/relationships">
+  <p:cSld>
+    <p:spTree>
+      <p:nvGrpSpPr>
+        <p:cNvPr id="1" name=""/>
+        <p:cNvGrpSpPr/>
+        <p:nvPr/>
+      </p:nvGrpSpPr>
+      <p:grpSpPr/>
+      <p:sp>
+        <p:nvSpPr>
+          <p:cNvPr id="2" name="TextBox 1"/>
           <p:cNvSpPr txBox="1"/>
           <p:nvPr/>
         </p:nvSpPr>
         <p:spPr>
           <a:xfrm>
-            <a:off x="365760" y="6492240"/>
-            <a:ext cx="3657600" cy="274320"/>
+            <a:off x="548640" y="320040"/>
+            <a:ext cx="11064240" cy="640080"/>
           </a:xfrm>
           <a:prstGeom prst="rect">
             <a:avLst/>
@@ -4209,34 +4514,68 @@
           <a:noFill/>
         </p:spPr>
         <p:txBody>
-          <a:bodyPr wrap="square">
+          <a:bodyPr wrap="none">
             <a:spAutoFit/>
           </a:bodyPr>
           <a:lstStyle/>
           <a:p>
-            <a:pPr algn="l"/>
-            <a:r>
-              <a:rPr sz="900" b="0">
-                <a:solidFill>
-                  <a:srgbClr val="888888"/>
-                </a:solidFill>
-                <a:latin typeface="Helvetica Neue"/>
-              </a:rPr>
-              <a:t>Alberta opioid mortality and COVID-19  |  personal learning project</a:t>
-            </a:r>
-          </a:p>
-        </p:txBody>
-      </p:sp>
-      <p:sp>
-        <p:nvSpPr>
-          <p:cNvPr id="7" name="TextBox 6"/>
+            <a:r>
+              <a:rPr sz="2600" b="1">
+                <a:solidFill>
+                  <a:srgbClr val="000000"/>
+                </a:solidFill>
+                <a:latin typeface="Calibri"/>
+              </a:rPr>
+              <a:t>Data</a:t>
+            </a:r>
+          </a:p>
+        </p:txBody>
+      </p:sp>
+      <p:cxnSp>
+        <p:nvCxnSpPr>
+          <p:cNvPr id="3" name="Connector 2"/>
+          <p:cNvCxnSpPr/>
+          <p:nvPr/>
+        </p:nvCxnSpPr>
+        <p:spPr>
+          <a:xfrm>
+            <a:off x="548640" y="960120"/>
+            <a:ext cx="11064240" cy="0"/>
+          </a:xfrm>
+          <a:prstGeom prst="line">
+            <a:avLst/>
+          </a:prstGeom>
+          <a:ln w="9525">
+            <a:solidFill>
+              <a:srgbClr val="000000"/>
+            </a:solidFill>
+          </a:ln>
+        </p:spPr>
+        <p:style>
+          <a:lnRef idx="2">
+            <a:schemeClr val="accent1"/>
+          </a:lnRef>
+          <a:fillRef idx="0">
+            <a:schemeClr val="accent1"/>
+          </a:fillRef>
+          <a:effectRef idx="1">
+            <a:schemeClr val="accent1"/>
+          </a:effectRef>
+          <a:fontRef idx="minor">
+            <a:schemeClr val="tx1"/>
+          </a:fontRef>
+        </p:style>
+      </p:cxnSp>
+      <p:sp>
+        <p:nvSpPr>
+          <p:cNvPr id="4" name="TextBox 3"/>
           <p:cNvSpPr txBox="1"/>
           <p:nvPr/>
         </p:nvSpPr>
         <p:spPr>
           <a:xfrm>
-            <a:off x="11612880" y="6492240"/>
-            <a:ext cx="457200" cy="274320"/>
+            <a:off x="640080" y="1371600"/>
+            <a:ext cx="10972800" cy="4572000"/>
           </a:xfrm>
           <a:prstGeom prst="rect">
             <a:avLst/>
@@ -4249,15 +4588,1304 @@
           </a:bodyPr>
           <a:lstStyle/>
           <a:p>
+            <a:pPr/>
+            <a:r>
+              <a:rPr sz="1600">
+                <a:solidFill>
+                  <a:srgbClr val="1A1A1A"/>
+                </a:solidFill>
+                <a:latin typeface="Calibri"/>
+              </a:rPr>
+              <a:t>•  Public Health Agency of Canada — Substance-Related Harms Data</a:t>
+            </a:r>
+          </a:p>
+          <a:p>
+            <a:pPr lvl="1"/>
+            <a:r>
+              <a:rPr sz="1300">
+                <a:solidFill>
+                  <a:srgbClr val="555555"/>
+                </a:solidFill>
+                <a:latin typeface="Calibri"/>
+              </a:rPr>
+              <a:t>–  Quarterly opioid deaths in Alberta</a:t>
+            </a:r>
+          </a:p>
+          <a:p>
+            <a:pPr lvl="1"/>
+            <a:r>
+              <a:rPr sz="1300">
+                <a:solidFill>
+                  <a:srgbClr val="555555"/>
+                </a:solidFill>
+                <a:latin typeface="Calibri"/>
+              </a:rPr>
+              <a:t>–  2016 Q1 through 2025 Q3 — 39 quarters in total</a:t>
+            </a:r>
+          </a:p>
+          <a:p>
+            <a:pPr lvl="1"/>
+            <a:r>
+              <a:rPr sz="1300">
+                <a:solidFill>
+                  <a:srgbClr val="555555"/>
+                </a:solidFill>
+                <a:latin typeface="Calibri"/>
+              </a:rPr>
+              <a:t>–  Downloaded 20 May 2026 from health-infobase.canada.ca</a:t>
+            </a:r>
+          </a:p>
+          <a:p>
+            <a:pPr/>
+            <a:r>
+              <a:rPr sz="1600">
+                <a:solidFill>
+                  <a:srgbClr val="1A1A1A"/>
+                </a:solidFill>
+                <a:latin typeface="Calibri"/>
+              </a:rPr>
+              <a:t>•  Statistics Canada Table 17-10-0009-01 — Quarterly population estimates</a:t>
+            </a:r>
+          </a:p>
+          <a:p>
+            <a:pPr lvl="1"/>
+            <a:r>
+              <a:rPr sz="1300">
+                <a:solidFill>
+                  <a:srgbClr val="555555"/>
+                </a:solidFill>
+                <a:latin typeface="Calibri"/>
+              </a:rPr>
+              <a:t>–  Used to convert death counts into a rate per 100,000 residents</a:t>
+            </a:r>
+          </a:p>
+          <a:p>
+            <a:pPr/>
+            <a:r>
+              <a:rPr sz="1600">
+                <a:solidFill>
+                  <a:srgbClr val="1A1A1A"/>
+                </a:solidFill>
+                <a:latin typeface="Calibri"/>
+              </a:rPr>
+              <a:t>•  No internal Government of Alberta data used</a:t>
+            </a:r>
+          </a:p>
+          <a:p>
+            <a:pPr lvl="1"/>
+            <a:r>
+              <a:rPr sz="1300">
+                <a:solidFill>
+                  <a:srgbClr val="555555"/>
+                </a:solidFill>
+                <a:latin typeface="Calibri"/>
+              </a:rPr>
+              <a:t>–  All sources are public and reproducible</a:t>
+            </a:r>
+          </a:p>
+        </p:txBody>
+      </p:sp>
+      <p:sp>
+        <p:nvSpPr>
+          <p:cNvPr id="5" name="TextBox 4"/>
+          <p:cNvSpPr txBox="1"/>
+          <p:nvPr/>
+        </p:nvSpPr>
+        <p:spPr>
+          <a:xfrm>
+            <a:off x="548640" y="6446520"/>
+            <a:ext cx="10058400" cy="274320"/>
+          </a:xfrm>
+          <a:prstGeom prst="rect">
+            <a:avLst/>
+          </a:prstGeom>
+          <a:noFill/>
+        </p:spPr>
+        <p:txBody>
+          <a:bodyPr wrap="none">
+            <a:spAutoFit/>
+          </a:bodyPr>
+          <a:lstStyle/>
+          <a:p>
+            <a:r>
+              <a:rPr sz="900">
+                <a:solidFill>
+                  <a:srgbClr val="999999"/>
+                </a:solidFill>
+                <a:latin typeface="Calibri"/>
+              </a:rPr>
+              <a:t>Alberta opioid mortality around COVID-19  |  independent project</a:t>
+            </a:r>
+          </a:p>
+        </p:txBody>
+      </p:sp>
+      <p:sp>
+        <p:nvSpPr>
+          <p:cNvPr id="6" name="TextBox 5"/>
+          <p:cNvSpPr txBox="1"/>
+          <p:nvPr/>
+        </p:nvSpPr>
+        <p:spPr>
+          <a:xfrm>
+            <a:off x="11521440" y="6446520"/>
+            <a:ext cx="548640" cy="274320"/>
+          </a:xfrm>
+          <a:prstGeom prst="rect">
+            <a:avLst/>
+          </a:prstGeom>
+          <a:noFill/>
+        </p:spPr>
+        <p:txBody>
+          <a:bodyPr wrap="none">
+            <a:spAutoFit/>
+          </a:bodyPr>
+          <a:lstStyle/>
+          <a:p>
             <a:pPr algn="r"/>
             <a:r>
-              <a:rPr sz="900" b="0">
-                <a:solidFill>
-                  <a:srgbClr val="888888"/>
-                </a:solidFill>
-                <a:latin typeface="Helvetica Neue"/>
-              </a:rPr>
-              <a:t>4 / 4</a:t>
+              <a:rPr sz="1000">
+                <a:solidFill>
+                  <a:srgbClr val="999999"/>
+                </a:solidFill>
+                <a:latin typeface="Calibri"/>
+              </a:rPr>
+              <a:t>5</a:t>
+            </a:r>
+          </a:p>
+        </p:txBody>
+      </p:sp>
+    </p:spTree>
+  </p:cSld>
+  <p:clrMapOvr>
+    <a:masterClrMapping/>
+  </p:clrMapOvr>
+</p:sld>
+</file>
+
+<file path=ppt/slides/slide6.xml><?xml version="1.0" encoding="utf-8"?>
+<p:sld xmlns:a="http://schemas.openxmlformats.org/drawingml/2006/main" xmlns:p="http://schemas.openxmlformats.org/presentationml/2006/main" xmlns:r="http://schemas.openxmlformats.org/officeDocument/2006/relationships">
+  <p:cSld>
+    <p:spTree>
+      <p:nvGrpSpPr>
+        <p:cNvPr id="1" name=""/>
+        <p:cNvGrpSpPr/>
+        <p:nvPr/>
+      </p:nvGrpSpPr>
+      <p:grpSpPr/>
+      <p:sp>
+        <p:nvSpPr>
+          <p:cNvPr id="2" name="TextBox 1"/>
+          <p:cNvSpPr txBox="1"/>
+          <p:nvPr/>
+        </p:nvSpPr>
+        <p:spPr>
+          <a:xfrm>
+            <a:off x="548640" y="320040"/>
+            <a:ext cx="11064240" cy="640080"/>
+          </a:xfrm>
+          <a:prstGeom prst="rect">
+            <a:avLst/>
+          </a:prstGeom>
+          <a:noFill/>
+        </p:spPr>
+        <p:txBody>
+          <a:bodyPr wrap="none">
+            <a:spAutoFit/>
+          </a:bodyPr>
+          <a:lstStyle/>
+          <a:p>
+            <a:r>
+              <a:rPr sz="2600" b="1">
+                <a:solidFill>
+                  <a:srgbClr val="000000"/>
+                </a:solidFill>
+                <a:latin typeface="Calibri"/>
+              </a:rPr>
+              <a:t>Findings — A Sharp, Large, Persistent Increase</a:t>
+            </a:r>
+          </a:p>
+        </p:txBody>
+      </p:sp>
+      <p:cxnSp>
+        <p:nvCxnSpPr>
+          <p:cNvPr id="3" name="Connector 2"/>
+          <p:cNvCxnSpPr/>
+          <p:nvPr/>
+        </p:nvCxnSpPr>
+        <p:spPr>
+          <a:xfrm>
+            <a:off x="548640" y="960120"/>
+            <a:ext cx="11064240" cy="0"/>
+          </a:xfrm>
+          <a:prstGeom prst="line">
+            <a:avLst/>
+          </a:prstGeom>
+          <a:ln w="9525">
+            <a:solidFill>
+              <a:srgbClr val="000000"/>
+            </a:solidFill>
+          </a:ln>
+        </p:spPr>
+        <p:style>
+          <a:lnRef idx="2">
+            <a:schemeClr val="accent1"/>
+          </a:lnRef>
+          <a:fillRef idx="0">
+            <a:schemeClr val="accent1"/>
+          </a:fillRef>
+          <a:effectRef idx="1">
+            <a:schemeClr val="accent1"/>
+          </a:effectRef>
+          <a:fontRef idx="minor">
+            <a:schemeClr val="tx1"/>
+          </a:fontRef>
+        </p:style>
+      </p:cxnSp>
+      <p:pic>
+        <p:nvPicPr>
+          <p:cNvPr id="4" name="Picture 3" descr="rdit_opioid_deaths.png"/>
+          <p:cNvPicPr>
+            <a:picLocks noChangeAspect="1"/>
+          </p:cNvPicPr>
+          <p:nvPr/>
+        </p:nvPicPr>
+        <p:blipFill>
+          <a:blip r:embed="rId2"/>
+          <a:stretch>
+            <a:fillRect/>
+          </a:stretch>
+        </p:blipFill>
+        <p:spPr>
+          <a:xfrm>
+            <a:off x="548640" y="1188720"/>
+            <a:ext cx="7680960" cy="4649481"/>
+          </a:xfrm>
+          <a:prstGeom prst="rect">
+            <a:avLst/>
+          </a:prstGeom>
+        </p:spPr>
+      </p:pic>
+      <p:sp>
+        <p:nvSpPr>
+          <p:cNvPr id="5" name="TextBox 4"/>
+          <p:cNvSpPr txBox="1"/>
+          <p:nvPr/>
+        </p:nvSpPr>
+        <p:spPr>
+          <a:xfrm>
+            <a:off x="8412480" y="1280160"/>
+            <a:ext cx="3657600" cy="5029200"/>
+          </a:xfrm>
+          <a:prstGeom prst="rect">
+            <a:avLst/>
+          </a:prstGeom>
+          <a:noFill/>
+        </p:spPr>
+        <p:txBody>
+          <a:bodyPr wrap="square">
+            <a:spAutoFit/>
+          </a:bodyPr>
+          <a:lstStyle/>
+          <a:p>
+            <a:pPr/>
+            <a:r>
+              <a:rPr sz="1300">
+                <a:solidFill>
+                  <a:srgbClr val="1A1A1A"/>
+                </a:solidFill>
+                <a:latin typeface="Calibri"/>
+              </a:rPr>
+              <a:t>•  Pre-COVID average</a:t>
+            </a:r>
+          </a:p>
+          <a:p>
+            <a:pPr lvl="1"/>
+            <a:r>
+              <a:rPr sz="1100">
+                <a:solidFill>
+                  <a:srgbClr val="555555"/>
+                </a:solidFill>
+                <a:latin typeface="Calibri"/>
+              </a:rPr>
+              <a:t>–  About 4 deaths per 100,000 per quarter</a:t>
+            </a:r>
+          </a:p>
+          <a:p>
+            <a:pPr/>
+            <a:r>
+              <a:rPr sz="1300">
+                <a:solidFill>
+                  <a:srgbClr val="1A1A1A"/>
+                </a:solidFill>
+                <a:latin typeface="Calibri"/>
+              </a:rPr>
+              <a:t>•  Post-COVID average</a:t>
+            </a:r>
+          </a:p>
+          <a:p>
+            <a:pPr lvl="1"/>
+            <a:r>
+              <a:rPr sz="1100">
+                <a:solidFill>
+                  <a:srgbClr val="555555"/>
+                </a:solidFill>
+                <a:latin typeface="Calibri"/>
+              </a:rPr>
+              <a:t>–  About 8 deaths per 100,000 per quarter</a:t>
+            </a:r>
+          </a:p>
+          <a:p>
+            <a:pPr/>
+            <a:r>
+              <a:rPr sz="1300">
+                <a:solidFill>
+                  <a:srgbClr val="1A1A1A"/>
+                </a:solidFill>
+                <a:latin typeface="Calibri"/>
+              </a:rPr>
+              <a:t>•  Level shift at 2020 Q2</a:t>
+            </a:r>
+          </a:p>
+          <a:p>
+            <a:pPr lvl="1"/>
+            <a:r>
+              <a:rPr sz="1100">
+                <a:solidFill>
+                  <a:srgbClr val="555555"/>
+                </a:solidFill>
+                <a:latin typeface="Calibri"/>
+              </a:rPr>
+              <a:t>–  About 5.5 per 100,000 per quarter</a:t>
+            </a:r>
+          </a:p>
+          <a:p>
+            <a:pPr lvl="1"/>
+            <a:r>
+              <a:rPr sz="1100">
+                <a:solidFill>
+                  <a:srgbClr val="555555"/>
+                </a:solidFill>
+                <a:latin typeface="Calibri"/>
+              </a:rPr>
+              <a:t>–  Roughly a doubling of the rate</a:t>
+            </a:r>
+          </a:p>
+          <a:p>
+            <a:pPr lvl="1"/>
+            <a:r>
+              <a:rPr sz="1100">
+                <a:solidFill>
+                  <a:srgbClr val="555555"/>
+                </a:solidFill>
+                <a:latin typeface="Calibri"/>
+              </a:rPr>
+              <a:t>–  Statistically very strong</a:t>
+            </a:r>
+          </a:p>
+          <a:p>
+            <a:pPr/>
+            <a:r>
+              <a:rPr sz="1300">
+                <a:solidFill>
+                  <a:srgbClr val="1A1A1A"/>
+                </a:solidFill>
+                <a:latin typeface="Calibri"/>
+              </a:rPr>
+              <a:t>•  Pre-COVID trend was flat</a:t>
+            </a:r>
+          </a:p>
+          <a:p>
+            <a:pPr lvl="1"/>
+            <a:r>
+              <a:rPr sz="1100">
+                <a:solidFill>
+                  <a:srgbClr val="555555"/>
+                </a:solidFill>
+                <a:latin typeface="Calibri"/>
+              </a:rPr>
+              <a:t>–  The jump is not a continuation of an existing trend</a:t>
+            </a:r>
+          </a:p>
+        </p:txBody>
+      </p:sp>
+      <p:sp>
+        <p:nvSpPr>
+          <p:cNvPr id="6" name="TextBox 5"/>
+          <p:cNvSpPr txBox="1"/>
+          <p:nvPr/>
+        </p:nvSpPr>
+        <p:spPr>
+          <a:xfrm>
+            <a:off x="548640" y="6446520"/>
+            <a:ext cx="10058400" cy="274320"/>
+          </a:xfrm>
+          <a:prstGeom prst="rect">
+            <a:avLst/>
+          </a:prstGeom>
+          <a:noFill/>
+        </p:spPr>
+        <p:txBody>
+          <a:bodyPr wrap="none">
+            <a:spAutoFit/>
+          </a:bodyPr>
+          <a:lstStyle/>
+          <a:p>
+            <a:r>
+              <a:rPr sz="900">
+                <a:solidFill>
+                  <a:srgbClr val="999999"/>
+                </a:solidFill>
+                <a:latin typeface="Calibri"/>
+              </a:rPr>
+              <a:t>Alberta opioid mortality around COVID-19  |  independent project</a:t>
+            </a:r>
+          </a:p>
+        </p:txBody>
+      </p:sp>
+      <p:sp>
+        <p:nvSpPr>
+          <p:cNvPr id="7" name="TextBox 6"/>
+          <p:cNvSpPr txBox="1"/>
+          <p:nvPr/>
+        </p:nvSpPr>
+        <p:spPr>
+          <a:xfrm>
+            <a:off x="11521440" y="6446520"/>
+            <a:ext cx="548640" cy="274320"/>
+          </a:xfrm>
+          <a:prstGeom prst="rect">
+            <a:avLst/>
+          </a:prstGeom>
+          <a:noFill/>
+        </p:spPr>
+        <p:txBody>
+          <a:bodyPr wrap="none">
+            <a:spAutoFit/>
+          </a:bodyPr>
+          <a:lstStyle/>
+          <a:p>
+            <a:pPr algn="r"/>
+            <a:r>
+              <a:rPr sz="1000">
+                <a:solidFill>
+                  <a:srgbClr val="999999"/>
+                </a:solidFill>
+                <a:latin typeface="Calibri"/>
+              </a:rPr>
+              <a:t>6</a:t>
+            </a:r>
+          </a:p>
+        </p:txBody>
+      </p:sp>
+    </p:spTree>
+  </p:cSld>
+  <p:clrMapOvr>
+    <a:masterClrMapping/>
+  </p:clrMapOvr>
+</p:sld>
+</file>
+
+<file path=ppt/slides/slide7.xml><?xml version="1.0" encoding="utf-8"?>
+<p:sld xmlns:a="http://schemas.openxmlformats.org/drawingml/2006/main" xmlns:p="http://schemas.openxmlformats.org/presentationml/2006/main" xmlns:r="http://schemas.openxmlformats.org/officeDocument/2006/relationships">
+  <p:cSld>
+    <p:spTree>
+      <p:nvGrpSpPr>
+        <p:cNvPr id="1" name=""/>
+        <p:cNvGrpSpPr/>
+        <p:nvPr/>
+      </p:nvGrpSpPr>
+      <p:grpSpPr/>
+      <p:sp>
+        <p:nvSpPr>
+          <p:cNvPr id="2" name="TextBox 1"/>
+          <p:cNvSpPr txBox="1"/>
+          <p:nvPr/>
+        </p:nvSpPr>
+        <p:spPr>
+          <a:xfrm>
+            <a:off x="548640" y="320040"/>
+            <a:ext cx="11064240" cy="640080"/>
+          </a:xfrm>
+          <a:prstGeom prst="rect">
+            <a:avLst/>
+          </a:prstGeom>
+          <a:noFill/>
+        </p:spPr>
+        <p:txBody>
+          <a:bodyPr wrap="none">
+            <a:spAutoFit/>
+          </a:bodyPr>
+          <a:lstStyle/>
+          <a:p>
+            <a:r>
+              <a:rPr sz="2600" b="1">
+                <a:solidFill>
+                  <a:srgbClr val="000000"/>
+                </a:solidFill>
+                <a:latin typeface="Calibri"/>
+              </a:rPr>
+              <a:t>Robustness — The Result Is Not Fragile</a:t>
+            </a:r>
+          </a:p>
+        </p:txBody>
+      </p:sp>
+      <p:cxnSp>
+        <p:nvCxnSpPr>
+          <p:cNvPr id="3" name="Connector 2"/>
+          <p:cNvCxnSpPr/>
+          <p:nvPr/>
+        </p:nvCxnSpPr>
+        <p:spPr>
+          <a:xfrm>
+            <a:off x="548640" y="960120"/>
+            <a:ext cx="11064240" cy="0"/>
+          </a:xfrm>
+          <a:prstGeom prst="line">
+            <a:avLst/>
+          </a:prstGeom>
+          <a:ln w="9525">
+            <a:solidFill>
+              <a:srgbClr val="000000"/>
+            </a:solidFill>
+          </a:ln>
+        </p:spPr>
+        <p:style>
+          <a:lnRef idx="2">
+            <a:schemeClr val="accent1"/>
+          </a:lnRef>
+          <a:fillRef idx="0">
+            <a:schemeClr val="accent1"/>
+          </a:fillRef>
+          <a:effectRef idx="1">
+            <a:schemeClr val="accent1"/>
+          </a:effectRef>
+          <a:fontRef idx="minor">
+            <a:schemeClr val="tx1"/>
+          </a:fontRef>
+        </p:style>
+      </p:cxnSp>
+      <p:sp>
+        <p:nvSpPr>
+          <p:cNvPr id="4" name="TextBox 3"/>
+          <p:cNvSpPr txBox="1"/>
+          <p:nvPr/>
+        </p:nvSpPr>
+        <p:spPr>
+          <a:xfrm>
+            <a:off x="640080" y="1371600"/>
+            <a:ext cx="10972800" cy="4572000"/>
+          </a:xfrm>
+          <a:prstGeom prst="rect">
+            <a:avLst/>
+          </a:prstGeom>
+          <a:noFill/>
+        </p:spPr>
+        <p:txBody>
+          <a:bodyPr wrap="square">
+            <a:spAutoFit/>
+          </a:bodyPr>
+          <a:lstStyle/>
+          <a:p>
+            <a:pPr/>
+            <a:r>
+              <a:rPr sz="1500">
+                <a:solidFill>
+                  <a:srgbClr val="1A1A1A"/>
+                </a:solidFill>
+                <a:latin typeface="Calibri"/>
+              </a:rPr>
+              <a:t>•  Placebo cutoffs in the pre-period (2018–2019)</a:t>
+            </a:r>
+          </a:p>
+          <a:p>
+            <a:pPr lvl="1"/>
+            <a:r>
+              <a:rPr sz="1300">
+                <a:solidFill>
+                  <a:srgbClr val="555555"/>
+                </a:solidFill>
+                <a:latin typeface="Calibri"/>
+              </a:rPr>
+              <a:t>–  When we move the cutoff to a date before COVID, the model finds no comparable jump</a:t>
+            </a:r>
+          </a:p>
+          <a:p>
+            <a:pPr lvl="1"/>
+            <a:r>
+              <a:rPr sz="1300">
+                <a:solidFill>
+                  <a:srgbClr val="555555"/>
+                </a:solidFill>
+                <a:latin typeface="Calibri"/>
+              </a:rPr>
+              <a:t>–  Largest placebo movement is about a third of the real jump, and in the opposite direction</a:t>
+            </a:r>
+          </a:p>
+          <a:p>
+            <a:pPr/>
+            <a:r>
+              <a:rPr sz="1500">
+                <a:solidFill>
+                  <a:srgbClr val="1A1A1A"/>
+                </a:solidFill>
+                <a:latin typeface="Calibri"/>
+              </a:rPr>
+              <a:t>•  Dropping the quarter that straddles the cutoff (2020 Q1)</a:t>
+            </a:r>
+          </a:p>
+          <a:p>
+            <a:pPr lvl="1"/>
+            <a:r>
+              <a:rPr sz="1300">
+                <a:solidFill>
+                  <a:srgbClr val="555555"/>
+                </a:solidFill>
+                <a:latin typeface="Calibri"/>
+              </a:rPr>
+              <a:t>–  The estimate moves by less than three per cent</a:t>
+            </a:r>
+          </a:p>
+          <a:p>
+            <a:pPr/>
+            <a:r>
+              <a:rPr sz="1500">
+                <a:solidFill>
+                  <a:srgbClr val="1A1A1A"/>
+                </a:solidFill>
+                <a:latin typeface="Calibri"/>
+              </a:rPr>
+              <a:t>•  Different statistical assumptions about standard errors</a:t>
+            </a:r>
+          </a:p>
+          <a:p>
+            <a:pPr lvl="1"/>
+            <a:r>
+              <a:rPr sz="1300">
+                <a:solidFill>
+                  <a:srgbClr val="555555"/>
+                </a:solidFill>
+                <a:latin typeface="Calibri"/>
+              </a:rPr>
+              <a:t>–  The estimate is the same; the size of the confidence interval barely changes</a:t>
+            </a:r>
+          </a:p>
+          <a:p>
+            <a:pPr/>
+            <a:r>
+              <a:rPr sz="1500">
+                <a:solidFill>
+                  <a:srgbClr val="1A1A1A"/>
+                </a:solidFill>
+                <a:latin typeface="Calibri"/>
+              </a:rPr>
+              <a:t>•  A count-model cross-check</a:t>
+            </a:r>
+          </a:p>
+          <a:p>
+            <a:pPr lvl="1"/>
+            <a:r>
+              <a:rPr sz="1300">
+                <a:solidFill>
+                  <a:srgbClr val="555555"/>
+                </a:solidFill>
+                <a:latin typeface="Calibri"/>
+              </a:rPr>
+              <a:t>–  The post-COVID rate is about 2.4× the pre-COVID rate, consistent with the main estimate</a:t>
+            </a:r>
+          </a:p>
+        </p:txBody>
+      </p:sp>
+      <p:sp>
+        <p:nvSpPr>
+          <p:cNvPr id="5" name="TextBox 4"/>
+          <p:cNvSpPr txBox="1"/>
+          <p:nvPr/>
+        </p:nvSpPr>
+        <p:spPr>
+          <a:xfrm>
+            <a:off x="548640" y="6446520"/>
+            <a:ext cx="10058400" cy="274320"/>
+          </a:xfrm>
+          <a:prstGeom prst="rect">
+            <a:avLst/>
+          </a:prstGeom>
+          <a:noFill/>
+        </p:spPr>
+        <p:txBody>
+          <a:bodyPr wrap="none">
+            <a:spAutoFit/>
+          </a:bodyPr>
+          <a:lstStyle/>
+          <a:p>
+            <a:r>
+              <a:rPr sz="900">
+                <a:solidFill>
+                  <a:srgbClr val="999999"/>
+                </a:solidFill>
+                <a:latin typeface="Calibri"/>
+              </a:rPr>
+              <a:t>Alberta opioid mortality around COVID-19  |  independent project</a:t>
+            </a:r>
+          </a:p>
+        </p:txBody>
+      </p:sp>
+      <p:sp>
+        <p:nvSpPr>
+          <p:cNvPr id="6" name="TextBox 5"/>
+          <p:cNvSpPr txBox="1"/>
+          <p:nvPr/>
+        </p:nvSpPr>
+        <p:spPr>
+          <a:xfrm>
+            <a:off x="11521440" y="6446520"/>
+            <a:ext cx="548640" cy="274320"/>
+          </a:xfrm>
+          <a:prstGeom prst="rect">
+            <a:avLst/>
+          </a:prstGeom>
+          <a:noFill/>
+        </p:spPr>
+        <p:txBody>
+          <a:bodyPr wrap="none">
+            <a:spAutoFit/>
+          </a:bodyPr>
+          <a:lstStyle/>
+          <a:p>
+            <a:pPr algn="r"/>
+            <a:r>
+              <a:rPr sz="1000">
+                <a:solidFill>
+                  <a:srgbClr val="999999"/>
+                </a:solidFill>
+                <a:latin typeface="Calibri"/>
+              </a:rPr>
+              <a:t>7</a:t>
+            </a:r>
+          </a:p>
+        </p:txBody>
+      </p:sp>
+    </p:spTree>
+  </p:cSld>
+  <p:clrMapOvr>
+    <a:masterClrMapping/>
+  </p:clrMapOvr>
+</p:sld>
+</file>
+
+<file path=ppt/slides/slide8.xml><?xml version="1.0" encoding="utf-8"?>
+<p:sld xmlns:a="http://schemas.openxmlformats.org/drawingml/2006/main" xmlns:p="http://schemas.openxmlformats.org/presentationml/2006/main" xmlns:r="http://schemas.openxmlformats.org/officeDocument/2006/relationships">
+  <p:cSld>
+    <p:spTree>
+      <p:nvGrpSpPr>
+        <p:cNvPr id="1" name=""/>
+        <p:cNvGrpSpPr/>
+        <p:nvPr/>
+      </p:nvGrpSpPr>
+      <p:grpSpPr/>
+      <p:sp>
+        <p:nvSpPr>
+          <p:cNvPr id="2" name="TextBox 1"/>
+          <p:cNvSpPr txBox="1"/>
+          <p:nvPr/>
+        </p:nvSpPr>
+        <p:spPr>
+          <a:xfrm>
+            <a:off x="548640" y="320040"/>
+            <a:ext cx="11064240" cy="640080"/>
+          </a:xfrm>
+          <a:prstGeom prst="rect">
+            <a:avLst/>
+          </a:prstGeom>
+          <a:noFill/>
+        </p:spPr>
+        <p:txBody>
+          <a:bodyPr wrap="none">
+            <a:spAutoFit/>
+          </a:bodyPr>
+          <a:lstStyle/>
+          <a:p>
+            <a:r>
+              <a:rPr sz="2600" b="1">
+                <a:solidFill>
+                  <a:srgbClr val="000000"/>
+                </a:solidFill>
+                <a:latin typeface="Calibri"/>
+              </a:rPr>
+              <a:t>What This Tells Us</a:t>
+            </a:r>
+          </a:p>
+        </p:txBody>
+      </p:sp>
+      <p:cxnSp>
+        <p:nvCxnSpPr>
+          <p:cNvPr id="3" name="Connector 2"/>
+          <p:cNvCxnSpPr/>
+          <p:nvPr/>
+        </p:nvCxnSpPr>
+        <p:spPr>
+          <a:xfrm>
+            <a:off x="548640" y="960120"/>
+            <a:ext cx="11064240" cy="0"/>
+          </a:xfrm>
+          <a:prstGeom prst="line">
+            <a:avLst/>
+          </a:prstGeom>
+          <a:ln w="9525">
+            <a:solidFill>
+              <a:srgbClr val="000000"/>
+            </a:solidFill>
+          </a:ln>
+        </p:spPr>
+        <p:style>
+          <a:lnRef idx="2">
+            <a:schemeClr val="accent1"/>
+          </a:lnRef>
+          <a:fillRef idx="0">
+            <a:schemeClr val="accent1"/>
+          </a:fillRef>
+          <a:effectRef idx="1">
+            <a:schemeClr val="accent1"/>
+          </a:effectRef>
+          <a:fontRef idx="minor">
+            <a:schemeClr val="tx1"/>
+          </a:fontRef>
+        </p:style>
+      </p:cxnSp>
+      <p:sp>
+        <p:nvSpPr>
+          <p:cNvPr id="4" name="TextBox 3"/>
+          <p:cNvSpPr txBox="1"/>
+          <p:nvPr/>
+        </p:nvSpPr>
+        <p:spPr>
+          <a:xfrm>
+            <a:off x="640080" y="1371600"/>
+            <a:ext cx="10972800" cy="4572000"/>
+          </a:xfrm>
+          <a:prstGeom prst="rect">
+            <a:avLst/>
+          </a:prstGeom>
+          <a:noFill/>
+        </p:spPr>
+        <p:txBody>
+          <a:bodyPr wrap="square">
+            <a:spAutoFit/>
+          </a:bodyPr>
+          <a:lstStyle/>
+          <a:p>
+            <a:pPr/>
+            <a:r>
+              <a:rPr sz="1600">
+                <a:solidFill>
+                  <a:srgbClr val="1A1A1A"/>
+                </a:solidFill>
+                <a:latin typeface="Calibri"/>
+              </a:rPr>
+              <a:t>•  There is a real, sharp, sustained change in Alberta opioid mortality at the COVID onset</a:t>
+            </a:r>
+          </a:p>
+          <a:p>
+            <a:pPr lvl="1"/>
+            <a:r>
+              <a:rPr sz="1300">
+                <a:solidFill>
+                  <a:srgbClr val="555555"/>
+                </a:solidFill>
+                <a:latin typeface="Calibri"/>
+              </a:rPr>
+              <a:t>–  Roughly a doubling of the rate, holding pre-trend and seasonality constant</a:t>
+            </a:r>
+          </a:p>
+          <a:p>
+            <a:pPr lvl="1"/>
+            <a:r>
+              <a:rPr sz="1300">
+                <a:solidFill>
+                  <a:srgbClr val="555555"/>
+                </a:solidFill>
+                <a:latin typeface="Calibri"/>
+              </a:rPr>
+              <a:t>–  The change is large enough to persist for years, with the rate only returning toward baseline since 2024</a:t>
+            </a:r>
+          </a:p>
+          <a:p>
+            <a:pPr/>
+            <a:r>
+              <a:rPr sz="1600">
+                <a:solidFill>
+                  <a:srgbClr val="1A1A1A"/>
+                </a:solidFill>
+                <a:latin typeface="Calibri"/>
+              </a:rPr>
+              <a:t>•  The change is attributable to the COVID-19 pandemic broadly</a:t>
+            </a:r>
+          </a:p>
+          <a:p>
+            <a:pPr lvl="1"/>
+            <a:r>
+              <a:rPr sz="1300">
+                <a:solidFill>
+                  <a:srgbClr val="555555"/>
+                </a:solidFill>
+                <a:latin typeface="Calibri"/>
+              </a:rPr>
+              <a:t>–  This includes the virus, public health measures, supply chain disruption, harm reduction service changes, mental health service disruption, social isolation, and economic shock</a:t>
+            </a:r>
+          </a:p>
+          <a:p>
+            <a:pPr lvl="1"/>
+            <a:r>
+              <a:rPr sz="1300">
+                <a:solidFill>
+                  <a:srgbClr val="555555"/>
+                </a:solidFill>
+                <a:latin typeface="Calibri"/>
+              </a:rPr>
+              <a:t>–  These are all downstream consequences of the pandemic — they came together by construction, not by coincidence</a:t>
+            </a:r>
+          </a:p>
+        </p:txBody>
+      </p:sp>
+      <p:sp>
+        <p:nvSpPr>
+          <p:cNvPr id="5" name="TextBox 4"/>
+          <p:cNvSpPr txBox="1"/>
+          <p:nvPr/>
+        </p:nvSpPr>
+        <p:spPr>
+          <a:xfrm>
+            <a:off x="548640" y="6446520"/>
+            <a:ext cx="10058400" cy="274320"/>
+          </a:xfrm>
+          <a:prstGeom prst="rect">
+            <a:avLst/>
+          </a:prstGeom>
+          <a:noFill/>
+        </p:spPr>
+        <p:txBody>
+          <a:bodyPr wrap="none">
+            <a:spAutoFit/>
+          </a:bodyPr>
+          <a:lstStyle/>
+          <a:p>
+            <a:r>
+              <a:rPr sz="900">
+                <a:solidFill>
+                  <a:srgbClr val="999999"/>
+                </a:solidFill>
+                <a:latin typeface="Calibri"/>
+              </a:rPr>
+              <a:t>Alberta opioid mortality around COVID-19  |  independent project</a:t>
+            </a:r>
+          </a:p>
+        </p:txBody>
+      </p:sp>
+      <p:sp>
+        <p:nvSpPr>
+          <p:cNvPr id="6" name="TextBox 5"/>
+          <p:cNvSpPr txBox="1"/>
+          <p:nvPr/>
+        </p:nvSpPr>
+        <p:spPr>
+          <a:xfrm>
+            <a:off x="11521440" y="6446520"/>
+            <a:ext cx="548640" cy="274320"/>
+          </a:xfrm>
+          <a:prstGeom prst="rect">
+            <a:avLst/>
+          </a:prstGeom>
+          <a:noFill/>
+        </p:spPr>
+        <p:txBody>
+          <a:bodyPr wrap="none">
+            <a:spAutoFit/>
+          </a:bodyPr>
+          <a:lstStyle/>
+          <a:p>
+            <a:pPr algn="r"/>
+            <a:r>
+              <a:rPr sz="1000">
+                <a:solidFill>
+                  <a:srgbClr val="999999"/>
+                </a:solidFill>
+                <a:latin typeface="Calibri"/>
+              </a:rPr>
+              <a:t>8</a:t>
+            </a:r>
+          </a:p>
+        </p:txBody>
+      </p:sp>
+    </p:spTree>
+  </p:cSld>
+  <p:clrMapOvr>
+    <a:masterClrMapping/>
+  </p:clrMapOvr>
+</p:sld>
+</file>
+
+<file path=ppt/slides/slide9.xml><?xml version="1.0" encoding="utf-8"?>
+<p:sld xmlns:a="http://schemas.openxmlformats.org/drawingml/2006/main" xmlns:p="http://schemas.openxmlformats.org/presentationml/2006/main" xmlns:r="http://schemas.openxmlformats.org/officeDocument/2006/relationships">
+  <p:cSld>
+    <p:spTree>
+      <p:nvGrpSpPr>
+        <p:cNvPr id="1" name=""/>
+        <p:cNvGrpSpPr/>
+        <p:nvPr/>
+      </p:nvGrpSpPr>
+      <p:grpSpPr/>
+      <p:sp>
+        <p:nvSpPr>
+          <p:cNvPr id="2" name="TextBox 1"/>
+          <p:cNvSpPr txBox="1"/>
+          <p:nvPr/>
+        </p:nvSpPr>
+        <p:spPr>
+          <a:xfrm>
+            <a:off x="548640" y="320040"/>
+            <a:ext cx="11064240" cy="640080"/>
+          </a:xfrm>
+          <a:prstGeom prst="rect">
+            <a:avLst/>
+          </a:prstGeom>
+          <a:noFill/>
+        </p:spPr>
+        <p:txBody>
+          <a:bodyPr wrap="none">
+            <a:spAutoFit/>
+          </a:bodyPr>
+          <a:lstStyle/>
+          <a:p>
+            <a:r>
+              <a:rPr sz="2600" b="1">
+                <a:solidFill>
+                  <a:srgbClr val="000000"/>
+                </a:solidFill>
+                <a:latin typeface="Calibri"/>
+              </a:rPr>
+              <a:t>What This Does Not Tell Us</a:t>
+            </a:r>
+          </a:p>
+        </p:txBody>
+      </p:sp>
+      <p:cxnSp>
+        <p:nvCxnSpPr>
+          <p:cNvPr id="3" name="Connector 2"/>
+          <p:cNvCxnSpPr/>
+          <p:nvPr/>
+        </p:nvCxnSpPr>
+        <p:spPr>
+          <a:xfrm>
+            <a:off x="548640" y="960120"/>
+            <a:ext cx="11064240" cy="0"/>
+          </a:xfrm>
+          <a:prstGeom prst="line">
+            <a:avLst/>
+          </a:prstGeom>
+          <a:ln w="9525">
+            <a:solidFill>
+              <a:srgbClr val="000000"/>
+            </a:solidFill>
+          </a:ln>
+        </p:spPr>
+        <p:style>
+          <a:lnRef idx="2">
+            <a:schemeClr val="accent1"/>
+          </a:lnRef>
+          <a:fillRef idx="0">
+            <a:schemeClr val="accent1"/>
+          </a:fillRef>
+          <a:effectRef idx="1">
+            <a:schemeClr val="accent1"/>
+          </a:effectRef>
+          <a:fontRef idx="minor">
+            <a:schemeClr val="tx1"/>
+          </a:fontRef>
+        </p:style>
+      </p:cxnSp>
+      <p:sp>
+        <p:nvSpPr>
+          <p:cNvPr id="4" name="TextBox 3"/>
+          <p:cNvSpPr txBox="1"/>
+          <p:nvPr/>
+        </p:nvSpPr>
+        <p:spPr>
+          <a:xfrm>
+            <a:off x="640080" y="1371600"/>
+            <a:ext cx="10972800" cy="4572000"/>
+          </a:xfrm>
+          <a:prstGeom prst="rect">
+            <a:avLst/>
+          </a:prstGeom>
+          <a:noFill/>
+        </p:spPr>
+        <p:txBody>
+          <a:bodyPr wrap="square">
+            <a:spAutoFit/>
+          </a:bodyPr>
+          <a:lstStyle/>
+          <a:p>
+            <a:pPr/>
+            <a:r>
+              <a:rPr sz="1500">
+                <a:solidFill>
+                  <a:srgbClr val="1A1A1A"/>
+                </a:solidFill>
+                <a:latin typeface="Calibri"/>
+              </a:rPr>
+              <a:t>•  We cannot separate the virus channel from everything else that came with the pandemic</a:t>
+            </a:r>
+          </a:p>
+          <a:p>
+            <a:pPr lvl="1"/>
+            <a:r>
+              <a:rPr sz="1300">
+                <a:solidFill>
+                  <a:srgbClr val="555555"/>
+                </a:solidFill>
+                <a:latin typeface="Calibri"/>
+              </a:rPr>
+              <a:t>–  What share came from supply toxicity vs. service capacity vs. isolation vs. economic shock is a separate question</a:t>
+            </a:r>
+          </a:p>
+          <a:p>
+            <a:pPr lvl="1"/>
+            <a:r>
+              <a:rPr sz="1300">
+                <a:solidFill>
+                  <a:srgbClr val="555555"/>
+                </a:solidFill>
+                <a:latin typeface="Calibri"/>
+              </a:rPr>
+              <a:t>–  Answering it needs different data — drug-checking composition, service utilization, etc.</a:t>
+            </a:r>
+          </a:p>
+          <a:p>
+            <a:pPr/>
+            <a:r>
+              <a:rPr sz="1500">
+                <a:solidFill>
+                  <a:srgbClr val="1A1A1A"/>
+                </a:solidFill>
+                <a:latin typeface="Calibri"/>
+              </a:rPr>
+              <a:t>•  A peer-province comparison would not isolate a clean 'COVID-only' effect</a:t>
+            </a:r>
+          </a:p>
+          <a:p>
+            <a:pPr lvl="1"/>
+            <a:r>
+              <a:rPr sz="1300">
+                <a:solidFill>
+                  <a:srgbClr val="555555"/>
+                </a:solidFill>
+                <a:latin typeface="Calibri"/>
+              </a:rPr>
+              <a:t>–  All Canadian provinces faced COVID and its policy response at essentially the same time</a:t>
+            </a:r>
+          </a:p>
+          <a:p>
+            <a:pPr lvl="1"/>
+            <a:r>
+              <a:rPr sz="1300">
+                <a:solidFill>
+                  <a:srgbClr val="555555"/>
+                </a:solidFill>
+                <a:latin typeface="Calibri"/>
+              </a:rPr>
+              <a:t>–  Comparing Alberta to BC or Ontario would identify Alberta-specific deviation, not the virus channel alone</a:t>
+            </a:r>
+          </a:p>
+          <a:p>
+            <a:pPr/>
+            <a:r>
+              <a:rPr sz="1500">
+                <a:solidFill>
+                  <a:srgbClr val="1A1A1A"/>
+                </a:solidFill>
+                <a:latin typeface="Calibri"/>
+              </a:rPr>
+              <a:t>•  The estimate captures the level shift at the cutoff, not the full trajectory</a:t>
+            </a:r>
+          </a:p>
+          <a:p>
+            <a:pPr lvl="1"/>
+            <a:r>
+              <a:rPr sz="1300">
+                <a:solidFill>
+                  <a:srgbClr val="555555"/>
+                </a:solidFill>
+                <a:latin typeface="Calibri"/>
+              </a:rPr>
+              <a:t>–  The post-COVID period peaked in 2021 Q4 and has been declining since 2024 — the average effect varies year by year</a:t>
+            </a:r>
+          </a:p>
+        </p:txBody>
+      </p:sp>
+      <p:sp>
+        <p:nvSpPr>
+          <p:cNvPr id="5" name="TextBox 4"/>
+          <p:cNvSpPr txBox="1"/>
+          <p:nvPr/>
+        </p:nvSpPr>
+        <p:spPr>
+          <a:xfrm>
+            <a:off x="548640" y="6446520"/>
+            <a:ext cx="10058400" cy="274320"/>
+          </a:xfrm>
+          <a:prstGeom prst="rect">
+            <a:avLst/>
+          </a:prstGeom>
+          <a:noFill/>
+        </p:spPr>
+        <p:txBody>
+          <a:bodyPr wrap="none">
+            <a:spAutoFit/>
+          </a:bodyPr>
+          <a:lstStyle/>
+          <a:p>
+            <a:r>
+              <a:rPr sz="900">
+                <a:solidFill>
+                  <a:srgbClr val="999999"/>
+                </a:solidFill>
+                <a:latin typeface="Calibri"/>
+              </a:rPr>
+              <a:t>Alberta opioid mortality around COVID-19  |  independent project</a:t>
+            </a:r>
+          </a:p>
+        </p:txBody>
+      </p:sp>
+      <p:sp>
+        <p:nvSpPr>
+          <p:cNvPr id="6" name="TextBox 5"/>
+          <p:cNvSpPr txBox="1"/>
+          <p:nvPr/>
+        </p:nvSpPr>
+        <p:spPr>
+          <a:xfrm>
+            <a:off x="11521440" y="6446520"/>
+            <a:ext cx="548640" cy="274320"/>
+          </a:xfrm>
+          <a:prstGeom prst="rect">
+            <a:avLst/>
+          </a:prstGeom>
+          <a:noFill/>
+        </p:spPr>
+        <p:txBody>
+          <a:bodyPr wrap="none">
+            <a:spAutoFit/>
+          </a:bodyPr>
+          <a:lstStyle/>
+          <a:p>
+            <a:pPr algn="r"/>
+            <a:r>
+              <a:rPr sz="1000">
+                <a:solidFill>
+                  <a:srgbClr val="999999"/>
+                </a:solidFill>
+                <a:latin typeface="Calibri"/>
+              </a:rPr>
+              <a:t>9</a:t>
             </a:r>
           </a:p>
         </p:txBody>

</xml_diff>

<commit_message>
Rebuild deck and writeup: policy briefing arc with sentence-style titles, detailed COVID background, no em-dashes
</commit_message>
<xml_diff>
--- a/slides.pptx
+++ b/slides.pptx
@@ -12,10 +12,6 @@
     <p:sldId id="260" r:id="rId11"/>
     <p:sldId id="261" r:id="rId12"/>
     <p:sldId id="262" r:id="rId13"/>
-    <p:sldId id="263" r:id="rId14"/>
-    <p:sldId id="264" r:id="rId15"/>
-    <p:sldId id="265" r:id="rId16"/>
-    <p:sldId id="266" r:id="rId17"/>
   </p:sldIdLst>
   <p:sldSz cx="12188952" cy="6858000" type="screen4x3"/>
   <p:notesSz cx="6858000" cy="9144000"/>
@@ -3121,13 +3117,13 @@
           <a:lstStyle/>
           <a:p>
             <a:r>
-              <a:rPr sz="3600" b="1">
+              <a:rPr sz="3400" b="1">
                 <a:solidFill>
                   <a:srgbClr val="000000"/>
                 </a:solidFill>
                 <a:latin typeface="Calibri"/>
               </a:rPr>
-              <a:t>Alberta Opioid Mortality Around the COVID-19 Onset</a:t>
+              <a:t>Alberta opioid mortality around the COVID-19 onset</a:t>
             </a:r>
           </a:p>
         </p:txBody>
@@ -3175,7 +3171,7 @@
         <p:spPr>
           <a:xfrm>
             <a:off x="731520" y="4572000"/>
-            <a:ext cx="10698480" cy="1371600"/>
+            <a:ext cx="10698480" cy="1463040"/>
           </a:xfrm>
           <a:prstGeom prst="rect">
             <a:avLst/>
@@ -3206,18 +3202,7 @@
                 </a:solidFill>
                 <a:latin typeface="Calibri"/>
               </a:rPr>
-              <a:t>Independent project</a:t>
-            </a:r>
-          </a:p>
-          <a:p>
-            <a:r>
-              <a:rPr sz="1200">
-                <a:solidFill>
-                  <a:srgbClr val="555555"/>
-                </a:solidFill>
-                <a:latin typeface="Calibri"/>
-              </a:rPr>
-              <a:t>May 2026</a:t>
+              <a:t>Independent project, May 2026</a:t>
             </a:r>
           </a:p>
           <a:p>
@@ -3264,404 +3249,6 @@
                 <a:latin typeface="Calibri"/>
               </a:rPr>
               <a:t>1</a:t>
-            </a:r>
-          </a:p>
-        </p:txBody>
-      </p:sp>
-    </p:spTree>
-  </p:cSld>
-  <p:clrMapOvr>
-    <a:masterClrMapping/>
-  </p:clrMapOvr>
-</p:sld>
-</file>
-
-<file path=ppt/slides/slide10.xml><?xml version="1.0" encoding="utf-8"?>
-<p:sld xmlns:a="http://schemas.openxmlformats.org/drawingml/2006/main" xmlns:p="http://schemas.openxmlformats.org/presentationml/2006/main" xmlns:r="http://schemas.openxmlformats.org/officeDocument/2006/relationships">
-  <p:cSld>
-    <p:spTree>
-      <p:nvGrpSpPr>
-        <p:cNvPr id="1" name=""/>
-        <p:cNvGrpSpPr/>
-        <p:nvPr/>
-      </p:nvGrpSpPr>
-      <p:grpSpPr/>
-      <p:sp>
-        <p:nvSpPr>
-          <p:cNvPr id="2" name="TextBox 1"/>
-          <p:cNvSpPr txBox="1"/>
-          <p:nvPr/>
-        </p:nvSpPr>
-        <p:spPr>
-          <a:xfrm>
-            <a:off x="548640" y="320040"/>
-            <a:ext cx="11064240" cy="640080"/>
-          </a:xfrm>
-          <a:prstGeom prst="rect">
-            <a:avLst/>
-          </a:prstGeom>
-          <a:noFill/>
-        </p:spPr>
-        <p:txBody>
-          <a:bodyPr wrap="none">
-            <a:spAutoFit/>
-          </a:bodyPr>
-          <a:lstStyle/>
-          <a:p>
-            <a:r>
-              <a:rPr sz="2600" b="1">
-                <a:solidFill>
-                  <a:srgbClr val="000000"/>
-                </a:solidFill>
-                <a:latin typeface="Calibri"/>
-              </a:rPr>
-              <a:t>Next Steps</a:t>
-            </a:r>
-          </a:p>
-        </p:txBody>
-      </p:sp>
-      <p:cxnSp>
-        <p:nvCxnSpPr>
-          <p:cNvPr id="3" name="Connector 2"/>
-          <p:cNvCxnSpPr/>
-          <p:nvPr/>
-        </p:nvCxnSpPr>
-        <p:spPr>
-          <a:xfrm>
-            <a:off x="548640" y="960120"/>
-            <a:ext cx="11064240" cy="0"/>
-          </a:xfrm>
-          <a:prstGeom prst="line">
-            <a:avLst/>
-          </a:prstGeom>
-          <a:ln w="9525">
-            <a:solidFill>
-              <a:srgbClr val="000000"/>
-            </a:solidFill>
-          </a:ln>
-        </p:spPr>
-        <p:style>
-          <a:lnRef idx="2">
-            <a:schemeClr val="accent1"/>
-          </a:lnRef>
-          <a:fillRef idx="0">
-            <a:schemeClr val="accent1"/>
-          </a:fillRef>
-          <a:effectRef idx="1">
-            <a:schemeClr val="accent1"/>
-          </a:effectRef>
-          <a:fontRef idx="minor">
-            <a:schemeClr val="tx1"/>
-          </a:fontRef>
-        </p:style>
-      </p:cxnSp>
-      <p:sp>
-        <p:nvSpPr>
-          <p:cNvPr id="4" name="TextBox 3"/>
-          <p:cNvSpPr txBox="1"/>
-          <p:nvPr/>
-        </p:nvSpPr>
-        <p:spPr>
-          <a:xfrm>
-            <a:off x="640080" y="1371600"/>
-            <a:ext cx="10972800" cy="4572000"/>
-          </a:xfrm>
-          <a:prstGeom prst="rect">
-            <a:avLst/>
-          </a:prstGeom>
-          <a:noFill/>
-        </p:spPr>
-        <p:txBody>
-          <a:bodyPr wrap="square">
-            <a:spAutoFit/>
-          </a:bodyPr>
-          <a:lstStyle/>
-          <a:p>
-            <a:pPr/>
-            <a:r>
-              <a:rPr sz="1600">
-                <a:solidFill>
-                  <a:srgbClr val="1A1A1A"/>
-                </a:solidFill>
-                <a:latin typeface="Calibri"/>
-              </a:rPr>
-              <a:t>•  Mechanism decomposition</a:t>
-            </a:r>
-          </a:p>
-          <a:p>
-            <a:pPr lvl="1"/>
-            <a:r>
-              <a:rPr sz="1300">
-                <a:solidFill>
-                  <a:srgbClr val="555555"/>
-                </a:solidFill>
-                <a:latin typeface="Calibri"/>
-              </a:rPr>
-              <a:t>–  Bring in supply-side data, service-capacity data, and outcome data to estimate the share of the jump attributable to each channel</a:t>
-            </a:r>
-          </a:p>
-          <a:p>
-            <a:pPr/>
-            <a:r>
-              <a:rPr sz="1600">
-                <a:solidFill>
-                  <a:srgbClr val="1A1A1A"/>
-                </a:solidFill>
-                <a:latin typeface="Calibri"/>
-              </a:rPr>
-              <a:t>•  Heterogeneity</a:t>
-            </a:r>
-          </a:p>
-          <a:p>
-            <a:pPr lvl="1"/>
-            <a:r>
-              <a:rPr sz="1300">
-                <a:solidFill>
-                  <a:srgbClr val="555555"/>
-                </a:solidFill>
-                <a:latin typeface="Calibri"/>
-              </a:rPr>
-              <a:t>–  Break the result down by age, sex, geographic zone, and substance type (fentanyl, carfentanil, other)</a:t>
-            </a:r>
-          </a:p>
-          <a:p>
-            <a:pPr/>
-            <a:r>
-              <a:rPr sz="1600">
-                <a:solidFill>
-                  <a:srgbClr val="1A1A1A"/>
-                </a:solidFill>
-                <a:latin typeface="Calibri"/>
-              </a:rPr>
-              <a:t>•  Post-period dynamics</a:t>
-            </a:r>
-          </a:p>
-          <a:p>
-            <a:pPr lvl="1"/>
-            <a:r>
-              <a:rPr sz="1300">
-                <a:solidFill>
-                  <a:srgbClr val="555555"/>
-                </a:solidFill>
-                <a:latin typeface="Calibri"/>
-              </a:rPr>
-              <a:t>–  Model the rise-to-peak-and-decline shape directly, rather than collapsing it into a single level shift</a:t>
-            </a:r>
-          </a:p>
-          <a:p>
-            <a:pPr/>
-            <a:r>
-              <a:rPr sz="1600">
-                <a:solidFill>
-                  <a:srgbClr val="1A1A1A"/>
-                </a:solidFill>
-                <a:latin typeface="Calibri"/>
-              </a:rPr>
-              <a:t>•  Cumulative excess deaths</a:t>
-            </a:r>
-          </a:p>
-          <a:p>
-            <a:pPr lvl="1"/>
-            <a:r>
-              <a:rPr sz="1300">
-                <a:solidFill>
-                  <a:srgbClr val="555555"/>
-                </a:solidFill>
-                <a:latin typeface="Calibri"/>
-              </a:rPr>
-              <a:t>–  Report a policy-relevant total alongside the immediate level shift</a:t>
-            </a:r>
-          </a:p>
-        </p:txBody>
-      </p:sp>
-      <p:sp>
-        <p:nvSpPr>
-          <p:cNvPr id="5" name="TextBox 4"/>
-          <p:cNvSpPr txBox="1"/>
-          <p:nvPr/>
-        </p:nvSpPr>
-        <p:spPr>
-          <a:xfrm>
-            <a:off x="548640" y="6446520"/>
-            <a:ext cx="10058400" cy="274320"/>
-          </a:xfrm>
-          <a:prstGeom prst="rect">
-            <a:avLst/>
-          </a:prstGeom>
-          <a:noFill/>
-        </p:spPr>
-        <p:txBody>
-          <a:bodyPr wrap="none">
-            <a:spAutoFit/>
-          </a:bodyPr>
-          <a:lstStyle/>
-          <a:p>
-            <a:r>
-              <a:rPr sz="900">
-                <a:solidFill>
-                  <a:srgbClr val="999999"/>
-                </a:solidFill>
-                <a:latin typeface="Calibri"/>
-              </a:rPr>
-              <a:t>Alberta opioid mortality around COVID-19  |  independent project</a:t>
-            </a:r>
-          </a:p>
-        </p:txBody>
-      </p:sp>
-      <p:sp>
-        <p:nvSpPr>
-          <p:cNvPr id="6" name="TextBox 5"/>
-          <p:cNvSpPr txBox="1"/>
-          <p:nvPr/>
-        </p:nvSpPr>
-        <p:spPr>
-          <a:xfrm>
-            <a:off x="11521440" y="6446520"/>
-            <a:ext cx="548640" cy="274320"/>
-          </a:xfrm>
-          <a:prstGeom prst="rect">
-            <a:avLst/>
-          </a:prstGeom>
-          <a:noFill/>
-        </p:spPr>
-        <p:txBody>
-          <a:bodyPr wrap="none">
-            <a:spAutoFit/>
-          </a:bodyPr>
-          <a:lstStyle/>
-          <a:p>
-            <a:pPr algn="r"/>
-            <a:r>
-              <a:rPr sz="1000">
-                <a:solidFill>
-                  <a:srgbClr val="999999"/>
-                </a:solidFill>
-                <a:latin typeface="Calibri"/>
-              </a:rPr>
-              <a:t>10</a:t>
-            </a:r>
-          </a:p>
-        </p:txBody>
-      </p:sp>
-    </p:spTree>
-  </p:cSld>
-  <p:clrMapOvr>
-    <a:masterClrMapping/>
-  </p:clrMapOvr>
-</p:sld>
-</file>
-
-<file path=ppt/slides/slide11.xml><?xml version="1.0" encoding="utf-8"?>
-<p:sld xmlns:a="http://schemas.openxmlformats.org/drawingml/2006/main" xmlns:p="http://schemas.openxmlformats.org/presentationml/2006/main" xmlns:r="http://schemas.openxmlformats.org/officeDocument/2006/relationships">
-  <p:cSld>
-    <p:spTree>
-      <p:nvGrpSpPr>
-        <p:cNvPr id="1" name=""/>
-        <p:cNvGrpSpPr/>
-        <p:nvPr/>
-      </p:nvGrpSpPr>
-      <p:grpSpPr/>
-      <p:sp>
-        <p:nvSpPr>
-          <p:cNvPr id="2" name="TextBox 1"/>
-          <p:cNvSpPr txBox="1"/>
-          <p:nvPr/>
-        </p:nvSpPr>
-        <p:spPr>
-          <a:xfrm>
-            <a:off x="548640" y="2926080"/>
-            <a:ext cx="11064240" cy="914400"/>
-          </a:xfrm>
-          <a:prstGeom prst="rect">
-            <a:avLst/>
-          </a:prstGeom>
-          <a:noFill/>
-        </p:spPr>
-        <p:txBody>
-          <a:bodyPr wrap="none">
-            <a:spAutoFit/>
-          </a:bodyPr>
-          <a:lstStyle/>
-          <a:p>
-            <a:pPr algn="ctr"/>
-            <a:r>
-              <a:rPr sz="5400" b="1">
-                <a:solidFill>
-                  <a:srgbClr val="000000"/>
-                </a:solidFill>
-                <a:latin typeface="Calibri"/>
-              </a:rPr>
-              <a:t>Questions?</a:t>
-            </a:r>
-          </a:p>
-        </p:txBody>
-      </p:sp>
-      <p:sp>
-        <p:nvSpPr>
-          <p:cNvPr id="3" name="TextBox 2"/>
-          <p:cNvSpPr txBox="1"/>
-          <p:nvPr/>
-        </p:nvSpPr>
-        <p:spPr>
-          <a:xfrm>
-            <a:off x="548640" y="4114800"/>
-            <a:ext cx="11064240" cy="457200"/>
-          </a:xfrm>
-          <a:prstGeom prst="rect">
-            <a:avLst/>
-          </a:prstGeom>
-          <a:noFill/>
-        </p:spPr>
-        <p:txBody>
-          <a:bodyPr wrap="none">
-            <a:spAutoFit/>
-          </a:bodyPr>
-          <a:lstStyle/>
-          <a:p>
-            <a:pPr algn="ctr"/>
-            <a:r>
-              <a:rPr sz="1400">
-                <a:solidFill>
-                  <a:srgbClr val="555555"/>
-                </a:solidFill>
-                <a:latin typeface="Calibri"/>
-              </a:rPr>
-              <a:t>Code, data, and full documentation: github.com/Adilbek123/alberta-substance-use-trends</a:t>
-            </a:r>
-          </a:p>
-        </p:txBody>
-      </p:sp>
-      <p:sp>
-        <p:nvSpPr>
-          <p:cNvPr id="4" name="TextBox 3"/>
-          <p:cNvSpPr txBox="1"/>
-          <p:nvPr/>
-        </p:nvSpPr>
-        <p:spPr>
-          <a:xfrm>
-            <a:off x="11521440" y="6446520"/>
-            <a:ext cx="548640" cy="274320"/>
-          </a:xfrm>
-          <a:prstGeom prst="rect">
-            <a:avLst/>
-          </a:prstGeom>
-          <a:noFill/>
-        </p:spPr>
-        <p:txBody>
-          <a:bodyPr wrap="none">
-            <a:spAutoFit/>
-          </a:bodyPr>
-          <a:lstStyle/>
-          <a:p>
-            <a:pPr algn="r"/>
-            <a:r>
-              <a:rPr sz="1000">
-                <a:solidFill>
-                  <a:srgbClr val="999999"/>
-                </a:solidFill>
-                <a:latin typeface="Calibri"/>
-              </a:rPr>
-              <a:t>11</a:t>
             </a:r>
           </a:p>
         </p:txBody>
@@ -3693,7 +3280,7 @@
         <p:spPr>
           <a:xfrm>
             <a:off x="548640" y="320040"/>
-            <a:ext cx="11064240" cy="640080"/>
+            <a:ext cx="11064240" cy="1005840"/>
           </a:xfrm>
           <a:prstGeom prst="rect">
             <a:avLst/>
@@ -3701,19 +3288,19 @@
           <a:noFill/>
         </p:spPr>
         <p:txBody>
-          <a:bodyPr wrap="none">
+          <a:bodyPr wrap="square">
             <a:spAutoFit/>
           </a:bodyPr>
           <a:lstStyle/>
           <a:p>
             <a:r>
-              <a:rPr sz="2600" b="1">
+              <a:rPr sz="2200" b="1">
                 <a:solidFill>
                   <a:srgbClr val="000000"/>
                 </a:solidFill>
                 <a:latin typeface="Calibri"/>
               </a:rPr>
-              <a:t>Question to be Answered</a:t>
+              <a:t>COVID-19 hit Alberta in March 2020, and many other things shifted at the same time</a:t>
             </a:r>
           </a:p>
         </p:txBody>
@@ -3726,7 +3313,7 @@
         </p:nvCxnSpPr>
         <p:spPr>
           <a:xfrm>
-            <a:off x="548640" y="960120"/>
+            <a:off x="548640" y="1325880"/>
             <a:ext cx="11064240" cy="0"/>
           </a:xfrm>
           <a:prstGeom prst="line">
@@ -3761,7 +3348,7 @@
         </p:nvSpPr>
         <p:spPr>
           <a:xfrm>
-            <a:off x="640080" y="1371600"/>
+            <a:off x="640080" y="1554480"/>
             <a:ext cx="10972800" cy="4572000"/>
           </a:xfrm>
           <a:prstGeom prst="rect">
@@ -3777,73 +3364,133 @@
           <a:p>
             <a:pPr/>
             <a:r>
-              <a:rPr sz="1700">
+              <a:rPr sz="1400">
                 <a:solidFill>
                   <a:srgbClr val="1A1A1A"/>
                 </a:solidFill>
                 <a:latin typeface="Calibri"/>
               </a:rPr>
-              <a:t>•  Did Alberta's opioid death rate shift sharply when COVID-19 hit, beyond what the prior trend explains?</a:t>
+              <a:t>•  COVID-19 was declared a pandemic by the WHO on 11 March 2020</a:t>
             </a:r>
           </a:p>
           <a:p>
             <a:pPr lvl="1"/>
             <a:r>
-              <a:rPr sz="1300">
+              <a:rPr sz="1200">
                 <a:solidFill>
                   <a:srgbClr val="555555"/>
                 </a:solidFill>
                 <a:latin typeface="Calibri"/>
               </a:rPr>
-              <a:t>–  Cutoff used: 2020 Q2, the first full quarter under Alberta's public health emergency</a:t>
+              <a:t>–  Alberta declared a public health emergency on 17 March 2020</a:t>
             </a:r>
           </a:p>
           <a:p>
             <a:pPr lvl="1"/>
             <a:r>
-              <a:rPr sz="1300">
+              <a:rPr sz="1200">
                 <a:solidFill>
                   <a:srgbClr val="555555"/>
                 </a:solidFill>
                 <a:latin typeface="Calibri"/>
               </a:rPr>
-              <a:t>–  Outcome: opioid-related deaths per 100,000 Alberta residents per quarter</a:t>
+              <a:t>–  Roughly 60,000 Canadians have died from COVID-19 directly between 2020 and 2023</a:t>
             </a:r>
           </a:p>
           <a:p>
             <a:pPr/>
             <a:r>
-              <a:rPr sz="1700">
+              <a:rPr sz="1400">
                 <a:solidFill>
                   <a:srgbClr val="1A1A1A"/>
                 </a:solidFill>
                 <a:latin typeface="Calibri"/>
               </a:rPr>
-              <a:t>•  Why this matters for Mental Health and Addiction work</a:t>
+              <a:t>•  Beyond the virus itself, the pandemic disrupted multiple systems at once</a:t>
             </a:r>
           </a:p>
           <a:p>
             <a:pPr lvl="1"/>
             <a:r>
-              <a:rPr sz="1300">
+              <a:rPr sz="1200">
                 <a:solidFill>
                   <a:srgbClr val="555555"/>
                 </a:solidFill>
                 <a:latin typeface="Calibri"/>
               </a:rPr>
-              <a:t>–  The post-COVID baseline shapes what we measure as 'success' under the Alberta Recovery Model</a:t>
+              <a:t>–  Drug supply chains for the unregulated drug market</a:t>
             </a:r>
           </a:p>
           <a:p>
             <a:pPr lvl="1"/>
             <a:r>
-              <a:rPr sz="1300">
+              <a:rPr sz="1200">
                 <a:solidFill>
                   <a:srgbClr val="555555"/>
                 </a:solidFill>
                 <a:latin typeface="Calibri"/>
               </a:rPr>
-              <a:t>–  Understanding the size of the shift is a prerequisite for any decomposition or follow-up policy work</a:t>
+              <a:t>–  Harm reduction services (e.g., supervised consumption sites operating at reduced capacity)</a:t>
+            </a:r>
+          </a:p>
+          <a:p>
+            <a:pPr lvl="1"/>
+            <a:r>
+              <a:rPr sz="1200">
+                <a:solidFill>
+                  <a:srgbClr val="555555"/>
+                </a:solidFill>
+                <a:latin typeface="Calibri"/>
+              </a:rPr>
+              <a:t>–  Mental health and addiction services (in-person care disruption, telehealth ramp-up lag)</a:t>
+            </a:r>
+          </a:p>
+          <a:p>
+            <a:pPr lvl="1"/>
+            <a:r>
+              <a:rPr sz="1200">
+                <a:solidFill>
+                  <a:srgbClr val="555555"/>
+                </a:solidFill>
+                <a:latin typeface="Calibri"/>
+              </a:rPr>
+              <a:t>–  Employment, housing, and social connection</a:t>
+            </a:r>
+          </a:p>
+          <a:p>
+            <a:pPr/>
+            <a:r>
+              <a:rPr sz="1400">
+                <a:solidFill>
+                  <a:srgbClr val="1A1A1A"/>
+                </a:solidFill>
+                <a:latin typeface="Calibri"/>
+              </a:rPr>
+              <a:t>•  Other provinces reported a surge in opioid deaths from 2020 onward</a:t>
+            </a:r>
+          </a:p>
+          <a:p>
+            <a:pPr lvl="1"/>
+            <a:r>
+              <a:rPr sz="1200">
+                <a:solidFill>
+                  <a:srgbClr val="555555"/>
+                </a:solidFill>
+                <a:latin typeface="Calibri"/>
+              </a:rPr>
+              <a:t>–  British Columbia, Ontario, and others saw sharp increases at roughly the same time</a:t>
+            </a:r>
+          </a:p>
+          <a:p>
+            <a:pPr lvl="1"/>
+            <a:r>
+              <a:rPr sz="1200">
+                <a:solidFill>
+                  <a:srgbClr val="555555"/>
+                </a:solidFill>
+                <a:latin typeface="Calibri"/>
+              </a:rPr>
+              <a:t>–  Alberta's pattern has not been quantified at this granularity in public analysis</a:t>
             </a:r>
           </a:p>
         </p:txBody>
@@ -3944,7 +3591,7 @@
         <p:spPr>
           <a:xfrm>
             <a:off x="548640" y="320040"/>
-            <a:ext cx="11064240" cy="640080"/>
+            <a:ext cx="11064240" cy="1005840"/>
           </a:xfrm>
           <a:prstGeom prst="rect">
             <a:avLst/>
@@ -3952,19 +3599,19 @@
           <a:noFill/>
         </p:spPr>
         <p:txBody>
-          <a:bodyPr wrap="none">
+          <a:bodyPr wrap="square">
             <a:spAutoFit/>
           </a:bodyPr>
           <a:lstStyle/>
           <a:p>
             <a:r>
-              <a:rPr sz="2600" b="1">
+              <a:rPr sz="2200" b="1">
                 <a:solidFill>
                   <a:srgbClr val="000000"/>
                 </a:solidFill>
                 <a:latin typeface="Calibri"/>
               </a:rPr>
-              <a:t>Background and Context</a:t>
+              <a:t>Did Alberta opioid mortality jump at the COVID onset, and is it real or noise?</a:t>
             </a:r>
           </a:p>
         </p:txBody>
@@ -3977,7 +3624,7 @@
         </p:nvCxnSpPr>
         <p:spPr>
           <a:xfrm>
-            <a:off x="548640" y="960120"/>
+            <a:off x="548640" y="1325880"/>
             <a:ext cx="11064240" cy="0"/>
           </a:xfrm>
           <a:prstGeom prst="line">
@@ -4012,7 +3659,7 @@
         </p:nvSpPr>
         <p:spPr>
           <a:xfrm>
-            <a:off x="640080" y="1371600"/>
+            <a:off x="640080" y="1554480"/>
             <a:ext cx="10972800" cy="4572000"/>
           </a:xfrm>
           <a:prstGeom prst="rect">
@@ -4028,85 +3675,109 @@
           <a:p>
             <a:pPr/>
             <a:r>
-              <a:rPr sz="1600">
+              <a:rPr sz="1400">
                 <a:solidFill>
                   <a:srgbClr val="1A1A1A"/>
                 </a:solidFill>
                 <a:latin typeface="Calibri"/>
               </a:rPr>
-              <a:t>•  Alberta opioid mortality from 2016 to early 2020</a:t>
+              <a:t>•  Pre-COVID context</a:t>
             </a:r>
           </a:p>
           <a:p>
             <a:pPr lvl="1"/>
             <a:r>
-              <a:rPr sz="1300">
+              <a:rPr sz="1200">
                 <a:solidFill>
                   <a:srgbClr val="555555"/>
                 </a:solidFill>
                 <a:latin typeface="Calibri"/>
               </a:rPr>
-              <a:t>–  Quarterly opioid death rate sat around 4 per 100,000</a:t>
+              <a:t>–  Alberta opioid death rate sat around 4 per 100,000 residents per quarter, 2016 through early 2020</a:t>
             </a:r>
           </a:p>
           <a:p>
             <a:pPr lvl="1"/>
             <a:r>
-              <a:rPr sz="1300">
+              <a:rPr sz="1200">
                 <a:solidFill>
                   <a:srgbClr val="555555"/>
                 </a:solidFill>
                 <a:latin typeface="Calibri"/>
               </a:rPr>
-              <a:t>–  Flat trend over the five years prior to COVID — no sustained rise or fall</a:t>
+              <a:t>–  Flat trend across that period, no sustained rise or fall</a:t>
             </a:r>
           </a:p>
           <a:p>
             <a:pPr/>
             <a:r>
-              <a:rPr sz="1600">
+              <a:rPr sz="1400">
                 <a:solidFill>
                   <a:srgbClr val="1A1A1A"/>
                 </a:solidFill>
                 <a:latin typeface="Calibri"/>
               </a:rPr>
-              <a:t>•  March 2020: Alberta declares a public health emergency</a:t>
+              <a:t>•  If a jump occurred at COVID, two things matter for policy</a:t>
             </a:r>
           </a:p>
           <a:p>
             <a:pPr lvl="1"/>
             <a:r>
-              <a:rPr sz="1300">
+              <a:rPr sz="1200">
                 <a:solidFill>
                   <a:srgbClr val="555555"/>
                 </a:solidFill>
                 <a:latin typeface="Calibri"/>
               </a:rPr>
-              <a:t>–  Many things changed at once — virus circulation, public health measures, harm reduction services, the unregulated drug supply, mental health services, social and economic conditions</a:t>
+              <a:t>–  How large was it? This sets the post-COVID baseline against which Recovery Model progress will be measured</a:t>
+            </a:r>
+          </a:p>
+          <a:p>
+            <a:pPr lvl="1"/>
+            <a:r>
+              <a:rPr sz="1200">
+                <a:solidFill>
+                  <a:srgbClr val="555555"/>
+                </a:solidFill>
+                <a:latin typeface="Calibri"/>
+              </a:rPr>
+              <a:t>–  Is it real, or could random variation in a noisy series explain it? This determines whether the change calls for action</a:t>
             </a:r>
           </a:p>
           <a:p>
             <a:pPr/>
             <a:r>
-              <a:rPr sz="1600">
+              <a:rPr sz="1400">
                 <a:solidFill>
                   <a:srgbClr val="1A1A1A"/>
                 </a:solidFill>
                 <a:latin typeface="Calibri"/>
               </a:rPr>
-              <a:t>•  Federal data shows opioid mortality rose sharply across Canada from 2020 onward</a:t>
+              <a:t>•  This analysis answers both questions</a:t>
             </a:r>
           </a:p>
           <a:p>
             <a:pPr lvl="1"/>
             <a:r>
-              <a:rPr sz="1300">
+              <a:rPr sz="1200">
                 <a:solidFill>
                   <a:srgbClr val="555555"/>
                 </a:solidFill>
                 <a:latin typeface="Calibri"/>
               </a:rPr>
-              <a:t>–  This analysis quantifies the Alberta-specific change at the cutoff</a:t>
+              <a:t>–  Whether the level shift exists at the cutoff, separately from the existing trend</a:t>
+            </a:r>
+          </a:p>
+          <a:p>
+            <a:pPr lvl="1"/>
+            <a:r>
+              <a:rPr sz="1200">
+                <a:solidFill>
+                  <a:srgbClr val="555555"/>
+                </a:solidFill>
+                <a:latin typeface="Calibri"/>
+              </a:rPr>
+              <a:t>–  Whether the size of the shift is meaningfully larger than what random variation could produce</a:t>
             </a:r>
           </a:p>
         </p:txBody>
@@ -4207,7 +3878,7 @@
         <p:spPr>
           <a:xfrm>
             <a:off x="548640" y="320040"/>
-            <a:ext cx="11064240" cy="640080"/>
+            <a:ext cx="11064240" cy="1005840"/>
           </a:xfrm>
           <a:prstGeom prst="rect">
             <a:avLst/>
@@ -4215,19 +3886,19 @@
           <a:noFill/>
         </p:spPr>
         <p:txBody>
-          <a:bodyPr wrap="none">
+          <a:bodyPr wrap="square">
             <a:spAutoFit/>
           </a:bodyPr>
           <a:lstStyle/>
           <a:p>
             <a:r>
-              <a:rPr sz="2600" b="1">
+              <a:rPr sz="2200" b="1">
                 <a:solidFill>
                   <a:srgbClr val="000000"/>
                 </a:solidFill>
                 <a:latin typeface="Calibri"/>
               </a:rPr>
-              <a:t>Approach</a:t>
+              <a:t>An interrupted time series compares the pre-COVID and post-COVID periods statistically</a:t>
             </a:r>
           </a:p>
         </p:txBody>
@@ -4240,7 +3911,7 @@
         </p:nvCxnSpPr>
         <p:spPr>
           <a:xfrm>
-            <a:off x="548640" y="960120"/>
+            <a:off x="548640" y="1325880"/>
             <a:ext cx="11064240" cy="0"/>
           </a:xfrm>
           <a:prstGeom prst="line">
@@ -4275,7 +3946,7 @@
         </p:nvSpPr>
         <p:spPr>
           <a:xfrm>
-            <a:off x="640080" y="1371600"/>
+            <a:off x="640080" y="1554480"/>
             <a:ext cx="10972800" cy="4572000"/>
           </a:xfrm>
           <a:prstGeom prst="rect">
@@ -4291,103 +3962,127 @@
           <a:p>
             <a:pPr/>
             <a:r>
-              <a:rPr sz="1600">
+              <a:rPr sz="1400">
                 <a:solidFill>
                   <a:srgbClr val="1A1A1A"/>
                 </a:solidFill>
                 <a:latin typeface="Calibri"/>
               </a:rPr>
-              <a:t>•  Interrupted time series</a:t>
+              <a:t>•  Method: interrupted time series (also called segmented regression)</a:t>
             </a:r>
           </a:p>
           <a:p>
             <a:pPr lvl="1"/>
             <a:r>
-              <a:rPr sz="1300">
+              <a:rPr sz="1200">
                 <a:solidFill>
                   <a:srgbClr val="555555"/>
                 </a:solidFill>
                 <a:latin typeface="Calibri"/>
               </a:rPr>
-              <a:t>–  Compare the trend in the years before the cutoff to the trend in the years after</a:t>
+              <a:t>–  Fits one trend to the pre-COVID years, another to the post-COVID years</a:t>
             </a:r>
           </a:p>
           <a:p>
             <a:pPr lvl="1"/>
             <a:r>
-              <a:rPr sz="1300">
+              <a:rPr sz="1200">
                 <a:solidFill>
                   <a:srgbClr val="555555"/>
                 </a:solidFill>
                 <a:latin typeface="Calibri"/>
               </a:rPr>
-              <a:t>–  Measure the gap between them at the cutoff itself</a:t>
+              <a:t>–  Measures the gap between them at the cutoff (2020 Q2, first full quarter under the emergency)</a:t>
+            </a:r>
+          </a:p>
+          <a:p>
+            <a:pPr lvl="1"/>
+            <a:r>
+              <a:rPr sz="1200">
+                <a:solidFill>
+                  <a:srgbClr val="555555"/>
+                </a:solidFill>
+                <a:latin typeface="Calibri"/>
+              </a:rPr>
+              <a:t>–  Tests whether that gap is meaningfully larger than the natural noise in the data</a:t>
             </a:r>
           </a:p>
           <a:p>
             <a:pPr/>
             <a:r>
-              <a:rPr sz="1600">
+              <a:rPr sz="1400">
                 <a:solidFill>
                   <a:srgbClr val="1A1A1A"/>
                 </a:solidFill>
                 <a:latin typeface="Calibri"/>
               </a:rPr>
-              <a:t>•  Adjustments to keep the comparison fair</a:t>
+              <a:t>•  Data</a:t>
             </a:r>
           </a:p>
           <a:p>
             <a:pPr lvl="1"/>
             <a:r>
-              <a:rPr sz="1300">
+              <a:rPr sz="1200">
                 <a:solidFill>
                   <a:srgbClr val="555555"/>
                 </a:solidFill>
                 <a:latin typeface="Calibri"/>
               </a:rPr>
-              <a:t>–  Use a rate per 100,000 residents (not raw counts), so population growth does not drive the result</a:t>
+              <a:t>–  Opioid deaths: Public Health Agency of Canada Health Infobase, Alberta quarterly, 2016 Q1 to 2025 Q3</a:t>
             </a:r>
           </a:p>
           <a:p>
             <a:pPr lvl="1"/>
             <a:r>
-              <a:rPr sz="1300">
+              <a:rPr sz="1200">
                 <a:solidFill>
                   <a:srgbClr val="555555"/>
                 </a:solidFill>
                 <a:latin typeface="Calibri"/>
               </a:rPr>
-              <a:t>–  Adjust for seasonality — opioid mortality has a predictable quarter-by-quarter pattern</a:t>
+              <a:t>–  Population: Statistics Canada Table 17-10-0009-01, used to convert counts to a rate per 100,000</a:t>
+            </a:r>
+          </a:p>
+          <a:p>
+            <a:pPr lvl="1"/>
+            <a:r>
+              <a:rPr sz="1200">
+                <a:solidFill>
+                  <a:srgbClr val="555555"/>
+                </a:solidFill>
+                <a:latin typeface="Calibri"/>
+              </a:rPr>
+              <a:t>–  No internal Government of Alberta data is used; all sources are public</a:t>
             </a:r>
           </a:p>
           <a:p>
             <a:pPr/>
             <a:r>
-              <a:rPr sz="1600">
+              <a:rPr sz="1400">
                 <a:solidFill>
                   <a:srgbClr val="1A1A1A"/>
                 </a:solidFill>
                 <a:latin typeface="Calibri"/>
               </a:rPr>
-              <a:t>•  Robustness checks to ensure the result is not fragile</a:t>
+              <a:t>•  Robustness checks confirm the result is not an artifact of method choices</a:t>
             </a:r>
           </a:p>
           <a:p>
             <a:pPr lvl="1"/>
             <a:r>
-              <a:rPr sz="1300">
+              <a:rPr sz="1200">
                 <a:solidFill>
                   <a:srgbClr val="555555"/>
                 </a:solidFill>
                 <a:latin typeface="Calibri"/>
               </a:rPr>
-              <a:t>–  Move the cutoff back into the pre-period as a placebo — should produce no jump</a:t>
+              <a:t>–  Placebo cutoffs placed in the pre-period (should produce no jump if the design is credible)</a:t>
             </a:r>
           </a:p>
           <a:p>
             <a:pPr lvl="1"/>
             <a:r>
-              <a:rPr sz="1300">
+              <a:rPr sz="1200">
                 <a:solidFill>
                   <a:srgbClr val="555555"/>
                 </a:solidFill>
@@ -4399,13 +4094,13 @@
           <a:p>
             <a:pPr lvl="1"/>
             <a:r>
-              <a:rPr sz="1300">
+              <a:rPr sz="1200">
                 <a:solidFill>
                   <a:srgbClr val="555555"/>
                 </a:solidFill>
                 <a:latin typeface="Calibri"/>
               </a:rPr>
-              <a:t>–  Re-fit using a count model with population offset as a cross-check</a:t>
+              <a:t>–  Cross-check using a count model with a population offset</a:t>
             </a:r>
           </a:p>
         </p:txBody>
@@ -4506,7 +4201,7 @@
         <p:spPr>
           <a:xfrm>
             <a:off x="548640" y="320040"/>
-            <a:ext cx="11064240" cy="640080"/>
+            <a:ext cx="11064240" cy="1005840"/>
           </a:xfrm>
           <a:prstGeom prst="rect">
             <a:avLst/>
@@ -4514,19 +4209,19 @@
           <a:noFill/>
         </p:spPr>
         <p:txBody>
-          <a:bodyPr wrap="none">
+          <a:bodyPr wrap="square">
             <a:spAutoFit/>
           </a:bodyPr>
           <a:lstStyle/>
           <a:p>
             <a:r>
-              <a:rPr sz="2600" b="1">
+              <a:rPr sz="2200" b="1">
                 <a:solidFill>
                   <a:srgbClr val="000000"/>
                 </a:solidFill>
                 <a:latin typeface="Calibri"/>
               </a:rPr>
-              <a:t>Data</a:t>
+              <a:t>The death rate roughly doubled at 2020 Q2, sharp, large, and robust</a:t>
             </a:r>
           </a:p>
         </p:txBody>
@@ -4539,282 +4234,7 @@
         </p:nvCxnSpPr>
         <p:spPr>
           <a:xfrm>
-            <a:off x="548640" y="960120"/>
-            <a:ext cx="11064240" cy="0"/>
-          </a:xfrm>
-          <a:prstGeom prst="line">
-            <a:avLst/>
-          </a:prstGeom>
-          <a:ln w="9525">
-            <a:solidFill>
-              <a:srgbClr val="000000"/>
-            </a:solidFill>
-          </a:ln>
-        </p:spPr>
-        <p:style>
-          <a:lnRef idx="2">
-            <a:schemeClr val="accent1"/>
-          </a:lnRef>
-          <a:fillRef idx="0">
-            <a:schemeClr val="accent1"/>
-          </a:fillRef>
-          <a:effectRef idx="1">
-            <a:schemeClr val="accent1"/>
-          </a:effectRef>
-          <a:fontRef idx="minor">
-            <a:schemeClr val="tx1"/>
-          </a:fontRef>
-        </p:style>
-      </p:cxnSp>
-      <p:sp>
-        <p:nvSpPr>
-          <p:cNvPr id="4" name="TextBox 3"/>
-          <p:cNvSpPr txBox="1"/>
-          <p:nvPr/>
-        </p:nvSpPr>
-        <p:spPr>
-          <a:xfrm>
-            <a:off x="640080" y="1371600"/>
-            <a:ext cx="10972800" cy="4572000"/>
-          </a:xfrm>
-          <a:prstGeom prst="rect">
-            <a:avLst/>
-          </a:prstGeom>
-          <a:noFill/>
-        </p:spPr>
-        <p:txBody>
-          <a:bodyPr wrap="square">
-            <a:spAutoFit/>
-          </a:bodyPr>
-          <a:lstStyle/>
-          <a:p>
-            <a:pPr/>
-            <a:r>
-              <a:rPr sz="1600">
-                <a:solidFill>
-                  <a:srgbClr val="1A1A1A"/>
-                </a:solidFill>
-                <a:latin typeface="Calibri"/>
-              </a:rPr>
-              <a:t>•  Public Health Agency of Canada — Substance-Related Harms Data</a:t>
-            </a:r>
-          </a:p>
-          <a:p>
-            <a:pPr lvl="1"/>
-            <a:r>
-              <a:rPr sz="1300">
-                <a:solidFill>
-                  <a:srgbClr val="555555"/>
-                </a:solidFill>
-                <a:latin typeface="Calibri"/>
-              </a:rPr>
-              <a:t>–  Quarterly opioid deaths in Alberta</a:t>
-            </a:r>
-          </a:p>
-          <a:p>
-            <a:pPr lvl="1"/>
-            <a:r>
-              <a:rPr sz="1300">
-                <a:solidFill>
-                  <a:srgbClr val="555555"/>
-                </a:solidFill>
-                <a:latin typeface="Calibri"/>
-              </a:rPr>
-              <a:t>–  2016 Q1 through 2025 Q3 — 39 quarters in total</a:t>
-            </a:r>
-          </a:p>
-          <a:p>
-            <a:pPr lvl="1"/>
-            <a:r>
-              <a:rPr sz="1300">
-                <a:solidFill>
-                  <a:srgbClr val="555555"/>
-                </a:solidFill>
-                <a:latin typeface="Calibri"/>
-              </a:rPr>
-              <a:t>–  Downloaded 20 May 2026 from health-infobase.canada.ca</a:t>
-            </a:r>
-          </a:p>
-          <a:p>
-            <a:pPr/>
-            <a:r>
-              <a:rPr sz="1600">
-                <a:solidFill>
-                  <a:srgbClr val="1A1A1A"/>
-                </a:solidFill>
-                <a:latin typeface="Calibri"/>
-              </a:rPr>
-              <a:t>•  Statistics Canada Table 17-10-0009-01 — Quarterly population estimates</a:t>
-            </a:r>
-          </a:p>
-          <a:p>
-            <a:pPr lvl="1"/>
-            <a:r>
-              <a:rPr sz="1300">
-                <a:solidFill>
-                  <a:srgbClr val="555555"/>
-                </a:solidFill>
-                <a:latin typeface="Calibri"/>
-              </a:rPr>
-              <a:t>–  Used to convert death counts into a rate per 100,000 residents</a:t>
-            </a:r>
-          </a:p>
-          <a:p>
-            <a:pPr/>
-            <a:r>
-              <a:rPr sz="1600">
-                <a:solidFill>
-                  <a:srgbClr val="1A1A1A"/>
-                </a:solidFill>
-                <a:latin typeface="Calibri"/>
-              </a:rPr>
-              <a:t>•  No internal Government of Alberta data used</a:t>
-            </a:r>
-          </a:p>
-          <a:p>
-            <a:pPr lvl="1"/>
-            <a:r>
-              <a:rPr sz="1300">
-                <a:solidFill>
-                  <a:srgbClr val="555555"/>
-                </a:solidFill>
-                <a:latin typeface="Calibri"/>
-              </a:rPr>
-              <a:t>–  All sources are public and reproducible</a:t>
-            </a:r>
-          </a:p>
-        </p:txBody>
-      </p:sp>
-      <p:sp>
-        <p:nvSpPr>
-          <p:cNvPr id="5" name="TextBox 4"/>
-          <p:cNvSpPr txBox="1"/>
-          <p:nvPr/>
-        </p:nvSpPr>
-        <p:spPr>
-          <a:xfrm>
-            <a:off x="548640" y="6446520"/>
-            <a:ext cx="10058400" cy="274320"/>
-          </a:xfrm>
-          <a:prstGeom prst="rect">
-            <a:avLst/>
-          </a:prstGeom>
-          <a:noFill/>
-        </p:spPr>
-        <p:txBody>
-          <a:bodyPr wrap="none">
-            <a:spAutoFit/>
-          </a:bodyPr>
-          <a:lstStyle/>
-          <a:p>
-            <a:r>
-              <a:rPr sz="900">
-                <a:solidFill>
-                  <a:srgbClr val="999999"/>
-                </a:solidFill>
-                <a:latin typeface="Calibri"/>
-              </a:rPr>
-              <a:t>Alberta opioid mortality around COVID-19  |  independent project</a:t>
-            </a:r>
-          </a:p>
-        </p:txBody>
-      </p:sp>
-      <p:sp>
-        <p:nvSpPr>
-          <p:cNvPr id="6" name="TextBox 5"/>
-          <p:cNvSpPr txBox="1"/>
-          <p:nvPr/>
-        </p:nvSpPr>
-        <p:spPr>
-          <a:xfrm>
-            <a:off x="11521440" y="6446520"/>
-            <a:ext cx="548640" cy="274320"/>
-          </a:xfrm>
-          <a:prstGeom prst="rect">
-            <a:avLst/>
-          </a:prstGeom>
-          <a:noFill/>
-        </p:spPr>
-        <p:txBody>
-          <a:bodyPr wrap="none">
-            <a:spAutoFit/>
-          </a:bodyPr>
-          <a:lstStyle/>
-          <a:p>
-            <a:pPr algn="r"/>
-            <a:r>
-              <a:rPr sz="1000">
-                <a:solidFill>
-                  <a:srgbClr val="999999"/>
-                </a:solidFill>
-                <a:latin typeface="Calibri"/>
-              </a:rPr>
-              <a:t>5</a:t>
-            </a:r>
-          </a:p>
-        </p:txBody>
-      </p:sp>
-    </p:spTree>
-  </p:cSld>
-  <p:clrMapOvr>
-    <a:masterClrMapping/>
-  </p:clrMapOvr>
-</p:sld>
-</file>
-
-<file path=ppt/slides/slide6.xml><?xml version="1.0" encoding="utf-8"?>
-<p:sld xmlns:a="http://schemas.openxmlformats.org/drawingml/2006/main" xmlns:p="http://schemas.openxmlformats.org/presentationml/2006/main" xmlns:r="http://schemas.openxmlformats.org/officeDocument/2006/relationships">
-  <p:cSld>
-    <p:spTree>
-      <p:nvGrpSpPr>
-        <p:cNvPr id="1" name=""/>
-        <p:cNvGrpSpPr/>
-        <p:nvPr/>
-      </p:nvGrpSpPr>
-      <p:grpSpPr/>
-      <p:sp>
-        <p:nvSpPr>
-          <p:cNvPr id="2" name="TextBox 1"/>
-          <p:cNvSpPr txBox="1"/>
-          <p:nvPr/>
-        </p:nvSpPr>
-        <p:spPr>
-          <a:xfrm>
-            <a:off x="548640" y="320040"/>
-            <a:ext cx="11064240" cy="640080"/>
-          </a:xfrm>
-          <a:prstGeom prst="rect">
-            <a:avLst/>
-          </a:prstGeom>
-          <a:noFill/>
-        </p:spPr>
-        <p:txBody>
-          <a:bodyPr wrap="none">
-            <a:spAutoFit/>
-          </a:bodyPr>
-          <a:lstStyle/>
-          <a:p>
-            <a:r>
-              <a:rPr sz="2600" b="1">
-                <a:solidFill>
-                  <a:srgbClr val="000000"/>
-                </a:solidFill>
-                <a:latin typeface="Calibri"/>
-              </a:rPr>
-              <a:t>Findings — A Sharp, Large, Persistent Increase</a:t>
-            </a:r>
-          </a:p>
-        </p:txBody>
-      </p:sp>
-      <p:cxnSp>
-        <p:nvCxnSpPr>
-          <p:cNvPr id="3" name="Connector 2"/>
-          <p:cNvCxnSpPr/>
-          <p:nvPr/>
-        </p:nvCxnSpPr>
-        <p:spPr>
-          <a:xfrm>
-            <a:off x="548640" y="960120"/>
+            <a:off x="548640" y="1325880"/>
             <a:ext cx="11064240" cy="0"/>
           </a:xfrm>
           <a:prstGeom prst="line">
@@ -4857,7 +4277,7 @@
         </p:blipFill>
         <p:spPr>
           <a:xfrm>
-            <a:off x="548640" y="1188720"/>
+            <a:off x="457200" y="1508760"/>
             <a:ext cx="7680960" cy="4649481"/>
           </a:xfrm>
           <a:prstGeom prst="rect">
@@ -4873,8 +4293,8 @@
         </p:nvSpPr>
         <p:spPr>
           <a:xfrm>
-            <a:off x="8412480" y="1280160"/>
-            <a:ext cx="3657600" cy="5029200"/>
+            <a:off x="8412480" y="1554480"/>
+            <a:ext cx="3657600" cy="4572000"/>
           </a:xfrm>
           <a:prstGeom prst="rect">
             <a:avLst/>
@@ -4889,7 +4309,7 @@
           <a:p>
             <a:pPr/>
             <a:r>
-              <a:rPr sz="1300">
+              <a:rPr sz="1200">
                 <a:solidFill>
                   <a:srgbClr val="1A1A1A"/>
                 </a:solidFill>
@@ -4901,7 +4321,7 @@
           <a:p>
             <a:pPr lvl="1"/>
             <a:r>
-              <a:rPr sz="1100">
+              <a:rPr sz="1000">
                 <a:solidFill>
                   <a:srgbClr val="555555"/>
                 </a:solidFill>
@@ -4913,7 +4333,7 @@
           <a:p>
             <a:pPr/>
             <a:r>
-              <a:rPr sz="1300">
+              <a:rPr sz="1200">
                 <a:solidFill>
                   <a:srgbClr val="1A1A1A"/>
                 </a:solidFill>
@@ -4925,7 +4345,7 @@
           <a:p>
             <a:pPr lvl="1"/>
             <a:r>
-              <a:rPr sz="1100">
+              <a:rPr sz="1000">
                 <a:solidFill>
                   <a:srgbClr val="555555"/>
                 </a:solidFill>
@@ -4937,19 +4357,19 @@
           <a:p>
             <a:pPr/>
             <a:r>
-              <a:rPr sz="1300">
+              <a:rPr sz="1200">
                 <a:solidFill>
                   <a:srgbClr val="1A1A1A"/>
                 </a:solidFill>
                 <a:latin typeface="Calibri"/>
               </a:rPr>
-              <a:t>•  Level shift at 2020 Q2</a:t>
+              <a:t>•  Level shift at the cutoff</a:t>
             </a:r>
           </a:p>
           <a:p>
             <a:pPr lvl="1"/>
             <a:r>
-              <a:rPr sz="1100">
+              <a:rPr sz="1000">
                 <a:solidFill>
                   <a:srgbClr val="555555"/>
                 </a:solidFill>
@@ -4961,31 +4381,31 @@
           <a:p>
             <a:pPr lvl="1"/>
             <a:r>
-              <a:rPr sz="1100">
+              <a:rPr sz="1000">
                 <a:solidFill>
                   <a:srgbClr val="555555"/>
                 </a:solidFill>
                 <a:latin typeface="Calibri"/>
               </a:rPr>
-              <a:t>–  Roughly a doubling of the rate</a:t>
+              <a:t>–  Roughly a doubling</a:t>
             </a:r>
           </a:p>
           <a:p>
             <a:pPr lvl="1"/>
             <a:r>
-              <a:rPr sz="1100">
+              <a:rPr sz="1000">
                 <a:solidFill>
                   <a:srgbClr val="555555"/>
                 </a:solidFill>
                 <a:latin typeface="Calibri"/>
               </a:rPr>
-              <a:t>–  Statistically very strong</a:t>
+              <a:t>–  Statistically very strong (p &lt; 0.001)</a:t>
             </a:r>
           </a:p>
           <a:p>
             <a:pPr/>
             <a:r>
-              <a:rPr sz="1300">
+              <a:rPr sz="1200">
                 <a:solidFill>
                   <a:srgbClr val="1A1A1A"/>
                 </a:solidFill>
@@ -4997,13 +4417,61 @@
           <a:p>
             <a:pPr lvl="1"/>
             <a:r>
-              <a:rPr sz="1100">
+              <a:rPr sz="1000">
                 <a:solidFill>
                   <a:srgbClr val="555555"/>
                 </a:solidFill>
                 <a:latin typeface="Calibri"/>
               </a:rPr>
-              <a:t>–  The jump is not a continuation of an existing trend</a:t>
+              <a:t>–  The jump is not part of an existing rise</a:t>
+            </a:r>
+          </a:p>
+          <a:p>
+            <a:pPr/>
+            <a:r>
+              <a:rPr sz="1200">
+                <a:solidFill>
+                  <a:srgbClr val="1A1A1A"/>
+                </a:solidFill>
+                <a:latin typeface="Calibri"/>
+              </a:rPr>
+              <a:t>•  All robustness checks hold</a:t>
+            </a:r>
+          </a:p>
+          <a:p>
+            <a:pPr lvl="1"/>
+            <a:r>
+              <a:rPr sz="1000">
+                <a:solidFill>
+                  <a:srgbClr val="555555"/>
+                </a:solidFill>
+                <a:latin typeface="Calibri"/>
+              </a:rPr>
+              <a:t>–  Placebos produce no jump</a:t>
+            </a:r>
+          </a:p>
+          <a:p>
+            <a:pPr lvl="1"/>
+            <a:r>
+              <a:rPr sz="1000">
+                <a:solidFill>
+                  <a:srgbClr val="555555"/>
+                </a:solidFill>
+                <a:latin typeface="Calibri"/>
+              </a:rPr>
+              <a:t>–  Drop-quarter estimate moves &lt;3%</a:t>
+            </a:r>
+          </a:p>
+          <a:p>
+            <a:pPr lvl="1"/>
+            <a:r>
+              <a:rPr sz="1000">
+                <a:solidFill>
+                  <a:srgbClr val="555555"/>
+                </a:solidFill>
+                <a:latin typeface="Calibri"/>
+              </a:rPr>
+              <a:t>–  Cross-check confirms</a:t>
             </a:r>
           </a:p>
         </p:txBody>
@@ -5045,6 +4513,293 @@
       <p:sp>
         <p:nvSpPr>
           <p:cNvPr id="7" name="TextBox 6"/>
+          <p:cNvSpPr txBox="1"/>
+          <p:nvPr/>
+        </p:nvSpPr>
+        <p:spPr>
+          <a:xfrm>
+            <a:off x="11521440" y="6446520"/>
+            <a:ext cx="548640" cy="274320"/>
+          </a:xfrm>
+          <a:prstGeom prst="rect">
+            <a:avLst/>
+          </a:prstGeom>
+          <a:noFill/>
+        </p:spPr>
+        <p:txBody>
+          <a:bodyPr wrap="none">
+            <a:spAutoFit/>
+          </a:bodyPr>
+          <a:lstStyle/>
+          <a:p>
+            <a:pPr algn="r"/>
+            <a:r>
+              <a:rPr sz="1000">
+                <a:solidFill>
+                  <a:srgbClr val="999999"/>
+                </a:solidFill>
+                <a:latin typeface="Calibri"/>
+              </a:rPr>
+              <a:t>5</a:t>
+            </a:r>
+          </a:p>
+        </p:txBody>
+      </p:sp>
+    </p:spTree>
+  </p:cSld>
+  <p:clrMapOvr>
+    <a:masterClrMapping/>
+  </p:clrMapOvr>
+</p:sld>
+</file>
+
+<file path=ppt/slides/slide6.xml><?xml version="1.0" encoding="utf-8"?>
+<p:sld xmlns:a="http://schemas.openxmlformats.org/drawingml/2006/main" xmlns:p="http://schemas.openxmlformats.org/presentationml/2006/main" xmlns:r="http://schemas.openxmlformats.org/officeDocument/2006/relationships">
+  <p:cSld>
+    <p:spTree>
+      <p:nvGrpSpPr>
+        <p:cNvPr id="1" name=""/>
+        <p:cNvGrpSpPr/>
+        <p:nvPr/>
+      </p:nvGrpSpPr>
+      <p:grpSpPr/>
+      <p:sp>
+        <p:nvSpPr>
+          <p:cNvPr id="2" name="TextBox 1"/>
+          <p:cNvSpPr txBox="1"/>
+          <p:nvPr/>
+        </p:nvSpPr>
+        <p:spPr>
+          <a:xfrm>
+            <a:off x="548640" y="320040"/>
+            <a:ext cx="11064240" cy="1005840"/>
+          </a:xfrm>
+          <a:prstGeom prst="rect">
+            <a:avLst/>
+          </a:prstGeom>
+          <a:noFill/>
+        </p:spPr>
+        <p:txBody>
+          <a:bodyPr wrap="square">
+            <a:spAutoFit/>
+          </a:bodyPr>
+          <a:lstStyle/>
+          <a:p>
+            <a:r>
+              <a:rPr sz="2200" b="1">
+                <a:solidFill>
+                  <a:srgbClr val="000000"/>
+                </a:solidFill>
+                <a:latin typeface="Calibri"/>
+              </a:rPr>
+              <a:t>The pandemic as a whole shifted opioid mortality, not the virus alone</a:t>
+            </a:r>
+          </a:p>
+        </p:txBody>
+      </p:sp>
+      <p:cxnSp>
+        <p:nvCxnSpPr>
+          <p:cNvPr id="3" name="Connector 2"/>
+          <p:cNvCxnSpPr/>
+          <p:nvPr/>
+        </p:nvCxnSpPr>
+        <p:spPr>
+          <a:xfrm>
+            <a:off x="548640" y="1325880"/>
+            <a:ext cx="11064240" cy="0"/>
+          </a:xfrm>
+          <a:prstGeom prst="line">
+            <a:avLst/>
+          </a:prstGeom>
+          <a:ln w="9525">
+            <a:solidFill>
+              <a:srgbClr val="000000"/>
+            </a:solidFill>
+          </a:ln>
+        </p:spPr>
+        <p:style>
+          <a:lnRef idx="2">
+            <a:schemeClr val="accent1"/>
+          </a:lnRef>
+          <a:fillRef idx="0">
+            <a:schemeClr val="accent1"/>
+          </a:fillRef>
+          <a:effectRef idx="1">
+            <a:schemeClr val="accent1"/>
+          </a:effectRef>
+          <a:fontRef idx="minor">
+            <a:schemeClr val="tx1"/>
+          </a:fontRef>
+        </p:style>
+      </p:cxnSp>
+      <p:sp>
+        <p:nvSpPr>
+          <p:cNvPr id="4" name="TextBox 3"/>
+          <p:cNvSpPr txBox="1"/>
+          <p:nvPr/>
+        </p:nvSpPr>
+        <p:spPr>
+          <a:xfrm>
+            <a:off x="640080" y="1554480"/>
+            <a:ext cx="10972800" cy="4572000"/>
+          </a:xfrm>
+          <a:prstGeom prst="rect">
+            <a:avLst/>
+          </a:prstGeom>
+          <a:noFill/>
+        </p:spPr>
+        <p:txBody>
+          <a:bodyPr wrap="square">
+            <a:spAutoFit/>
+          </a:bodyPr>
+          <a:lstStyle/>
+          <a:p>
+            <a:pPr/>
+            <a:r>
+              <a:rPr sz="1400">
+                <a:solidFill>
+                  <a:srgbClr val="1A1A1A"/>
+                </a:solidFill>
+                <a:latin typeface="Calibri"/>
+              </a:rPr>
+              <a:t>•  The total effect attributable to the pandemic, including its downstream consequences</a:t>
+            </a:r>
+          </a:p>
+          <a:p>
+            <a:pPr lvl="1"/>
+            <a:r>
+              <a:rPr sz="1200">
+                <a:solidFill>
+                  <a:srgbClr val="555555"/>
+                </a:solidFill>
+                <a:latin typeface="Calibri"/>
+              </a:rPr>
+              <a:t>–  Virus, public health measures, drug supply disruption, harm reduction capacity, mental health service disruption, isolation, economic shock</a:t>
+            </a:r>
+          </a:p>
+          <a:p>
+            <a:pPr lvl="1"/>
+            <a:r>
+              <a:rPr sz="1200">
+                <a:solidFill>
+                  <a:srgbClr val="555555"/>
+                </a:solidFill>
+                <a:latin typeface="Calibri"/>
+              </a:rPr>
+              <a:t>–  These came together by construction, not by coincidence; a pandemic without them is not a counterfactual that exists in any data</a:t>
+            </a:r>
+          </a:p>
+          <a:p>
+            <a:pPr/>
+            <a:r>
+              <a:rPr sz="1400">
+                <a:solidFill>
+                  <a:srgbClr val="1A1A1A"/>
+                </a:solidFill>
+                <a:latin typeface="Calibri"/>
+              </a:rPr>
+              <a:t>•  The analysis cannot separate which channel did the most damage</a:t>
+            </a:r>
+          </a:p>
+          <a:p>
+            <a:pPr lvl="1"/>
+            <a:r>
+              <a:rPr sz="1200">
+                <a:solidFill>
+                  <a:srgbClr val="555555"/>
+                </a:solidFill>
+                <a:latin typeface="Calibri"/>
+              </a:rPr>
+              <a:t>–  Decomposing into supply vs. services vs. isolation vs. economic shock requires different data</a:t>
+            </a:r>
+          </a:p>
+          <a:p>
+            <a:pPr lvl="1"/>
+            <a:r>
+              <a:rPr sz="1200">
+                <a:solidFill>
+                  <a:srgbClr val="555555"/>
+                </a:solidFill>
+                <a:latin typeface="Calibri"/>
+              </a:rPr>
+              <a:t>–  Drug-checking composition, service utilization series, and similar mechanism-level sources</a:t>
+            </a:r>
+          </a:p>
+          <a:p>
+            <a:pPr/>
+            <a:r>
+              <a:rPr sz="1400">
+                <a:solidFill>
+                  <a:srgbClr val="1A1A1A"/>
+                </a:solidFill>
+                <a:latin typeface="Calibri"/>
+              </a:rPr>
+              <a:t>•  Comparing Alberta to other provinces would not isolate a virus-only effect</a:t>
+            </a:r>
+          </a:p>
+          <a:p>
+            <a:pPr lvl="1"/>
+            <a:r>
+              <a:rPr sz="1200">
+                <a:solidFill>
+                  <a:srgbClr val="555555"/>
+                </a:solidFill>
+                <a:latin typeface="Calibri"/>
+              </a:rPr>
+              <a:t>–  Every Canadian province faced COVID and its policy response at essentially the same time</a:t>
+            </a:r>
+          </a:p>
+          <a:p>
+            <a:pPr lvl="1"/>
+            <a:r>
+              <a:rPr sz="1200">
+                <a:solidFill>
+                  <a:srgbClr val="555555"/>
+                </a:solidFill>
+                <a:latin typeface="Calibri"/>
+              </a:rPr>
+              <a:t>–  A peer comparison would identify Alberta-specific deviation from the common pattern, not the virus channel alone</a:t>
+            </a:r>
+          </a:p>
+        </p:txBody>
+      </p:sp>
+      <p:sp>
+        <p:nvSpPr>
+          <p:cNvPr id="5" name="TextBox 4"/>
+          <p:cNvSpPr txBox="1"/>
+          <p:nvPr/>
+        </p:nvSpPr>
+        <p:spPr>
+          <a:xfrm>
+            <a:off x="548640" y="6446520"/>
+            <a:ext cx="10058400" cy="274320"/>
+          </a:xfrm>
+          <a:prstGeom prst="rect">
+            <a:avLst/>
+          </a:prstGeom>
+          <a:noFill/>
+        </p:spPr>
+        <p:txBody>
+          <a:bodyPr wrap="none">
+            <a:spAutoFit/>
+          </a:bodyPr>
+          <a:lstStyle/>
+          <a:p>
+            <a:r>
+              <a:rPr sz="900">
+                <a:solidFill>
+                  <a:srgbClr val="999999"/>
+                </a:solidFill>
+                <a:latin typeface="Calibri"/>
+              </a:rPr>
+              <a:t>Alberta opioid mortality around COVID-19  |  independent project</a:t>
+            </a:r>
+          </a:p>
+        </p:txBody>
+      </p:sp>
+      <p:sp>
+        <p:nvSpPr>
+          <p:cNvPr id="6" name="TextBox 5"/>
           <p:cNvSpPr txBox="1"/>
           <p:nvPr/>
         </p:nvSpPr>
@@ -5104,7 +4859,7 @@
         <p:spPr>
           <a:xfrm>
             <a:off x="548640" y="320040"/>
-            <a:ext cx="11064240" cy="640080"/>
+            <a:ext cx="11064240" cy="1005840"/>
           </a:xfrm>
           <a:prstGeom prst="rect">
             <a:avLst/>
@@ -5112,19 +4867,19 @@
           <a:noFill/>
         </p:spPr>
         <p:txBody>
-          <a:bodyPr wrap="none">
+          <a:bodyPr wrap="square">
             <a:spAutoFit/>
           </a:bodyPr>
           <a:lstStyle/>
           <a:p>
             <a:r>
-              <a:rPr sz="2600" b="1">
+              <a:rPr sz="2200" b="1">
                 <a:solidFill>
                   <a:srgbClr val="000000"/>
                 </a:solidFill>
                 <a:latin typeface="Calibri"/>
               </a:rPr>
-              <a:t>Robustness — The Result Is Not Fragile</a:t>
+              <a:t>Post-COVID baseline is higher than pre-COVID, and recovery is already underway</a:t>
             </a:r>
           </a:p>
         </p:txBody>
@@ -5137,7 +4892,7 @@
         </p:nvCxnSpPr>
         <p:spPr>
           <a:xfrm>
-            <a:off x="548640" y="960120"/>
+            <a:off x="548640" y="1325880"/>
             <a:ext cx="11064240" cy="0"/>
           </a:xfrm>
           <a:prstGeom prst="line">
@@ -5172,7 +4927,7 @@
         </p:nvSpPr>
         <p:spPr>
           <a:xfrm>
-            <a:off x="640080" y="1371600"/>
+            <a:off x="640080" y="1554480"/>
             <a:ext cx="10972800" cy="4572000"/>
           </a:xfrm>
           <a:prstGeom prst="rect">
@@ -5188,109 +4943,133 @@
           <a:p>
             <a:pPr/>
             <a:r>
-              <a:rPr sz="1500">
+              <a:rPr sz="1400">
                 <a:solidFill>
                   <a:srgbClr val="1A1A1A"/>
                 </a:solidFill>
                 <a:latin typeface="Calibri"/>
               </a:rPr>
-              <a:t>•  Placebo cutoffs in the pre-period (2018–2019)</a:t>
+              <a:t>•  For Recovery Model performance measurement, the baseline matters</a:t>
             </a:r>
           </a:p>
           <a:p>
             <a:pPr lvl="1"/>
             <a:r>
-              <a:rPr sz="1300">
+              <a:rPr sz="1200">
                 <a:solidFill>
                   <a:srgbClr val="555555"/>
                 </a:solidFill>
                 <a:latin typeface="Calibri"/>
               </a:rPr>
-              <a:t>–  When we move the cutoff to a date before COVID, the model finds no comparable jump</a:t>
+              <a:t>–  The post-COVID baseline is roughly double the pre-COVID baseline</a:t>
             </a:r>
           </a:p>
           <a:p>
             <a:pPr lvl="1"/>
             <a:r>
-              <a:rPr sz="1300">
+              <a:rPr sz="1200">
                 <a:solidFill>
                   <a:srgbClr val="555555"/>
                 </a:solidFill>
                 <a:latin typeface="Calibri"/>
               </a:rPr>
-              <a:t>–  Largest placebo movement is about a third of the real jump, and in the opposite direction</a:t>
+              <a:t>–  Any 'return to baseline' framing needs to be explicit about which baseline</a:t>
             </a:r>
           </a:p>
           <a:p>
             <a:pPr/>
             <a:r>
-              <a:rPr sz="1500">
+              <a:rPr sz="1400">
                 <a:solidFill>
                   <a:srgbClr val="1A1A1A"/>
                 </a:solidFill>
                 <a:latin typeface="Calibri"/>
               </a:rPr>
-              <a:t>•  Dropping the quarter that straddles the cutoff (2020 Q1)</a:t>
+              <a:t>•  The trajectory is not flat: a real recovery is already visible</a:t>
             </a:r>
           </a:p>
           <a:p>
             <a:pPr lvl="1"/>
             <a:r>
-              <a:rPr sz="1300">
+              <a:rPr sz="1200">
                 <a:solidFill>
                   <a:srgbClr val="555555"/>
                 </a:solidFill>
                 <a:latin typeface="Calibri"/>
               </a:rPr>
-              <a:t>–  The estimate moves by less than three per cent</a:t>
+              <a:t>–  The post-COVID period peaked in 2021 Q4 and has been declining since 2024</a:t>
+            </a:r>
+          </a:p>
+          <a:p>
+            <a:pPr lvl="1"/>
+            <a:r>
+              <a:rPr sz="1200">
+                <a:solidFill>
+                  <a:srgbClr val="555555"/>
+                </a:solidFill>
+                <a:latin typeface="Calibri"/>
+              </a:rPr>
+              <a:t>–  A single average over the post-period masks this dynamic</a:t>
             </a:r>
           </a:p>
           <a:p>
             <a:pPr/>
             <a:r>
-              <a:rPr sz="1500">
+              <a:rPr sz="1400">
                 <a:solidFill>
                   <a:srgbClr val="1A1A1A"/>
                 </a:solidFill>
                 <a:latin typeface="Calibri"/>
               </a:rPr>
-              <a:t>•  Different statistical assumptions about standard errors</a:t>
+              <a:t>•  The next analytical work is decomposition, not better identification</a:t>
             </a:r>
           </a:p>
           <a:p>
             <a:pPr lvl="1"/>
             <a:r>
-              <a:rPr sz="1300">
+              <a:rPr sz="1200">
                 <a:solidFill>
                   <a:srgbClr val="555555"/>
                 </a:solidFill>
                 <a:latin typeface="Calibri"/>
               </a:rPr>
-              <a:t>–  The estimate is the same; the size of the confidence interval barely changes</a:t>
-            </a:r>
-          </a:p>
-          <a:p>
-            <a:pPr/>
-            <a:r>
-              <a:rPr sz="1500">
-                <a:solidFill>
-                  <a:srgbClr val="1A1A1A"/>
-                </a:solidFill>
-                <a:latin typeface="Calibri"/>
-              </a:rPr>
-              <a:t>•  A count-model cross-check</a:t>
+              <a:t>–  Which channel drove most of the shift (supply, services, isolation, economic)</a:t>
             </a:r>
           </a:p>
           <a:p>
             <a:pPr lvl="1"/>
             <a:r>
-              <a:rPr sz="1300">
+              <a:rPr sz="1200">
                 <a:solidFill>
                   <a:srgbClr val="555555"/>
                 </a:solidFill>
                 <a:latin typeface="Calibri"/>
               </a:rPr>
-              <a:t>–  The post-COVID rate is about 2.4× the pre-COVID rate, consistent with the main estimate</a:t>
+              <a:t>–  Which age groups, geographic zones, and substance types concentrate the increase</a:t>
+            </a:r>
+          </a:p>
+          <a:p>
+            <a:pPr lvl="1"/>
+            <a:r>
+              <a:rPr sz="1200">
+                <a:solidFill>
+                  <a:srgbClr val="555555"/>
+                </a:solidFill>
+                <a:latin typeface="Calibri"/>
+              </a:rPr>
+              <a:t>–  Modelling the rise-to-peak-and-decline shape directly, rather than a single level shift</a:t>
+            </a:r>
+          </a:p>
+          <a:p>
+            <a:pPr lvl="1"/>
+            <a:r>
+              <a:rPr sz="1200">
+                <a:solidFill>
+                  <a:srgbClr val="555555"/>
+                </a:solidFill>
+                <a:latin typeface="Calibri"/>
+              </a:rPr>
+              <a:t>–  Cumulative excess deaths through end-of-sample as a policy-relevant total</a:t>
             </a:r>
           </a:p>
         </p:txBody>
@@ -5360,532 +5139,6 @@
                 <a:latin typeface="Calibri"/>
               </a:rPr>
               <a:t>7</a:t>
-            </a:r>
-          </a:p>
-        </p:txBody>
-      </p:sp>
-    </p:spTree>
-  </p:cSld>
-  <p:clrMapOvr>
-    <a:masterClrMapping/>
-  </p:clrMapOvr>
-</p:sld>
-</file>
-
-<file path=ppt/slides/slide8.xml><?xml version="1.0" encoding="utf-8"?>
-<p:sld xmlns:a="http://schemas.openxmlformats.org/drawingml/2006/main" xmlns:p="http://schemas.openxmlformats.org/presentationml/2006/main" xmlns:r="http://schemas.openxmlformats.org/officeDocument/2006/relationships">
-  <p:cSld>
-    <p:spTree>
-      <p:nvGrpSpPr>
-        <p:cNvPr id="1" name=""/>
-        <p:cNvGrpSpPr/>
-        <p:nvPr/>
-      </p:nvGrpSpPr>
-      <p:grpSpPr/>
-      <p:sp>
-        <p:nvSpPr>
-          <p:cNvPr id="2" name="TextBox 1"/>
-          <p:cNvSpPr txBox="1"/>
-          <p:nvPr/>
-        </p:nvSpPr>
-        <p:spPr>
-          <a:xfrm>
-            <a:off x="548640" y="320040"/>
-            <a:ext cx="11064240" cy="640080"/>
-          </a:xfrm>
-          <a:prstGeom prst="rect">
-            <a:avLst/>
-          </a:prstGeom>
-          <a:noFill/>
-        </p:spPr>
-        <p:txBody>
-          <a:bodyPr wrap="none">
-            <a:spAutoFit/>
-          </a:bodyPr>
-          <a:lstStyle/>
-          <a:p>
-            <a:r>
-              <a:rPr sz="2600" b="1">
-                <a:solidFill>
-                  <a:srgbClr val="000000"/>
-                </a:solidFill>
-                <a:latin typeface="Calibri"/>
-              </a:rPr>
-              <a:t>What This Tells Us</a:t>
-            </a:r>
-          </a:p>
-        </p:txBody>
-      </p:sp>
-      <p:cxnSp>
-        <p:nvCxnSpPr>
-          <p:cNvPr id="3" name="Connector 2"/>
-          <p:cNvCxnSpPr/>
-          <p:nvPr/>
-        </p:nvCxnSpPr>
-        <p:spPr>
-          <a:xfrm>
-            <a:off x="548640" y="960120"/>
-            <a:ext cx="11064240" cy="0"/>
-          </a:xfrm>
-          <a:prstGeom prst="line">
-            <a:avLst/>
-          </a:prstGeom>
-          <a:ln w="9525">
-            <a:solidFill>
-              <a:srgbClr val="000000"/>
-            </a:solidFill>
-          </a:ln>
-        </p:spPr>
-        <p:style>
-          <a:lnRef idx="2">
-            <a:schemeClr val="accent1"/>
-          </a:lnRef>
-          <a:fillRef idx="0">
-            <a:schemeClr val="accent1"/>
-          </a:fillRef>
-          <a:effectRef idx="1">
-            <a:schemeClr val="accent1"/>
-          </a:effectRef>
-          <a:fontRef idx="minor">
-            <a:schemeClr val="tx1"/>
-          </a:fontRef>
-        </p:style>
-      </p:cxnSp>
-      <p:sp>
-        <p:nvSpPr>
-          <p:cNvPr id="4" name="TextBox 3"/>
-          <p:cNvSpPr txBox="1"/>
-          <p:nvPr/>
-        </p:nvSpPr>
-        <p:spPr>
-          <a:xfrm>
-            <a:off x="640080" y="1371600"/>
-            <a:ext cx="10972800" cy="4572000"/>
-          </a:xfrm>
-          <a:prstGeom prst="rect">
-            <a:avLst/>
-          </a:prstGeom>
-          <a:noFill/>
-        </p:spPr>
-        <p:txBody>
-          <a:bodyPr wrap="square">
-            <a:spAutoFit/>
-          </a:bodyPr>
-          <a:lstStyle/>
-          <a:p>
-            <a:pPr/>
-            <a:r>
-              <a:rPr sz="1600">
-                <a:solidFill>
-                  <a:srgbClr val="1A1A1A"/>
-                </a:solidFill>
-                <a:latin typeface="Calibri"/>
-              </a:rPr>
-              <a:t>•  There is a real, sharp, sustained change in Alberta opioid mortality at the COVID onset</a:t>
-            </a:r>
-          </a:p>
-          <a:p>
-            <a:pPr lvl="1"/>
-            <a:r>
-              <a:rPr sz="1300">
-                <a:solidFill>
-                  <a:srgbClr val="555555"/>
-                </a:solidFill>
-                <a:latin typeface="Calibri"/>
-              </a:rPr>
-              <a:t>–  Roughly a doubling of the rate, holding pre-trend and seasonality constant</a:t>
-            </a:r>
-          </a:p>
-          <a:p>
-            <a:pPr lvl="1"/>
-            <a:r>
-              <a:rPr sz="1300">
-                <a:solidFill>
-                  <a:srgbClr val="555555"/>
-                </a:solidFill>
-                <a:latin typeface="Calibri"/>
-              </a:rPr>
-              <a:t>–  The change is large enough to persist for years, with the rate only returning toward baseline since 2024</a:t>
-            </a:r>
-          </a:p>
-          <a:p>
-            <a:pPr/>
-            <a:r>
-              <a:rPr sz="1600">
-                <a:solidFill>
-                  <a:srgbClr val="1A1A1A"/>
-                </a:solidFill>
-                <a:latin typeface="Calibri"/>
-              </a:rPr>
-              <a:t>•  The change is attributable to the COVID-19 pandemic broadly</a:t>
-            </a:r>
-          </a:p>
-          <a:p>
-            <a:pPr lvl="1"/>
-            <a:r>
-              <a:rPr sz="1300">
-                <a:solidFill>
-                  <a:srgbClr val="555555"/>
-                </a:solidFill>
-                <a:latin typeface="Calibri"/>
-              </a:rPr>
-              <a:t>–  This includes the virus, public health measures, supply chain disruption, harm reduction service changes, mental health service disruption, social isolation, and economic shock</a:t>
-            </a:r>
-          </a:p>
-          <a:p>
-            <a:pPr lvl="1"/>
-            <a:r>
-              <a:rPr sz="1300">
-                <a:solidFill>
-                  <a:srgbClr val="555555"/>
-                </a:solidFill>
-                <a:latin typeface="Calibri"/>
-              </a:rPr>
-              <a:t>–  These are all downstream consequences of the pandemic — they came together by construction, not by coincidence</a:t>
-            </a:r>
-          </a:p>
-        </p:txBody>
-      </p:sp>
-      <p:sp>
-        <p:nvSpPr>
-          <p:cNvPr id="5" name="TextBox 4"/>
-          <p:cNvSpPr txBox="1"/>
-          <p:nvPr/>
-        </p:nvSpPr>
-        <p:spPr>
-          <a:xfrm>
-            <a:off x="548640" y="6446520"/>
-            <a:ext cx="10058400" cy="274320"/>
-          </a:xfrm>
-          <a:prstGeom prst="rect">
-            <a:avLst/>
-          </a:prstGeom>
-          <a:noFill/>
-        </p:spPr>
-        <p:txBody>
-          <a:bodyPr wrap="none">
-            <a:spAutoFit/>
-          </a:bodyPr>
-          <a:lstStyle/>
-          <a:p>
-            <a:r>
-              <a:rPr sz="900">
-                <a:solidFill>
-                  <a:srgbClr val="999999"/>
-                </a:solidFill>
-                <a:latin typeface="Calibri"/>
-              </a:rPr>
-              <a:t>Alberta opioid mortality around COVID-19  |  independent project</a:t>
-            </a:r>
-          </a:p>
-        </p:txBody>
-      </p:sp>
-      <p:sp>
-        <p:nvSpPr>
-          <p:cNvPr id="6" name="TextBox 5"/>
-          <p:cNvSpPr txBox="1"/>
-          <p:nvPr/>
-        </p:nvSpPr>
-        <p:spPr>
-          <a:xfrm>
-            <a:off x="11521440" y="6446520"/>
-            <a:ext cx="548640" cy="274320"/>
-          </a:xfrm>
-          <a:prstGeom prst="rect">
-            <a:avLst/>
-          </a:prstGeom>
-          <a:noFill/>
-        </p:spPr>
-        <p:txBody>
-          <a:bodyPr wrap="none">
-            <a:spAutoFit/>
-          </a:bodyPr>
-          <a:lstStyle/>
-          <a:p>
-            <a:pPr algn="r"/>
-            <a:r>
-              <a:rPr sz="1000">
-                <a:solidFill>
-                  <a:srgbClr val="999999"/>
-                </a:solidFill>
-                <a:latin typeface="Calibri"/>
-              </a:rPr>
-              <a:t>8</a:t>
-            </a:r>
-          </a:p>
-        </p:txBody>
-      </p:sp>
-    </p:spTree>
-  </p:cSld>
-  <p:clrMapOvr>
-    <a:masterClrMapping/>
-  </p:clrMapOvr>
-</p:sld>
-</file>
-
-<file path=ppt/slides/slide9.xml><?xml version="1.0" encoding="utf-8"?>
-<p:sld xmlns:a="http://schemas.openxmlformats.org/drawingml/2006/main" xmlns:p="http://schemas.openxmlformats.org/presentationml/2006/main" xmlns:r="http://schemas.openxmlformats.org/officeDocument/2006/relationships">
-  <p:cSld>
-    <p:spTree>
-      <p:nvGrpSpPr>
-        <p:cNvPr id="1" name=""/>
-        <p:cNvGrpSpPr/>
-        <p:nvPr/>
-      </p:nvGrpSpPr>
-      <p:grpSpPr/>
-      <p:sp>
-        <p:nvSpPr>
-          <p:cNvPr id="2" name="TextBox 1"/>
-          <p:cNvSpPr txBox="1"/>
-          <p:nvPr/>
-        </p:nvSpPr>
-        <p:spPr>
-          <a:xfrm>
-            <a:off x="548640" y="320040"/>
-            <a:ext cx="11064240" cy="640080"/>
-          </a:xfrm>
-          <a:prstGeom prst="rect">
-            <a:avLst/>
-          </a:prstGeom>
-          <a:noFill/>
-        </p:spPr>
-        <p:txBody>
-          <a:bodyPr wrap="none">
-            <a:spAutoFit/>
-          </a:bodyPr>
-          <a:lstStyle/>
-          <a:p>
-            <a:r>
-              <a:rPr sz="2600" b="1">
-                <a:solidFill>
-                  <a:srgbClr val="000000"/>
-                </a:solidFill>
-                <a:latin typeface="Calibri"/>
-              </a:rPr>
-              <a:t>What This Does Not Tell Us</a:t>
-            </a:r>
-          </a:p>
-        </p:txBody>
-      </p:sp>
-      <p:cxnSp>
-        <p:nvCxnSpPr>
-          <p:cNvPr id="3" name="Connector 2"/>
-          <p:cNvCxnSpPr/>
-          <p:nvPr/>
-        </p:nvCxnSpPr>
-        <p:spPr>
-          <a:xfrm>
-            <a:off x="548640" y="960120"/>
-            <a:ext cx="11064240" cy="0"/>
-          </a:xfrm>
-          <a:prstGeom prst="line">
-            <a:avLst/>
-          </a:prstGeom>
-          <a:ln w="9525">
-            <a:solidFill>
-              <a:srgbClr val="000000"/>
-            </a:solidFill>
-          </a:ln>
-        </p:spPr>
-        <p:style>
-          <a:lnRef idx="2">
-            <a:schemeClr val="accent1"/>
-          </a:lnRef>
-          <a:fillRef idx="0">
-            <a:schemeClr val="accent1"/>
-          </a:fillRef>
-          <a:effectRef idx="1">
-            <a:schemeClr val="accent1"/>
-          </a:effectRef>
-          <a:fontRef idx="minor">
-            <a:schemeClr val="tx1"/>
-          </a:fontRef>
-        </p:style>
-      </p:cxnSp>
-      <p:sp>
-        <p:nvSpPr>
-          <p:cNvPr id="4" name="TextBox 3"/>
-          <p:cNvSpPr txBox="1"/>
-          <p:nvPr/>
-        </p:nvSpPr>
-        <p:spPr>
-          <a:xfrm>
-            <a:off x="640080" y="1371600"/>
-            <a:ext cx="10972800" cy="4572000"/>
-          </a:xfrm>
-          <a:prstGeom prst="rect">
-            <a:avLst/>
-          </a:prstGeom>
-          <a:noFill/>
-        </p:spPr>
-        <p:txBody>
-          <a:bodyPr wrap="square">
-            <a:spAutoFit/>
-          </a:bodyPr>
-          <a:lstStyle/>
-          <a:p>
-            <a:pPr/>
-            <a:r>
-              <a:rPr sz="1500">
-                <a:solidFill>
-                  <a:srgbClr val="1A1A1A"/>
-                </a:solidFill>
-                <a:latin typeface="Calibri"/>
-              </a:rPr>
-              <a:t>•  We cannot separate the virus channel from everything else that came with the pandemic</a:t>
-            </a:r>
-          </a:p>
-          <a:p>
-            <a:pPr lvl="1"/>
-            <a:r>
-              <a:rPr sz="1300">
-                <a:solidFill>
-                  <a:srgbClr val="555555"/>
-                </a:solidFill>
-                <a:latin typeface="Calibri"/>
-              </a:rPr>
-              <a:t>–  What share came from supply toxicity vs. service capacity vs. isolation vs. economic shock is a separate question</a:t>
-            </a:r>
-          </a:p>
-          <a:p>
-            <a:pPr lvl="1"/>
-            <a:r>
-              <a:rPr sz="1300">
-                <a:solidFill>
-                  <a:srgbClr val="555555"/>
-                </a:solidFill>
-                <a:latin typeface="Calibri"/>
-              </a:rPr>
-              <a:t>–  Answering it needs different data — drug-checking composition, service utilization, etc.</a:t>
-            </a:r>
-          </a:p>
-          <a:p>
-            <a:pPr/>
-            <a:r>
-              <a:rPr sz="1500">
-                <a:solidFill>
-                  <a:srgbClr val="1A1A1A"/>
-                </a:solidFill>
-                <a:latin typeface="Calibri"/>
-              </a:rPr>
-              <a:t>•  A peer-province comparison would not isolate a clean 'COVID-only' effect</a:t>
-            </a:r>
-          </a:p>
-          <a:p>
-            <a:pPr lvl="1"/>
-            <a:r>
-              <a:rPr sz="1300">
-                <a:solidFill>
-                  <a:srgbClr val="555555"/>
-                </a:solidFill>
-                <a:latin typeface="Calibri"/>
-              </a:rPr>
-              <a:t>–  All Canadian provinces faced COVID and its policy response at essentially the same time</a:t>
-            </a:r>
-          </a:p>
-          <a:p>
-            <a:pPr lvl="1"/>
-            <a:r>
-              <a:rPr sz="1300">
-                <a:solidFill>
-                  <a:srgbClr val="555555"/>
-                </a:solidFill>
-                <a:latin typeface="Calibri"/>
-              </a:rPr>
-              <a:t>–  Comparing Alberta to BC or Ontario would identify Alberta-specific deviation, not the virus channel alone</a:t>
-            </a:r>
-          </a:p>
-          <a:p>
-            <a:pPr/>
-            <a:r>
-              <a:rPr sz="1500">
-                <a:solidFill>
-                  <a:srgbClr val="1A1A1A"/>
-                </a:solidFill>
-                <a:latin typeface="Calibri"/>
-              </a:rPr>
-              <a:t>•  The estimate captures the level shift at the cutoff, not the full trajectory</a:t>
-            </a:r>
-          </a:p>
-          <a:p>
-            <a:pPr lvl="1"/>
-            <a:r>
-              <a:rPr sz="1300">
-                <a:solidFill>
-                  <a:srgbClr val="555555"/>
-                </a:solidFill>
-                <a:latin typeface="Calibri"/>
-              </a:rPr>
-              <a:t>–  The post-COVID period peaked in 2021 Q4 and has been declining since 2024 — the average effect varies year by year</a:t>
-            </a:r>
-          </a:p>
-        </p:txBody>
-      </p:sp>
-      <p:sp>
-        <p:nvSpPr>
-          <p:cNvPr id="5" name="TextBox 4"/>
-          <p:cNvSpPr txBox="1"/>
-          <p:nvPr/>
-        </p:nvSpPr>
-        <p:spPr>
-          <a:xfrm>
-            <a:off x="548640" y="6446520"/>
-            <a:ext cx="10058400" cy="274320"/>
-          </a:xfrm>
-          <a:prstGeom prst="rect">
-            <a:avLst/>
-          </a:prstGeom>
-          <a:noFill/>
-        </p:spPr>
-        <p:txBody>
-          <a:bodyPr wrap="none">
-            <a:spAutoFit/>
-          </a:bodyPr>
-          <a:lstStyle/>
-          <a:p>
-            <a:r>
-              <a:rPr sz="900">
-                <a:solidFill>
-                  <a:srgbClr val="999999"/>
-                </a:solidFill>
-                <a:latin typeface="Calibri"/>
-              </a:rPr>
-              <a:t>Alberta opioid mortality around COVID-19  |  independent project</a:t>
-            </a:r>
-          </a:p>
-        </p:txBody>
-      </p:sp>
-      <p:sp>
-        <p:nvSpPr>
-          <p:cNvPr id="6" name="TextBox 5"/>
-          <p:cNvSpPr txBox="1"/>
-          <p:nvPr/>
-        </p:nvSpPr>
-        <p:spPr>
-          <a:xfrm>
-            <a:off x="11521440" y="6446520"/>
-            <a:ext cx="548640" cy="274320"/>
-          </a:xfrm>
-          <a:prstGeom prst="rect">
-            <a:avLst/>
-          </a:prstGeom>
-          <a:noFill/>
-        </p:spPr>
-        <p:txBody>
-          <a:bodyPr wrap="none">
-            <a:spAutoFit/>
-          </a:bodyPr>
-          <a:lstStyle/>
-          <a:p>
-            <a:pPr algn="r"/>
-            <a:r>
-              <a:rPr sz="1000">
-                <a:solidFill>
-                  <a:srgbClr val="999999"/>
-                </a:solidFill>
-                <a:latin typeface="Calibri"/>
-              </a:rPr>
-              <a:t>9</a:t>
             </a:r>
           </a:p>
         </p:txBody>

</xml_diff>

<commit_message>
Rebuild deck in GoA Cabinet format (Issue/Purpose/Background/Approach/Findings/Discussion/Limitations); verify all external facts; soften unverifiable claims
</commit_message>
<xml_diff>
--- a/slides.pptx
+++ b/slides.pptx
@@ -12,6 +12,7 @@
     <p:sldId id="260" r:id="rId11"/>
     <p:sldId id="261" r:id="rId12"/>
     <p:sldId id="262" r:id="rId13"/>
+    <p:sldId id="263" r:id="rId14"/>
   </p:sldIdLst>
   <p:sldSz cx="12188952" cy="6858000" type="screen4x3"/>
   <p:notesSz cx="6858000" cy="9144000"/>
@@ -3123,7 +3124,7 @@
                 </a:solidFill>
                 <a:latin typeface="Calibri"/>
               </a:rPr>
-              <a:t>Alberta opioid mortality around the COVID-19 onset</a:t>
+              <a:t>Alberta Opioid Mortality Around the COVID-19 Onset</a:t>
             </a:r>
           </a:p>
         </p:txBody>
@@ -3157,7 +3158,7 @@
                 </a:solidFill>
                 <a:latin typeface="Calibri"/>
               </a:rPr>
-              <a:t>An interrupted time series analysis using federal data</a:t>
+              <a:t>Interrupted Time Series Analysis Using Federal Data</a:t>
             </a:r>
           </a:p>
         </p:txBody>
@@ -3280,7 +3281,7 @@
         <p:spPr>
           <a:xfrm>
             <a:off x="548640" y="320040"/>
-            <a:ext cx="11064240" cy="1005840"/>
+            <a:ext cx="11064240" cy="640080"/>
           </a:xfrm>
           <a:prstGeom prst="rect">
             <a:avLst/>
@@ -3288,19 +3289,19 @@
           <a:noFill/>
         </p:spPr>
         <p:txBody>
-          <a:bodyPr wrap="square">
+          <a:bodyPr wrap="none">
             <a:spAutoFit/>
           </a:bodyPr>
           <a:lstStyle/>
           <a:p>
             <a:r>
-              <a:rPr sz="2200" b="1">
+              <a:rPr sz="2600" b="1">
                 <a:solidFill>
                   <a:srgbClr val="000000"/>
                 </a:solidFill>
                 <a:latin typeface="Calibri"/>
               </a:rPr>
-              <a:t>COVID-19 hit Alberta in March 2020, and many other things shifted at the same time</a:t>
+              <a:t>Issue</a:t>
             </a:r>
           </a:p>
         </p:txBody>
@@ -3313,7 +3314,7 @@
         </p:nvCxnSpPr>
         <p:spPr>
           <a:xfrm>
-            <a:off x="548640" y="1325880"/>
+            <a:off x="548640" y="960120"/>
             <a:ext cx="11064240" cy="0"/>
           </a:xfrm>
           <a:prstGeom prst="line">
@@ -3348,7 +3349,7 @@
         </p:nvSpPr>
         <p:spPr>
           <a:xfrm>
-            <a:off x="640080" y="1554480"/>
+            <a:off x="640080" y="1371600"/>
             <a:ext cx="10972800" cy="4572000"/>
           </a:xfrm>
           <a:prstGeom prst="rect">
@@ -3364,133 +3365,37 @@
           <a:p>
             <a:pPr/>
             <a:r>
-              <a:rPr sz="1400">
+              <a:rPr sz="1600">
                 <a:solidFill>
                   <a:srgbClr val="1A1A1A"/>
                 </a:solidFill>
                 <a:latin typeface="Calibri"/>
               </a:rPr>
-              <a:t>•  COVID-19 was declared a pandemic by the WHO on 11 March 2020</a:t>
-            </a:r>
-          </a:p>
-          <a:p>
-            <a:pPr lvl="1"/>
-            <a:r>
-              <a:rPr sz="1200">
-                <a:solidFill>
-                  <a:srgbClr val="555555"/>
-                </a:solidFill>
-                <a:latin typeface="Calibri"/>
-              </a:rPr>
-              <a:t>–  Alberta declared a public health emergency on 17 March 2020</a:t>
-            </a:r>
-          </a:p>
-          <a:p>
-            <a:pPr lvl="1"/>
-            <a:r>
-              <a:rPr sz="1200">
-                <a:solidFill>
-                  <a:srgbClr val="555555"/>
-                </a:solidFill>
-                <a:latin typeface="Calibri"/>
-              </a:rPr>
-              <a:t>–  Roughly 60,000 Canadians have died from COVID-19 directly between 2020 and 2023</a:t>
+              <a:t>•  Opioid mortality in Alberta has risen sharply since the start of the COVID-19 pandemic, but the size and timing of the shift have not been quantified for this analysis at quarterly resolution.</a:t>
             </a:r>
           </a:p>
           <a:p>
             <a:pPr/>
             <a:r>
-              <a:rPr sz="1400">
+              <a:rPr sz="1600">
                 <a:solidFill>
                   <a:srgbClr val="1A1A1A"/>
                 </a:solidFill>
                 <a:latin typeface="Calibri"/>
               </a:rPr>
-              <a:t>•  Beyond the virus itself, the pandemic disrupted multiple systems at once</a:t>
-            </a:r>
-          </a:p>
-          <a:p>
-            <a:pPr lvl="1"/>
-            <a:r>
-              <a:rPr sz="1200">
-                <a:solidFill>
-                  <a:srgbClr val="555555"/>
-                </a:solidFill>
-                <a:latin typeface="Calibri"/>
-              </a:rPr>
-              <a:t>–  Drug supply chains for the unregulated drug market</a:t>
-            </a:r>
-          </a:p>
-          <a:p>
-            <a:pPr lvl="1"/>
-            <a:r>
-              <a:rPr sz="1200">
-                <a:solidFill>
-                  <a:srgbClr val="555555"/>
-                </a:solidFill>
-                <a:latin typeface="Calibri"/>
-              </a:rPr>
-              <a:t>–  Harm reduction services (e.g., supervised consumption sites operating at reduced capacity)</a:t>
-            </a:r>
-          </a:p>
-          <a:p>
-            <a:pPr lvl="1"/>
-            <a:r>
-              <a:rPr sz="1200">
-                <a:solidFill>
-                  <a:srgbClr val="555555"/>
-                </a:solidFill>
-                <a:latin typeface="Calibri"/>
-              </a:rPr>
-              <a:t>–  Mental health and addiction services (in-person care disruption, telehealth ramp-up lag)</a:t>
-            </a:r>
-          </a:p>
-          <a:p>
-            <a:pPr lvl="1"/>
-            <a:r>
-              <a:rPr sz="1200">
-                <a:solidFill>
-                  <a:srgbClr val="555555"/>
-                </a:solidFill>
-                <a:latin typeface="Calibri"/>
-              </a:rPr>
-              <a:t>–  Employment, housing, and social connection</a:t>
+              <a:t>•  Without a defensible measurement of the post-COVID baseline, performance under the Alberta Recovery Model cannot be evaluated against a meaningful counterfactual.</a:t>
             </a:r>
           </a:p>
           <a:p>
             <a:pPr/>
             <a:r>
-              <a:rPr sz="1400">
+              <a:rPr sz="1600">
                 <a:solidFill>
                   <a:srgbClr val="1A1A1A"/>
                 </a:solidFill>
                 <a:latin typeface="Calibri"/>
               </a:rPr>
-              <a:t>•  Other provinces reported a surge in opioid deaths from 2020 onward</a:t>
-            </a:r>
-          </a:p>
-          <a:p>
-            <a:pPr lvl="1"/>
-            <a:r>
-              <a:rPr sz="1200">
-                <a:solidFill>
-                  <a:srgbClr val="555555"/>
-                </a:solidFill>
-                <a:latin typeface="Calibri"/>
-              </a:rPr>
-              <a:t>–  British Columbia, Ontario, and others saw sharp increases at roughly the same time</a:t>
-            </a:r>
-          </a:p>
-          <a:p>
-            <a:pPr lvl="1"/>
-            <a:r>
-              <a:rPr sz="1200">
-                <a:solidFill>
-                  <a:srgbClr val="555555"/>
-                </a:solidFill>
-                <a:latin typeface="Calibri"/>
-              </a:rPr>
-              <a:t>–  Alberta's pattern has not been quantified at this granularity in public analysis</a:t>
+              <a:t>•  This analysis quantifies the level shift at the COVID onset using publicly available federal data, and tests whether the shift is statistically meaningful or could be explained by random variation in a noisy series.</a:t>
             </a:r>
           </a:p>
         </p:txBody>
@@ -3591,7 +3496,7 @@
         <p:spPr>
           <a:xfrm>
             <a:off x="548640" y="320040"/>
-            <a:ext cx="11064240" cy="1005840"/>
+            <a:ext cx="11064240" cy="640080"/>
           </a:xfrm>
           <a:prstGeom prst="rect">
             <a:avLst/>
@@ -3599,19 +3504,19 @@
           <a:noFill/>
         </p:spPr>
         <p:txBody>
-          <a:bodyPr wrap="square">
+          <a:bodyPr wrap="none">
             <a:spAutoFit/>
           </a:bodyPr>
           <a:lstStyle/>
           <a:p>
             <a:r>
-              <a:rPr sz="2200" b="1">
+              <a:rPr sz="2600" b="1">
                 <a:solidFill>
                   <a:srgbClr val="000000"/>
                 </a:solidFill>
                 <a:latin typeface="Calibri"/>
               </a:rPr>
-              <a:t>Did Alberta opioid mortality jump at the COVID onset, and is it real or noise?</a:t>
+              <a:t>Purpose</a:t>
             </a:r>
           </a:p>
         </p:txBody>
@@ -3624,7 +3529,7 @@
         </p:nvCxnSpPr>
         <p:spPr>
           <a:xfrm>
-            <a:off x="548640" y="1325880"/>
+            <a:off x="548640" y="960120"/>
             <a:ext cx="11064240" cy="0"/>
           </a:xfrm>
           <a:prstGeom prst="line">
@@ -3659,7 +3564,7 @@
         </p:nvSpPr>
         <p:spPr>
           <a:xfrm>
-            <a:off x="640080" y="1554480"/>
+            <a:off x="640080" y="1371600"/>
             <a:ext cx="10972800" cy="4572000"/>
           </a:xfrm>
           <a:prstGeom prst="rect">
@@ -3675,13 +3580,13 @@
           <a:p>
             <a:pPr/>
             <a:r>
-              <a:rPr sz="1400">
+              <a:rPr sz="1500">
                 <a:solidFill>
                   <a:srgbClr val="1A1A1A"/>
                 </a:solidFill>
                 <a:latin typeface="Calibri"/>
               </a:rPr>
-              <a:t>•  Pre-COVID context</a:t>
+              <a:t>•  Establish whether Alberta's opioid death rate shifted at the COVID-19 onset</a:t>
             </a:r>
           </a:p>
           <a:p>
@@ -3693,7 +3598,7 @@
                 </a:solidFill>
                 <a:latin typeface="Calibri"/>
               </a:rPr>
-              <a:t>–  Alberta opioid death rate sat around 4 per 100,000 residents per quarter, 2016 through early 2020</a:t>
+              <a:t>–  Identify the size of the shift, if any</a:t>
             </a:r>
           </a:p>
           <a:p>
@@ -3705,19 +3610,19 @@
                 </a:solidFill>
                 <a:latin typeface="Calibri"/>
               </a:rPr>
-              <a:t>–  Flat trend across that period, no sustained rise or fall</a:t>
+              <a:t>–  Test whether the shift is meaningfully larger than the natural noise in the data</a:t>
             </a:r>
           </a:p>
           <a:p>
             <a:pPr/>
             <a:r>
-              <a:rPr sz="1400">
+              <a:rPr sz="1500">
                 <a:solidFill>
                   <a:srgbClr val="1A1A1A"/>
                 </a:solidFill>
                 <a:latin typeface="Calibri"/>
               </a:rPr>
-              <a:t>•  If a jump occurred at COVID, two things matter for policy</a:t>
+              <a:t>•  Inform the post-COVID baseline used for Recovery Model performance measurement</a:t>
             </a:r>
           </a:p>
           <a:p>
@@ -3729,7 +3634,7 @@
                 </a:solidFill>
                 <a:latin typeface="Calibri"/>
               </a:rPr>
-              <a:t>–  How large was it? This sets the post-COVID baseline against which Recovery Model progress will be measured</a:t>
+              <a:t>–  The baseline before the pandemic is materially different from the baseline after</a:t>
             </a:r>
           </a:p>
           <a:p>
@@ -3741,19 +3646,19 @@
                 </a:solidFill>
                 <a:latin typeface="Calibri"/>
               </a:rPr>
-              <a:t>–  Is it real, or could random variation in a noisy series explain it? This determines whether the change calls for action</a:t>
+              <a:t>–  Any performance framing needs to be explicit about which baseline it compares to</a:t>
             </a:r>
           </a:p>
           <a:p>
             <a:pPr/>
             <a:r>
-              <a:rPr sz="1400">
+              <a:rPr sz="1500">
                 <a:solidFill>
                   <a:srgbClr val="1A1A1A"/>
                 </a:solidFill>
                 <a:latin typeface="Calibri"/>
               </a:rPr>
-              <a:t>•  This analysis answers both questions</a:t>
+              <a:t>•  Demonstrate an analytical approach the Ministry's Business Intelligence team could apply to other indicators</a:t>
             </a:r>
           </a:p>
           <a:p>
@@ -3765,7 +3670,7 @@
                 </a:solidFill>
                 <a:latin typeface="Calibri"/>
               </a:rPr>
-              <a:t>–  Whether the level shift exists at the cutoff, separately from the existing trend</a:t>
+              <a:t>–  The same method applies to hospitalization, emergency department, and EMS data</a:t>
             </a:r>
           </a:p>
           <a:p>
@@ -3777,7 +3682,7 @@
                 </a:solidFill>
                 <a:latin typeface="Calibri"/>
               </a:rPr>
-              <a:t>–  Whether the size of the shift is meaningfully larger than what random variation could produce</a:t>
+              <a:t>–  Same data source, same code structure, different outcome variable</a:t>
             </a:r>
           </a:p>
         </p:txBody>
@@ -3878,7 +3783,7 @@
         <p:spPr>
           <a:xfrm>
             <a:off x="548640" y="320040"/>
-            <a:ext cx="11064240" cy="1005840"/>
+            <a:ext cx="11064240" cy="640080"/>
           </a:xfrm>
           <a:prstGeom prst="rect">
             <a:avLst/>
@@ -3886,19 +3791,19 @@
           <a:noFill/>
         </p:spPr>
         <p:txBody>
-          <a:bodyPr wrap="square">
+          <a:bodyPr wrap="none">
             <a:spAutoFit/>
           </a:bodyPr>
           <a:lstStyle/>
           <a:p>
             <a:r>
-              <a:rPr sz="2200" b="1">
+              <a:rPr sz="2600" b="1">
                 <a:solidFill>
                   <a:srgbClr val="000000"/>
                 </a:solidFill>
                 <a:latin typeface="Calibri"/>
               </a:rPr>
-              <a:t>An interrupted time series compares the pre-COVID and post-COVID periods statistically</a:t>
+              <a:t>Background</a:t>
             </a:r>
           </a:p>
         </p:txBody>
@@ -3911,7 +3816,7 @@
         </p:nvCxnSpPr>
         <p:spPr>
           <a:xfrm>
-            <a:off x="548640" y="1325880"/>
+            <a:off x="548640" y="960120"/>
             <a:ext cx="11064240" cy="0"/>
           </a:xfrm>
           <a:prstGeom prst="line">
@@ -3946,7 +3851,7 @@
         </p:nvSpPr>
         <p:spPr>
           <a:xfrm>
-            <a:off x="640080" y="1554480"/>
+            <a:off x="640080" y="1371600"/>
             <a:ext cx="10972800" cy="4572000"/>
           </a:xfrm>
           <a:prstGeom prst="rect">
@@ -3968,7 +3873,7 @@
                 </a:solidFill>
                 <a:latin typeface="Calibri"/>
               </a:rPr>
-              <a:t>•  Method: interrupted time series (also called segmented regression)</a:t>
+              <a:t>•  COVID-19 pandemic context</a:t>
             </a:r>
           </a:p>
           <a:p>
@@ -3980,7 +3885,7 @@
                 </a:solidFill>
                 <a:latin typeface="Calibri"/>
               </a:rPr>
-              <a:t>–  Fits one trend to the pre-COVID years, another to the post-COVID years</a:t>
+              <a:t>–  WHO characterized COVID-19 as a pandemic on 11 March 2020</a:t>
             </a:r>
           </a:p>
           <a:p>
@@ -3992,7 +3897,7 @@
                 </a:solidFill>
                 <a:latin typeface="Calibri"/>
               </a:rPr>
-              <a:t>–  Measures the gap between them at the cutoff (2020 Q2, first full quarter under the emergency)</a:t>
+              <a:t>–  Alberta declared a provincial public health emergency on 17 March 2020</a:t>
             </a:r>
           </a:p>
           <a:p>
@@ -4004,7 +3909,7 @@
                 </a:solidFill>
                 <a:latin typeface="Calibri"/>
               </a:rPr>
-              <a:t>–  Tests whether that gap is meaningfully larger than the natural noise in the data</a:t>
+              <a:t>–  Approximately 60,000 Canadians have died from the virus directly through 2024</a:t>
             </a:r>
           </a:p>
           <a:p>
@@ -4016,7 +3921,7 @@
                 </a:solidFill>
                 <a:latin typeface="Calibri"/>
               </a:rPr>
-              <a:t>•  Data</a:t>
+              <a:t>•  Beyond the virus itself, the pandemic disrupted several systems at once</a:t>
             </a:r>
           </a:p>
           <a:p>
@@ -4028,7 +3933,7 @@
                 </a:solidFill>
                 <a:latin typeface="Calibri"/>
               </a:rPr>
-              <a:t>–  Opioid deaths: Public Health Agency of Canada Health Infobase, Alberta quarterly, 2016 Q1 to 2025 Q3</a:t>
+              <a:t>–  Drug supply chains for the unregulated drug market</a:t>
             </a:r>
           </a:p>
           <a:p>
@@ -4040,7 +3945,7 @@
                 </a:solidFill>
                 <a:latin typeface="Calibri"/>
               </a:rPr>
-              <a:t>–  Population: Statistics Canada Table 17-10-0009-01, used to convert counts to a rate per 100,000</a:t>
+              <a:t>–  Harm reduction service delivery (in-person service capacity, hours, access)</a:t>
             </a:r>
           </a:p>
           <a:p>
@@ -4052,7 +3957,19 @@
                 </a:solidFill>
                 <a:latin typeface="Calibri"/>
               </a:rPr>
-              <a:t>–  No internal Government of Alberta data is used; all sources are public</a:t>
+              <a:t>–  Mental health and addiction service delivery (in-person care disruption)</a:t>
+            </a:r>
+          </a:p>
+          <a:p>
+            <a:pPr lvl="1"/>
+            <a:r>
+              <a:rPr sz="1200">
+                <a:solidFill>
+                  <a:srgbClr val="555555"/>
+                </a:solidFill>
+                <a:latin typeface="Calibri"/>
+              </a:rPr>
+              <a:t>–  Employment, housing, and social connection</a:t>
             </a:r>
           </a:p>
           <a:p>
@@ -4064,7 +3981,7 @@
                 </a:solidFill>
                 <a:latin typeface="Calibri"/>
               </a:rPr>
-              <a:t>•  Robustness checks confirm the result is not an artifact of method choices</a:t>
+              <a:t>•  Other provinces reported a substantial increase in opioid mortality starting 2020 Q2</a:t>
             </a:r>
           </a:p>
           <a:p>
@@ -4076,7 +3993,7 @@
                 </a:solidFill>
                 <a:latin typeface="Calibri"/>
               </a:rPr>
-              <a:t>–  Placebo cutoffs placed in the pre-period (should produce no jump if the design is credible)</a:t>
+              <a:t>–  British Columbia: quarterly opioid deaths roughly doubled (2019 average vs 2020 Q2 to 2021 Q1)</a:t>
             </a:r>
           </a:p>
           <a:p>
@@ -4088,7 +4005,7 @@
                 </a:solidFill>
                 <a:latin typeface="Calibri"/>
               </a:rPr>
-              <a:t>–  Drop the quarter that straddles the cutoff and refit</a:t>
+              <a:t>–  Ontario: quarterly opioid deaths rose by roughly 75 per cent over the same comparison</a:t>
             </a:r>
           </a:p>
           <a:p>
@@ -4100,7 +4017,7 @@
                 </a:solidFill>
                 <a:latin typeface="Calibri"/>
               </a:rPr>
-              <a:t>–  Cross-check using a count model with a population offset</a:t>
+              <a:t>–  Federal data (PHAC) confirms a Canada-wide pattern at the same cutoff</a:t>
             </a:r>
           </a:p>
         </p:txBody>
@@ -4201,7 +4118,7 @@
         <p:spPr>
           <a:xfrm>
             <a:off x="548640" y="320040"/>
-            <a:ext cx="11064240" cy="1005840"/>
+            <a:ext cx="11064240" cy="640080"/>
           </a:xfrm>
           <a:prstGeom prst="rect">
             <a:avLst/>
@@ -4209,19 +4126,19 @@
           <a:noFill/>
         </p:spPr>
         <p:txBody>
-          <a:bodyPr wrap="square">
+          <a:bodyPr wrap="none">
             <a:spAutoFit/>
           </a:bodyPr>
           <a:lstStyle/>
           <a:p>
             <a:r>
-              <a:rPr sz="2200" b="1">
+              <a:rPr sz="2600" b="1">
                 <a:solidFill>
                   <a:srgbClr val="000000"/>
                 </a:solidFill>
                 <a:latin typeface="Calibri"/>
               </a:rPr>
-              <a:t>The death rate roughly doubled at 2020 Q2, sharp, large, and robust</a:t>
+              <a:t>Approach</a:t>
             </a:r>
           </a:p>
         </p:txBody>
@@ -4234,7 +4151,330 @@
         </p:nvCxnSpPr>
         <p:spPr>
           <a:xfrm>
-            <a:off x="548640" y="1325880"/>
+            <a:off x="548640" y="960120"/>
+            <a:ext cx="11064240" cy="0"/>
+          </a:xfrm>
+          <a:prstGeom prst="line">
+            <a:avLst/>
+          </a:prstGeom>
+          <a:ln w="9525">
+            <a:solidFill>
+              <a:srgbClr val="000000"/>
+            </a:solidFill>
+          </a:ln>
+        </p:spPr>
+        <p:style>
+          <a:lnRef idx="2">
+            <a:schemeClr val="accent1"/>
+          </a:lnRef>
+          <a:fillRef idx="0">
+            <a:schemeClr val="accent1"/>
+          </a:fillRef>
+          <a:effectRef idx="1">
+            <a:schemeClr val="accent1"/>
+          </a:effectRef>
+          <a:fontRef idx="minor">
+            <a:schemeClr val="tx1"/>
+          </a:fontRef>
+        </p:style>
+      </p:cxnSp>
+      <p:sp>
+        <p:nvSpPr>
+          <p:cNvPr id="4" name="TextBox 3"/>
+          <p:cNvSpPr txBox="1"/>
+          <p:nvPr/>
+        </p:nvSpPr>
+        <p:spPr>
+          <a:xfrm>
+            <a:off x="640080" y="1371600"/>
+            <a:ext cx="10972800" cy="4572000"/>
+          </a:xfrm>
+          <a:prstGeom prst="rect">
+            <a:avLst/>
+          </a:prstGeom>
+          <a:noFill/>
+        </p:spPr>
+        <p:txBody>
+          <a:bodyPr wrap="square">
+            <a:spAutoFit/>
+          </a:bodyPr>
+          <a:lstStyle/>
+          <a:p>
+            <a:pPr/>
+            <a:r>
+              <a:rPr sz="1400">
+                <a:solidFill>
+                  <a:srgbClr val="1A1A1A"/>
+                </a:solidFill>
+                <a:latin typeface="Calibri"/>
+              </a:rPr>
+              <a:t>•  Method: interrupted time series (segmented regression)</a:t>
+            </a:r>
+          </a:p>
+          <a:p>
+            <a:pPr lvl="1"/>
+            <a:r>
+              <a:rPr sz="1200">
+                <a:solidFill>
+                  <a:srgbClr val="555555"/>
+                </a:solidFill>
+                <a:latin typeface="Calibri"/>
+              </a:rPr>
+              <a:t>–  Fits one trend to the pre-COVID years, another to the post-COVID years</a:t>
+            </a:r>
+          </a:p>
+          <a:p>
+            <a:pPr lvl="1"/>
+            <a:r>
+              <a:rPr sz="1200">
+                <a:solidFill>
+                  <a:srgbClr val="555555"/>
+                </a:solidFill>
+                <a:latin typeface="Calibri"/>
+              </a:rPr>
+              <a:t>–  Measures the gap between them at the cutoff (2020 Q2, first full quarter under the emergency)</a:t>
+            </a:r>
+          </a:p>
+          <a:p>
+            <a:pPr lvl="1"/>
+            <a:r>
+              <a:rPr sz="1200">
+                <a:solidFill>
+                  <a:srgbClr val="555555"/>
+                </a:solidFill>
+                <a:latin typeface="Calibri"/>
+              </a:rPr>
+              <a:t>–  Tests whether that gap is meaningfully larger than the natural noise in the data</a:t>
+            </a:r>
+          </a:p>
+          <a:p>
+            <a:pPr/>
+            <a:r>
+              <a:rPr sz="1400">
+                <a:solidFill>
+                  <a:srgbClr val="1A1A1A"/>
+                </a:solidFill>
+                <a:latin typeface="Calibri"/>
+              </a:rPr>
+              <a:t>•  Data</a:t>
+            </a:r>
+          </a:p>
+          <a:p>
+            <a:pPr lvl="1"/>
+            <a:r>
+              <a:rPr sz="1200">
+                <a:solidFill>
+                  <a:srgbClr val="555555"/>
+                </a:solidFill>
+                <a:latin typeface="Calibri"/>
+              </a:rPr>
+              <a:t>–  Opioid deaths: Public Health Agency of Canada, Health Infobase, Alberta quarterly, 2016 Q1 to 2025 Q3</a:t>
+            </a:r>
+          </a:p>
+          <a:p>
+            <a:pPr lvl="1"/>
+            <a:r>
+              <a:rPr sz="1200">
+                <a:solidFill>
+                  <a:srgbClr val="555555"/>
+                </a:solidFill>
+                <a:latin typeface="Calibri"/>
+              </a:rPr>
+              <a:t>–  Population: Statistics Canada Table 17-10-0009-01, used to convert counts to a rate per 100,000</a:t>
+            </a:r>
+          </a:p>
+          <a:p>
+            <a:pPr lvl="1"/>
+            <a:r>
+              <a:rPr sz="1200">
+                <a:solidFill>
+                  <a:srgbClr val="555555"/>
+                </a:solidFill>
+                <a:latin typeface="Calibri"/>
+              </a:rPr>
+              <a:t>–  No internal Government of Alberta data is used; all sources are public</a:t>
+            </a:r>
+          </a:p>
+          <a:p>
+            <a:pPr/>
+            <a:r>
+              <a:rPr sz="1400">
+                <a:solidFill>
+                  <a:srgbClr val="1A1A1A"/>
+                </a:solidFill>
+                <a:latin typeface="Calibri"/>
+              </a:rPr>
+              <a:t>•  Robustness checks confirm the result is not an artefact of method choices</a:t>
+            </a:r>
+          </a:p>
+          <a:p>
+            <a:pPr lvl="1"/>
+            <a:r>
+              <a:rPr sz="1200">
+                <a:solidFill>
+                  <a:srgbClr val="555555"/>
+                </a:solidFill>
+                <a:latin typeface="Calibri"/>
+              </a:rPr>
+              <a:t>–  Placebo cutoffs placed in the pre-period (should produce no jump if the design is credible)</a:t>
+            </a:r>
+          </a:p>
+          <a:p>
+            <a:pPr lvl="1"/>
+            <a:r>
+              <a:rPr sz="1200">
+                <a:solidFill>
+                  <a:srgbClr val="555555"/>
+                </a:solidFill>
+                <a:latin typeface="Calibri"/>
+              </a:rPr>
+              <a:t>–  Drop the quarter that straddles the cutoff and refit</a:t>
+            </a:r>
+          </a:p>
+          <a:p>
+            <a:pPr lvl="1"/>
+            <a:r>
+              <a:rPr sz="1200">
+                <a:solidFill>
+                  <a:srgbClr val="555555"/>
+                </a:solidFill>
+                <a:latin typeface="Calibri"/>
+              </a:rPr>
+              <a:t>–  Cross-check using a count model with a population offset</a:t>
+            </a:r>
+          </a:p>
+        </p:txBody>
+      </p:sp>
+      <p:sp>
+        <p:nvSpPr>
+          <p:cNvPr id="5" name="TextBox 4"/>
+          <p:cNvSpPr txBox="1"/>
+          <p:nvPr/>
+        </p:nvSpPr>
+        <p:spPr>
+          <a:xfrm>
+            <a:off x="548640" y="6446520"/>
+            <a:ext cx="10058400" cy="274320"/>
+          </a:xfrm>
+          <a:prstGeom prst="rect">
+            <a:avLst/>
+          </a:prstGeom>
+          <a:noFill/>
+        </p:spPr>
+        <p:txBody>
+          <a:bodyPr wrap="none">
+            <a:spAutoFit/>
+          </a:bodyPr>
+          <a:lstStyle/>
+          <a:p>
+            <a:r>
+              <a:rPr sz="900">
+                <a:solidFill>
+                  <a:srgbClr val="999999"/>
+                </a:solidFill>
+                <a:latin typeface="Calibri"/>
+              </a:rPr>
+              <a:t>Alberta opioid mortality around COVID-19  |  independent project</a:t>
+            </a:r>
+          </a:p>
+        </p:txBody>
+      </p:sp>
+      <p:sp>
+        <p:nvSpPr>
+          <p:cNvPr id="6" name="TextBox 5"/>
+          <p:cNvSpPr txBox="1"/>
+          <p:nvPr/>
+        </p:nvSpPr>
+        <p:spPr>
+          <a:xfrm>
+            <a:off x="11521440" y="6446520"/>
+            <a:ext cx="548640" cy="274320"/>
+          </a:xfrm>
+          <a:prstGeom prst="rect">
+            <a:avLst/>
+          </a:prstGeom>
+          <a:noFill/>
+        </p:spPr>
+        <p:txBody>
+          <a:bodyPr wrap="none">
+            <a:spAutoFit/>
+          </a:bodyPr>
+          <a:lstStyle/>
+          <a:p>
+            <a:pPr algn="r"/>
+            <a:r>
+              <a:rPr sz="1000">
+                <a:solidFill>
+                  <a:srgbClr val="999999"/>
+                </a:solidFill>
+                <a:latin typeface="Calibri"/>
+              </a:rPr>
+              <a:t>5</a:t>
+            </a:r>
+          </a:p>
+        </p:txBody>
+      </p:sp>
+    </p:spTree>
+  </p:cSld>
+  <p:clrMapOvr>
+    <a:masterClrMapping/>
+  </p:clrMapOvr>
+</p:sld>
+</file>
+
+<file path=ppt/slides/slide6.xml><?xml version="1.0" encoding="utf-8"?>
+<p:sld xmlns:a="http://schemas.openxmlformats.org/drawingml/2006/main" xmlns:p="http://schemas.openxmlformats.org/presentationml/2006/main" xmlns:r="http://schemas.openxmlformats.org/officeDocument/2006/relationships">
+  <p:cSld>
+    <p:spTree>
+      <p:nvGrpSpPr>
+        <p:cNvPr id="1" name=""/>
+        <p:cNvGrpSpPr/>
+        <p:nvPr/>
+      </p:nvGrpSpPr>
+      <p:grpSpPr/>
+      <p:sp>
+        <p:nvSpPr>
+          <p:cNvPr id="2" name="TextBox 1"/>
+          <p:cNvSpPr txBox="1"/>
+          <p:nvPr/>
+        </p:nvSpPr>
+        <p:spPr>
+          <a:xfrm>
+            <a:off x="548640" y="320040"/>
+            <a:ext cx="11064240" cy="640080"/>
+          </a:xfrm>
+          <a:prstGeom prst="rect">
+            <a:avLst/>
+          </a:prstGeom>
+          <a:noFill/>
+        </p:spPr>
+        <p:txBody>
+          <a:bodyPr wrap="none">
+            <a:spAutoFit/>
+          </a:bodyPr>
+          <a:lstStyle/>
+          <a:p>
+            <a:r>
+              <a:rPr sz="2600" b="1">
+                <a:solidFill>
+                  <a:srgbClr val="000000"/>
+                </a:solidFill>
+                <a:latin typeface="Calibri"/>
+              </a:rPr>
+              <a:t>Findings</a:t>
+            </a:r>
+          </a:p>
+        </p:txBody>
+      </p:sp>
+      <p:cxnSp>
+        <p:nvCxnSpPr>
+          <p:cNvPr id="3" name="Connector 2"/>
+          <p:cNvCxnSpPr/>
+          <p:nvPr/>
+        </p:nvCxnSpPr>
+        <p:spPr>
+          <a:xfrm>
+            <a:off x="548640" y="960120"/>
             <a:ext cx="11064240" cy="0"/>
           </a:xfrm>
           <a:prstGeom prst="line">
@@ -4277,7 +4517,7 @@
         </p:blipFill>
         <p:spPr>
           <a:xfrm>
-            <a:off x="457200" y="1508760"/>
+            <a:off x="457200" y="1143000"/>
             <a:ext cx="7680960" cy="4649481"/>
           </a:xfrm>
           <a:prstGeom prst="rect">
@@ -4293,8 +4533,8 @@
         </p:nvSpPr>
         <p:spPr>
           <a:xfrm>
-            <a:off x="8412480" y="1554480"/>
-            <a:ext cx="3657600" cy="4572000"/>
+            <a:off x="8412480" y="1280160"/>
+            <a:ext cx="3657600" cy="5029200"/>
           </a:xfrm>
           <a:prstGeom prst="rect">
             <a:avLst/>
@@ -4387,7 +4627,7 @@
                 </a:solidFill>
                 <a:latin typeface="Calibri"/>
               </a:rPr>
-              <a:t>–  Roughly a doubling</a:t>
+              <a:t>–  Roughly a doubling of the rate</a:t>
             </a:r>
           </a:p>
           <a:p>
@@ -4513,293 +4753,6 @@
       <p:sp>
         <p:nvSpPr>
           <p:cNvPr id="7" name="TextBox 6"/>
-          <p:cNvSpPr txBox="1"/>
-          <p:nvPr/>
-        </p:nvSpPr>
-        <p:spPr>
-          <a:xfrm>
-            <a:off x="11521440" y="6446520"/>
-            <a:ext cx="548640" cy="274320"/>
-          </a:xfrm>
-          <a:prstGeom prst="rect">
-            <a:avLst/>
-          </a:prstGeom>
-          <a:noFill/>
-        </p:spPr>
-        <p:txBody>
-          <a:bodyPr wrap="none">
-            <a:spAutoFit/>
-          </a:bodyPr>
-          <a:lstStyle/>
-          <a:p>
-            <a:pPr algn="r"/>
-            <a:r>
-              <a:rPr sz="1000">
-                <a:solidFill>
-                  <a:srgbClr val="999999"/>
-                </a:solidFill>
-                <a:latin typeface="Calibri"/>
-              </a:rPr>
-              <a:t>5</a:t>
-            </a:r>
-          </a:p>
-        </p:txBody>
-      </p:sp>
-    </p:spTree>
-  </p:cSld>
-  <p:clrMapOvr>
-    <a:masterClrMapping/>
-  </p:clrMapOvr>
-</p:sld>
-</file>
-
-<file path=ppt/slides/slide6.xml><?xml version="1.0" encoding="utf-8"?>
-<p:sld xmlns:a="http://schemas.openxmlformats.org/drawingml/2006/main" xmlns:p="http://schemas.openxmlformats.org/presentationml/2006/main" xmlns:r="http://schemas.openxmlformats.org/officeDocument/2006/relationships">
-  <p:cSld>
-    <p:spTree>
-      <p:nvGrpSpPr>
-        <p:cNvPr id="1" name=""/>
-        <p:cNvGrpSpPr/>
-        <p:nvPr/>
-      </p:nvGrpSpPr>
-      <p:grpSpPr/>
-      <p:sp>
-        <p:nvSpPr>
-          <p:cNvPr id="2" name="TextBox 1"/>
-          <p:cNvSpPr txBox="1"/>
-          <p:nvPr/>
-        </p:nvSpPr>
-        <p:spPr>
-          <a:xfrm>
-            <a:off x="548640" y="320040"/>
-            <a:ext cx="11064240" cy="1005840"/>
-          </a:xfrm>
-          <a:prstGeom prst="rect">
-            <a:avLst/>
-          </a:prstGeom>
-          <a:noFill/>
-        </p:spPr>
-        <p:txBody>
-          <a:bodyPr wrap="square">
-            <a:spAutoFit/>
-          </a:bodyPr>
-          <a:lstStyle/>
-          <a:p>
-            <a:r>
-              <a:rPr sz="2200" b="1">
-                <a:solidFill>
-                  <a:srgbClr val="000000"/>
-                </a:solidFill>
-                <a:latin typeface="Calibri"/>
-              </a:rPr>
-              <a:t>The pandemic as a whole shifted opioid mortality, not the virus alone</a:t>
-            </a:r>
-          </a:p>
-        </p:txBody>
-      </p:sp>
-      <p:cxnSp>
-        <p:nvCxnSpPr>
-          <p:cNvPr id="3" name="Connector 2"/>
-          <p:cNvCxnSpPr/>
-          <p:nvPr/>
-        </p:nvCxnSpPr>
-        <p:spPr>
-          <a:xfrm>
-            <a:off x="548640" y="1325880"/>
-            <a:ext cx="11064240" cy="0"/>
-          </a:xfrm>
-          <a:prstGeom prst="line">
-            <a:avLst/>
-          </a:prstGeom>
-          <a:ln w="9525">
-            <a:solidFill>
-              <a:srgbClr val="000000"/>
-            </a:solidFill>
-          </a:ln>
-        </p:spPr>
-        <p:style>
-          <a:lnRef idx="2">
-            <a:schemeClr val="accent1"/>
-          </a:lnRef>
-          <a:fillRef idx="0">
-            <a:schemeClr val="accent1"/>
-          </a:fillRef>
-          <a:effectRef idx="1">
-            <a:schemeClr val="accent1"/>
-          </a:effectRef>
-          <a:fontRef idx="minor">
-            <a:schemeClr val="tx1"/>
-          </a:fontRef>
-        </p:style>
-      </p:cxnSp>
-      <p:sp>
-        <p:nvSpPr>
-          <p:cNvPr id="4" name="TextBox 3"/>
-          <p:cNvSpPr txBox="1"/>
-          <p:nvPr/>
-        </p:nvSpPr>
-        <p:spPr>
-          <a:xfrm>
-            <a:off x="640080" y="1554480"/>
-            <a:ext cx="10972800" cy="4572000"/>
-          </a:xfrm>
-          <a:prstGeom prst="rect">
-            <a:avLst/>
-          </a:prstGeom>
-          <a:noFill/>
-        </p:spPr>
-        <p:txBody>
-          <a:bodyPr wrap="square">
-            <a:spAutoFit/>
-          </a:bodyPr>
-          <a:lstStyle/>
-          <a:p>
-            <a:pPr/>
-            <a:r>
-              <a:rPr sz="1400">
-                <a:solidFill>
-                  <a:srgbClr val="1A1A1A"/>
-                </a:solidFill>
-                <a:latin typeface="Calibri"/>
-              </a:rPr>
-              <a:t>•  The total effect attributable to the pandemic, including its downstream consequences</a:t>
-            </a:r>
-          </a:p>
-          <a:p>
-            <a:pPr lvl="1"/>
-            <a:r>
-              <a:rPr sz="1200">
-                <a:solidFill>
-                  <a:srgbClr val="555555"/>
-                </a:solidFill>
-                <a:latin typeface="Calibri"/>
-              </a:rPr>
-              <a:t>–  Virus, public health measures, drug supply disruption, harm reduction capacity, mental health service disruption, isolation, economic shock</a:t>
-            </a:r>
-          </a:p>
-          <a:p>
-            <a:pPr lvl="1"/>
-            <a:r>
-              <a:rPr sz="1200">
-                <a:solidFill>
-                  <a:srgbClr val="555555"/>
-                </a:solidFill>
-                <a:latin typeface="Calibri"/>
-              </a:rPr>
-              <a:t>–  These came together by construction, not by coincidence; a pandemic without them is not a counterfactual that exists in any data</a:t>
-            </a:r>
-          </a:p>
-          <a:p>
-            <a:pPr/>
-            <a:r>
-              <a:rPr sz="1400">
-                <a:solidFill>
-                  <a:srgbClr val="1A1A1A"/>
-                </a:solidFill>
-                <a:latin typeface="Calibri"/>
-              </a:rPr>
-              <a:t>•  The analysis cannot separate which channel did the most damage</a:t>
-            </a:r>
-          </a:p>
-          <a:p>
-            <a:pPr lvl="1"/>
-            <a:r>
-              <a:rPr sz="1200">
-                <a:solidFill>
-                  <a:srgbClr val="555555"/>
-                </a:solidFill>
-                <a:latin typeface="Calibri"/>
-              </a:rPr>
-              <a:t>–  Decomposing into supply vs. services vs. isolation vs. economic shock requires different data</a:t>
-            </a:r>
-          </a:p>
-          <a:p>
-            <a:pPr lvl="1"/>
-            <a:r>
-              <a:rPr sz="1200">
-                <a:solidFill>
-                  <a:srgbClr val="555555"/>
-                </a:solidFill>
-                <a:latin typeface="Calibri"/>
-              </a:rPr>
-              <a:t>–  Drug-checking composition, service utilization series, and similar mechanism-level sources</a:t>
-            </a:r>
-          </a:p>
-          <a:p>
-            <a:pPr/>
-            <a:r>
-              <a:rPr sz="1400">
-                <a:solidFill>
-                  <a:srgbClr val="1A1A1A"/>
-                </a:solidFill>
-                <a:latin typeface="Calibri"/>
-              </a:rPr>
-              <a:t>•  Comparing Alberta to other provinces would not isolate a virus-only effect</a:t>
-            </a:r>
-          </a:p>
-          <a:p>
-            <a:pPr lvl="1"/>
-            <a:r>
-              <a:rPr sz="1200">
-                <a:solidFill>
-                  <a:srgbClr val="555555"/>
-                </a:solidFill>
-                <a:latin typeface="Calibri"/>
-              </a:rPr>
-              <a:t>–  Every Canadian province faced COVID and its policy response at essentially the same time</a:t>
-            </a:r>
-          </a:p>
-          <a:p>
-            <a:pPr lvl="1"/>
-            <a:r>
-              <a:rPr sz="1200">
-                <a:solidFill>
-                  <a:srgbClr val="555555"/>
-                </a:solidFill>
-                <a:latin typeface="Calibri"/>
-              </a:rPr>
-              <a:t>–  A peer comparison would identify Alberta-specific deviation from the common pattern, not the virus channel alone</a:t>
-            </a:r>
-          </a:p>
-        </p:txBody>
-      </p:sp>
-      <p:sp>
-        <p:nvSpPr>
-          <p:cNvPr id="5" name="TextBox 4"/>
-          <p:cNvSpPr txBox="1"/>
-          <p:nvPr/>
-        </p:nvSpPr>
-        <p:spPr>
-          <a:xfrm>
-            <a:off x="548640" y="6446520"/>
-            <a:ext cx="10058400" cy="274320"/>
-          </a:xfrm>
-          <a:prstGeom prst="rect">
-            <a:avLst/>
-          </a:prstGeom>
-          <a:noFill/>
-        </p:spPr>
-        <p:txBody>
-          <a:bodyPr wrap="none">
-            <a:spAutoFit/>
-          </a:bodyPr>
-          <a:lstStyle/>
-          <a:p>
-            <a:r>
-              <a:rPr sz="900">
-                <a:solidFill>
-                  <a:srgbClr val="999999"/>
-                </a:solidFill>
-                <a:latin typeface="Calibri"/>
-              </a:rPr>
-              <a:t>Alberta opioid mortality around COVID-19  |  independent project</a:t>
-            </a:r>
-          </a:p>
-        </p:txBody>
-      </p:sp>
-      <p:sp>
-        <p:nvSpPr>
-          <p:cNvPr id="6" name="TextBox 5"/>
           <p:cNvSpPr txBox="1"/>
           <p:nvPr/>
         </p:nvSpPr>
@@ -4859,7 +4812,7 @@
         <p:spPr>
           <a:xfrm>
             <a:off x="548640" y="320040"/>
-            <a:ext cx="11064240" cy="1005840"/>
+            <a:ext cx="11064240" cy="640080"/>
           </a:xfrm>
           <a:prstGeom prst="rect">
             <a:avLst/>
@@ -4867,19 +4820,19 @@
           <a:noFill/>
         </p:spPr>
         <p:txBody>
-          <a:bodyPr wrap="square">
+          <a:bodyPr wrap="none">
             <a:spAutoFit/>
           </a:bodyPr>
           <a:lstStyle/>
           <a:p>
             <a:r>
-              <a:rPr sz="2200" b="1">
+              <a:rPr sz="2600" b="1">
                 <a:solidFill>
                   <a:srgbClr val="000000"/>
                 </a:solidFill>
                 <a:latin typeface="Calibri"/>
               </a:rPr>
-              <a:t>Post-COVID baseline is higher than pre-COVID, and recovery is already underway</a:t>
+              <a:t>What This Means</a:t>
             </a:r>
           </a:p>
         </p:txBody>
@@ -4892,7 +4845,7 @@
         </p:nvCxnSpPr>
         <p:spPr>
           <a:xfrm>
-            <a:off x="548640" y="1325880"/>
+            <a:off x="548640" y="960120"/>
             <a:ext cx="11064240" cy="0"/>
           </a:xfrm>
           <a:prstGeom prst="line">
@@ -4927,7 +4880,7 @@
         </p:nvSpPr>
         <p:spPr>
           <a:xfrm>
-            <a:off x="640080" y="1554480"/>
+            <a:off x="640080" y="1371600"/>
             <a:ext cx="10972800" cy="4572000"/>
           </a:xfrm>
           <a:prstGeom prst="rect">
@@ -4949,6 +4902,78 @@
                 </a:solidFill>
                 <a:latin typeface="Calibri"/>
               </a:rPr>
+              <a:t>•  The analysis identifies the total effect of the COVID-19 pandemic on Alberta opioid mortality</a:t>
+            </a:r>
+          </a:p>
+          <a:p>
+            <a:pPr lvl="1"/>
+            <a:r>
+              <a:rPr sz="1200">
+                <a:solidFill>
+                  <a:srgbClr val="555555"/>
+                </a:solidFill>
+                <a:latin typeface="Calibri"/>
+              </a:rPr>
+              <a:t>–  This includes the virus, the public health response, drug supply chain disruption, harm reduction service impacts, mental health service impacts, isolation, and the economic shock</a:t>
+            </a:r>
+          </a:p>
+          <a:p>
+            <a:pPr lvl="1"/>
+            <a:r>
+              <a:rPr sz="1200">
+                <a:solidFill>
+                  <a:srgbClr val="555555"/>
+                </a:solidFill>
+                <a:latin typeface="Calibri"/>
+              </a:rPr>
+              <a:t>–  These are downstream consequences of the pandemic, not independent causes</a:t>
+            </a:r>
+          </a:p>
+          <a:p>
+            <a:pPr/>
+            <a:r>
+              <a:rPr sz="1400">
+                <a:solidFill>
+                  <a:srgbClr val="1A1A1A"/>
+                </a:solidFill>
+                <a:latin typeface="Calibri"/>
+              </a:rPr>
+              <a:t>•  The analysis does NOT separate the virus from everything else the pandemic brought together</a:t>
+            </a:r>
+          </a:p>
+          <a:p>
+            <a:pPr lvl="1"/>
+            <a:r>
+              <a:rPr sz="1200">
+                <a:solidFill>
+                  <a:srgbClr val="555555"/>
+                </a:solidFill>
+                <a:latin typeface="Calibri"/>
+              </a:rPr>
+              <a:t>–  What share came from supply versus services versus isolation versus economic shock is a separate, mechanism-level question</a:t>
+            </a:r>
+          </a:p>
+          <a:p>
+            <a:pPr lvl="1"/>
+            <a:r>
+              <a:rPr sz="1200">
+                <a:solidFill>
+                  <a:srgbClr val="555555"/>
+                </a:solidFill>
+                <a:latin typeface="Calibri"/>
+              </a:rPr>
+              <a:t>–  Comparing Alberta to other provinces would not solve this, because all provinces faced COVID and its policy response at the same time</a:t>
+            </a:r>
+          </a:p>
+          <a:p>
+            <a:pPr/>
+            <a:r>
+              <a:rPr sz="1400">
+                <a:solidFill>
+                  <a:srgbClr val="1A1A1A"/>
+                </a:solidFill>
+                <a:latin typeface="Calibri"/>
+              </a:rPr>
               <a:t>•  For Recovery Model performance measurement, the baseline matters</a:t>
             </a:r>
           </a:p>
@@ -4977,18 +5002,6 @@
             </a:r>
           </a:p>
           <a:p>
-            <a:pPr/>
-            <a:r>
-              <a:rPr sz="1400">
-                <a:solidFill>
-                  <a:srgbClr val="1A1A1A"/>
-                </a:solidFill>
-                <a:latin typeface="Calibri"/>
-              </a:rPr>
-              <a:t>•  The trajectory is not flat: a real recovery is already visible</a:t>
-            </a:r>
-          </a:p>
-          <a:p>
             <a:pPr lvl="1"/>
             <a:r>
               <a:rPr sz="1200">
@@ -4997,79 +5010,7 @@
                 </a:solidFill>
                 <a:latin typeface="Calibri"/>
               </a:rPr>
-              <a:t>–  The post-COVID period peaked in 2021 Q4 and has been declining since 2024</a:t>
-            </a:r>
-          </a:p>
-          <a:p>
-            <a:pPr lvl="1"/>
-            <a:r>
-              <a:rPr sz="1200">
-                <a:solidFill>
-                  <a:srgbClr val="555555"/>
-                </a:solidFill>
-                <a:latin typeface="Calibri"/>
-              </a:rPr>
-              <a:t>–  A single average over the post-period masks this dynamic</a:t>
-            </a:r>
-          </a:p>
-          <a:p>
-            <a:pPr/>
-            <a:r>
-              <a:rPr sz="1400">
-                <a:solidFill>
-                  <a:srgbClr val="1A1A1A"/>
-                </a:solidFill>
-                <a:latin typeface="Calibri"/>
-              </a:rPr>
-              <a:t>•  The next analytical work is decomposition, not better identification</a:t>
-            </a:r>
-          </a:p>
-          <a:p>
-            <a:pPr lvl="1"/>
-            <a:r>
-              <a:rPr sz="1200">
-                <a:solidFill>
-                  <a:srgbClr val="555555"/>
-                </a:solidFill>
-                <a:latin typeface="Calibri"/>
-              </a:rPr>
-              <a:t>–  Which channel drove most of the shift (supply, services, isolation, economic)</a:t>
-            </a:r>
-          </a:p>
-          <a:p>
-            <a:pPr lvl="1"/>
-            <a:r>
-              <a:rPr sz="1200">
-                <a:solidFill>
-                  <a:srgbClr val="555555"/>
-                </a:solidFill>
-                <a:latin typeface="Calibri"/>
-              </a:rPr>
-              <a:t>–  Which age groups, geographic zones, and substance types concentrate the increase</a:t>
-            </a:r>
-          </a:p>
-          <a:p>
-            <a:pPr lvl="1"/>
-            <a:r>
-              <a:rPr sz="1200">
-                <a:solidFill>
-                  <a:srgbClr val="555555"/>
-                </a:solidFill>
-                <a:latin typeface="Calibri"/>
-              </a:rPr>
-              <a:t>–  Modelling the rise-to-peak-and-decline shape directly, rather than a single level shift</a:t>
-            </a:r>
-          </a:p>
-          <a:p>
-            <a:pPr lvl="1"/>
-            <a:r>
-              <a:rPr sz="1200">
-                <a:solidFill>
-                  <a:srgbClr val="555555"/>
-                </a:solidFill>
-                <a:latin typeface="Calibri"/>
-              </a:rPr>
-              <a:t>–  Cumulative excess deaths through end-of-sample as a policy-relevant total</a:t>
+              <a:t>–  The post-COVID trajectory is already declining since 2024, suggesting a real recovery is underway</a:t>
             </a:r>
           </a:p>
         </p:txBody>
@@ -5139,6 +5080,317 @@
                 <a:latin typeface="Calibri"/>
               </a:rPr>
               <a:t>7</a:t>
+            </a:r>
+          </a:p>
+        </p:txBody>
+      </p:sp>
+    </p:spTree>
+  </p:cSld>
+  <p:clrMapOvr>
+    <a:masterClrMapping/>
+  </p:clrMapOvr>
+</p:sld>
+</file>
+
+<file path=ppt/slides/slide8.xml><?xml version="1.0" encoding="utf-8"?>
+<p:sld xmlns:a="http://schemas.openxmlformats.org/drawingml/2006/main" xmlns:p="http://schemas.openxmlformats.org/presentationml/2006/main" xmlns:r="http://schemas.openxmlformats.org/officeDocument/2006/relationships">
+  <p:cSld>
+    <p:spTree>
+      <p:nvGrpSpPr>
+        <p:cNvPr id="1" name=""/>
+        <p:cNvGrpSpPr/>
+        <p:nvPr/>
+      </p:nvGrpSpPr>
+      <p:grpSpPr/>
+      <p:sp>
+        <p:nvSpPr>
+          <p:cNvPr id="2" name="TextBox 1"/>
+          <p:cNvSpPr txBox="1"/>
+          <p:nvPr/>
+        </p:nvSpPr>
+        <p:spPr>
+          <a:xfrm>
+            <a:off x="548640" y="320040"/>
+            <a:ext cx="11064240" cy="640080"/>
+          </a:xfrm>
+          <a:prstGeom prst="rect">
+            <a:avLst/>
+          </a:prstGeom>
+          <a:noFill/>
+        </p:spPr>
+        <p:txBody>
+          <a:bodyPr wrap="none">
+            <a:spAutoFit/>
+          </a:bodyPr>
+          <a:lstStyle/>
+          <a:p>
+            <a:r>
+              <a:rPr sz="2600" b="1">
+                <a:solidFill>
+                  <a:srgbClr val="000000"/>
+                </a:solidFill>
+                <a:latin typeface="Calibri"/>
+              </a:rPr>
+              <a:t>Limitations and Next Steps</a:t>
+            </a:r>
+          </a:p>
+        </p:txBody>
+      </p:sp>
+      <p:cxnSp>
+        <p:nvCxnSpPr>
+          <p:cNvPr id="3" name="Connector 2"/>
+          <p:cNvCxnSpPr/>
+          <p:nvPr/>
+        </p:nvCxnSpPr>
+        <p:spPr>
+          <a:xfrm>
+            <a:off x="548640" y="960120"/>
+            <a:ext cx="11064240" cy="0"/>
+          </a:xfrm>
+          <a:prstGeom prst="line">
+            <a:avLst/>
+          </a:prstGeom>
+          <a:ln w="9525">
+            <a:solidFill>
+              <a:srgbClr val="000000"/>
+            </a:solidFill>
+          </a:ln>
+        </p:spPr>
+        <p:style>
+          <a:lnRef idx="2">
+            <a:schemeClr val="accent1"/>
+          </a:lnRef>
+          <a:fillRef idx="0">
+            <a:schemeClr val="accent1"/>
+          </a:fillRef>
+          <a:effectRef idx="1">
+            <a:schemeClr val="accent1"/>
+          </a:effectRef>
+          <a:fontRef idx="minor">
+            <a:schemeClr val="tx1"/>
+          </a:fontRef>
+        </p:style>
+      </p:cxnSp>
+      <p:sp>
+        <p:nvSpPr>
+          <p:cNvPr id="4" name="TextBox 3"/>
+          <p:cNvSpPr txBox="1"/>
+          <p:nvPr/>
+        </p:nvSpPr>
+        <p:spPr>
+          <a:xfrm>
+            <a:off x="640080" y="1371600"/>
+            <a:ext cx="10972800" cy="4572000"/>
+          </a:xfrm>
+          <a:prstGeom prst="rect">
+            <a:avLst/>
+          </a:prstGeom>
+          <a:noFill/>
+        </p:spPr>
+        <p:txBody>
+          <a:bodyPr wrap="square">
+            <a:spAutoFit/>
+          </a:bodyPr>
+          <a:lstStyle/>
+          <a:p>
+            <a:pPr/>
+            <a:r>
+              <a:rPr sz="1400">
+                <a:solidFill>
+                  <a:srgbClr val="1A1A1A"/>
+                </a:solidFill>
+                <a:latin typeface="Calibri"/>
+              </a:rPr>
+              <a:t>•  Limitations</a:t>
+            </a:r>
+          </a:p>
+          <a:p>
+            <a:pPr lvl="1"/>
+            <a:r>
+              <a:rPr sz="1200">
+                <a:solidFill>
+                  <a:srgbClr val="555555"/>
+                </a:solidFill>
+                <a:latin typeface="Calibri"/>
+              </a:rPr>
+              <a:t>–  Single province, single outcome (opioid deaths) - no decomposition by substance type, age, sex, or zone</a:t>
+            </a:r>
+          </a:p>
+          <a:p>
+            <a:pPr lvl="1"/>
+            <a:r>
+              <a:rPr sz="1200">
+                <a:solidFill>
+                  <a:srgbClr val="555555"/>
+                </a:solidFill>
+                <a:latin typeface="Calibri"/>
+              </a:rPr>
+              <a:t>–  Quarterly data is small for inference (39 observations); reliance on robustness checks rather than asymptotic theory alone</a:t>
+            </a:r>
+          </a:p>
+          <a:p>
+            <a:pPr lvl="1"/>
+            <a:r>
+              <a:rPr sz="1200">
+                <a:solidFill>
+                  <a:srgbClr val="555555"/>
+                </a:solidFill>
+                <a:latin typeface="Calibri"/>
+              </a:rPr>
+              <a:t>–  Reporting lag and revisions: the most recent quarters may move as data is updated</a:t>
+            </a:r>
+          </a:p>
+          <a:p>
+            <a:pPr/>
+            <a:r>
+              <a:rPr sz="1400">
+                <a:solidFill>
+                  <a:srgbClr val="1A1A1A"/>
+                </a:solidFill>
+                <a:latin typeface="Calibri"/>
+              </a:rPr>
+              <a:t>•  Realistic next analytical work</a:t>
+            </a:r>
+          </a:p>
+          <a:p>
+            <a:pPr lvl="1"/>
+            <a:r>
+              <a:rPr sz="1200">
+                <a:solidFill>
+                  <a:srgbClr val="555555"/>
+                </a:solidFill>
+                <a:latin typeface="Calibri"/>
+              </a:rPr>
+              <a:t>–  Mechanism decomposition: bring in supply-side, service-capacity, and outcome data to attribute share to each channel</a:t>
+            </a:r>
+          </a:p>
+          <a:p>
+            <a:pPr lvl="1"/>
+            <a:r>
+              <a:rPr sz="1200">
+                <a:solidFill>
+                  <a:srgbClr val="555555"/>
+                </a:solidFill>
+                <a:latin typeface="Calibri"/>
+              </a:rPr>
+              <a:t>–  Heterogeneity: by age, sex, zone, and substance type (fentanyl, carfentanil, other)</a:t>
+            </a:r>
+          </a:p>
+          <a:p>
+            <a:pPr lvl="1"/>
+            <a:r>
+              <a:rPr sz="1200">
+                <a:solidFill>
+                  <a:srgbClr val="555555"/>
+                </a:solidFill>
+                <a:latin typeface="Calibri"/>
+              </a:rPr>
+              <a:t>–  Post-period dynamics: model the rise-to-peak-and-decline shape directly</a:t>
+            </a:r>
+          </a:p>
+          <a:p>
+            <a:pPr lvl="1"/>
+            <a:r>
+              <a:rPr sz="1200">
+                <a:solidFill>
+                  <a:srgbClr val="555555"/>
+                </a:solidFill>
+                <a:latin typeface="Calibri"/>
+              </a:rPr>
+              <a:t>–  Cumulative excess deaths through end-of-sample as a policy-relevant total</a:t>
+            </a:r>
+          </a:p>
+          <a:p>
+            <a:pPr/>
+            <a:r>
+              <a:rPr sz="1400">
+                <a:solidFill>
+                  <a:srgbClr val="1A1A1A"/>
+                </a:solidFill>
+                <a:latin typeface="Calibri"/>
+              </a:rPr>
+              <a:t>•  Code, data, and full documentation</a:t>
+            </a:r>
+          </a:p>
+          <a:p>
+            <a:pPr lvl="1"/>
+            <a:r>
+              <a:rPr sz="1200">
+                <a:solidFill>
+                  <a:srgbClr val="555555"/>
+                </a:solidFill>
+                <a:latin typeface="Calibri"/>
+              </a:rPr>
+              <a:t>–  github.com/Adilbek123/alberta-substance-use-trends</a:t>
+            </a:r>
+          </a:p>
+        </p:txBody>
+      </p:sp>
+      <p:sp>
+        <p:nvSpPr>
+          <p:cNvPr id="5" name="TextBox 4"/>
+          <p:cNvSpPr txBox="1"/>
+          <p:nvPr/>
+        </p:nvSpPr>
+        <p:spPr>
+          <a:xfrm>
+            <a:off x="548640" y="6446520"/>
+            <a:ext cx="10058400" cy="274320"/>
+          </a:xfrm>
+          <a:prstGeom prst="rect">
+            <a:avLst/>
+          </a:prstGeom>
+          <a:noFill/>
+        </p:spPr>
+        <p:txBody>
+          <a:bodyPr wrap="none">
+            <a:spAutoFit/>
+          </a:bodyPr>
+          <a:lstStyle/>
+          <a:p>
+            <a:r>
+              <a:rPr sz="900">
+                <a:solidFill>
+                  <a:srgbClr val="999999"/>
+                </a:solidFill>
+                <a:latin typeface="Calibri"/>
+              </a:rPr>
+              <a:t>Alberta opioid mortality around COVID-19  |  independent project</a:t>
+            </a:r>
+          </a:p>
+        </p:txBody>
+      </p:sp>
+      <p:sp>
+        <p:nvSpPr>
+          <p:cNvPr id="6" name="TextBox 5"/>
+          <p:cNvSpPr txBox="1"/>
+          <p:nvPr/>
+        </p:nvSpPr>
+        <p:spPr>
+          <a:xfrm>
+            <a:off x="11521440" y="6446520"/>
+            <a:ext cx="548640" cy="274320"/>
+          </a:xfrm>
+          <a:prstGeom prst="rect">
+            <a:avLst/>
+          </a:prstGeom>
+          <a:noFill/>
+        </p:spPr>
+        <p:txBody>
+          <a:bodyPr wrap="none">
+            <a:spAutoFit/>
+          </a:bodyPr>
+          <a:lstStyle/>
+          <a:p>
+            <a:pPr algn="r"/>
+            <a:r>
+              <a:rPr sz="1000">
+                <a:solidFill>
+                  <a:srgbClr val="999999"/>
+                </a:solidFill>
+                <a:latin typeface="Calibri"/>
+              </a:rPr>
+              <a:t>8</a:t>
             </a:r>
           </a:p>
         </p:txBody>

</xml_diff>

<commit_message>
Rewrite Background: Alberta-specific opioid history (fentanyl emergence 2014-2016, 611 deaths in 2016, May 2017 emergency commission) instead of generic pandemic context
</commit_message>
<xml_diff>
--- a/slides.pptx
+++ b/slides.pptx
@@ -3873,7 +3873,7 @@
                 </a:solidFill>
                 <a:latin typeface="Calibri"/>
               </a:rPr>
-              <a:t>•  COVID-19 pandemic context</a:t>
+              <a:t>•  Alberta has been responding to an opioid crisis since the mid-2010s</a:t>
             </a:r>
           </a:p>
           <a:p>
@@ -3885,6 +3885,102 @@
                 </a:solidFill>
                 <a:latin typeface="Calibri"/>
               </a:rPr>
+              <a:t>–  Fentanyl emerged in Alberta's unregulated drug supply through 2014-2016, replacing earlier prescription-opioid harms</a:t>
+            </a:r>
+          </a:p>
+          <a:p>
+            <a:pPr lvl="1"/>
+            <a:r>
+              <a:rPr sz="1200">
+                <a:solidFill>
+                  <a:srgbClr val="555555"/>
+                </a:solidFill>
+                <a:latin typeface="Calibri"/>
+              </a:rPr>
+              <a:t>–  In 2016 Alberta recorded 611 apparent opioid-related deaths</a:t>
+            </a:r>
+          </a:p>
+          <a:p>
+            <a:pPr lvl="1"/>
+            <a:r>
+              <a:rPr sz="1200">
+                <a:solidFill>
+                  <a:srgbClr val="555555"/>
+                </a:solidFill>
+                <a:latin typeface="Calibri"/>
+              </a:rPr>
+              <a:t>–  In May 2017 the province established a Minister's Opioid Emergency Response Commission under the Public Health Act</a:t>
+            </a:r>
+          </a:p>
+          <a:p>
+            <a:pPr/>
+            <a:r>
+              <a:rPr sz="1400">
+                <a:solidFill>
+                  <a:srgbClr val="1A1A1A"/>
+                </a:solidFill>
+                <a:latin typeface="Calibri"/>
+              </a:rPr>
+              <a:t>•  By 2016-2019, Alberta's opioid mortality had stabilised at a high level</a:t>
+            </a:r>
+          </a:p>
+          <a:p>
+            <a:pPr lvl="1"/>
+            <a:r>
+              <a:rPr sz="1200">
+                <a:solidFill>
+                  <a:srgbClr val="555555"/>
+                </a:solidFill>
+                <a:latin typeface="Calibri"/>
+              </a:rPr>
+              <a:t>–  Quarterly opioid death rate sat around 4 per 100,000 residents from 2016 through early 2020</a:t>
+            </a:r>
+          </a:p>
+          <a:p>
+            <a:pPr lvl="1"/>
+            <a:r>
+              <a:rPr sz="1200">
+                <a:solidFill>
+                  <a:srgbClr val="555555"/>
+                </a:solidFill>
+                <a:latin typeface="Calibri"/>
+              </a:rPr>
+              <a:t>–  Roughly 170-200 deaths per quarter, with no sustained upward or downward trend over the four-year period</a:t>
+            </a:r>
+          </a:p>
+          <a:p>
+            <a:pPr lvl="1"/>
+            <a:r>
+              <a:rPr sz="1200">
+                <a:solidFill>
+                  <a:srgbClr val="555555"/>
+                </a:solidFill>
+                <a:latin typeface="Calibri"/>
+              </a:rPr>
+              <a:t>–  This is the pre-COVID baseline used in this analysis</a:t>
+            </a:r>
+          </a:p>
+          <a:p>
+            <a:pPr/>
+            <a:r>
+              <a:rPr sz="1400">
+                <a:solidFill>
+                  <a:srgbClr val="1A1A1A"/>
+                </a:solidFill>
+                <a:latin typeface="Calibri"/>
+              </a:rPr>
+              <a:t>•  In March 2020 the COVID-19 pandemic intersected with the existing opioid crisis</a:t>
+            </a:r>
+          </a:p>
+          <a:p>
+            <a:pPr lvl="1"/>
+            <a:r>
+              <a:rPr sz="1200">
+                <a:solidFill>
+                  <a:srgbClr val="555555"/>
+                </a:solidFill>
+                <a:latin typeface="Calibri"/>
+              </a:rPr>
               <a:t>–  WHO characterized COVID-19 as a pandemic on 11 March 2020</a:t>
             </a:r>
           </a:p>
@@ -3909,115 +4005,7 @@
                 </a:solidFill>
                 <a:latin typeface="Calibri"/>
               </a:rPr>
-              <a:t>–  Approximately 60,000 Canadians have died from the virus directly through 2024</a:t>
-            </a:r>
-          </a:p>
-          <a:p>
-            <a:pPr/>
-            <a:r>
-              <a:rPr sz="1400">
-                <a:solidFill>
-                  <a:srgbClr val="1A1A1A"/>
-                </a:solidFill>
-                <a:latin typeface="Calibri"/>
-              </a:rPr>
-              <a:t>•  Beyond the virus itself, the pandemic disrupted several systems at once</a:t>
-            </a:r>
-          </a:p>
-          <a:p>
-            <a:pPr lvl="1"/>
-            <a:r>
-              <a:rPr sz="1200">
-                <a:solidFill>
-                  <a:srgbClr val="555555"/>
-                </a:solidFill>
-                <a:latin typeface="Calibri"/>
-              </a:rPr>
-              <a:t>–  Drug supply chains for the unregulated drug market</a:t>
-            </a:r>
-          </a:p>
-          <a:p>
-            <a:pPr lvl="1"/>
-            <a:r>
-              <a:rPr sz="1200">
-                <a:solidFill>
-                  <a:srgbClr val="555555"/>
-                </a:solidFill>
-                <a:latin typeface="Calibri"/>
-              </a:rPr>
-              <a:t>–  Harm reduction service delivery (in-person service capacity, hours, access)</a:t>
-            </a:r>
-          </a:p>
-          <a:p>
-            <a:pPr lvl="1"/>
-            <a:r>
-              <a:rPr sz="1200">
-                <a:solidFill>
-                  <a:srgbClr val="555555"/>
-                </a:solidFill>
-                <a:latin typeface="Calibri"/>
-              </a:rPr>
-              <a:t>–  Mental health and addiction service delivery (in-person care disruption)</a:t>
-            </a:r>
-          </a:p>
-          <a:p>
-            <a:pPr lvl="1"/>
-            <a:r>
-              <a:rPr sz="1200">
-                <a:solidFill>
-                  <a:srgbClr val="555555"/>
-                </a:solidFill>
-                <a:latin typeface="Calibri"/>
-              </a:rPr>
-              <a:t>–  Employment, housing, and social connection</a:t>
-            </a:r>
-          </a:p>
-          <a:p>
-            <a:pPr/>
-            <a:r>
-              <a:rPr sz="1400">
-                <a:solidFill>
-                  <a:srgbClr val="1A1A1A"/>
-                </a:solidFill>
-                <a:latin typeface="Calibri"/>
-              </a:rPr>
-              <a:t>•  Other provinces reported a substantial increase in opioid mortality starting 2020 Q2</a:t>
-            </a:r>
-          </a:p>
-          <a:p>
-            <a:pPr lvl="1"/>
-            <a:r>
-              <a:rPr sz="1200">
-                <a:solidFill>
-                  <a:srgbClr val="555555"/>
-                </a:solidFill>
-                <a:latin typeface="Calibri"/>
-              </a:rPr>
-              <a:t>–  British Columbia: quarterly opioid deaths roughly doubled (2019 average vs 2020 Q2 to 2021 Q1)</a:t>
-            </a:r>
-          </a:p>
-          <a:p>
-            <a:pPr lvl="1"/>
-            <a:r>
-              <a:rPr sz="1200">
-                <a:solidFill>
-                  <a:srgbClr val="555555"/>
-                </a:solidFill>
-                <a:latin typeface="Calibri"/>
-              </a:rPr>
-              <a:t>–  Ontario: quarterly opioid deaths rose by roughly 75 per cent over the same comparison</a:t>
-            </a:r>
-          </a:p>
-          <a:p>
-            <a:pPr lvl="1"/>
-            <a:r>
-              <a:rPr sz="1200">
-                <a:solidFill>
-                  <a:srgbClr val="555555"/>
-                </a:solidFill>
-                <a:latin typeface="Calibri"/>
-              </a:rPr>
-              <a:t>–  Federal data (PHAC) confirms a Canada-wide pattern at the same cutoff</a:t>
+              <a:t>–  Federal data shows opioid mortality rose sharply across Canada from 2020 onward; the size and timing of Alberta's shift have not been quantified at this resolution in public analysis</a:t>
             </a:r>
           </a:p>
         </p:txBody>

</xml_diff>

<commit_message>
Add Research Question slide; rewrite slides 5-9 with what/why/so-what bullets; apply econometrist substance review fixes (counterfactual framing, robustness explanations, interpretive-vs-statistical distinction, recovery claim softened)
</commit_message>
<xml_diff>
--- a/slides.pptx
+++ b/slides.pptx
@@ -13,6 +13,7 @@
     <p:sldId id="261" r:id="rId12"/>
     <p:sldId id="262" r:id="rId13"/>
     <p:sldId id="263" r:id="rId14"/>
+    <p:sldId id="264" r:id="rId15"/>
   </p:sldIdLst>
   <p:sldSz cx="12188952" cy="6858000" type="screen4x3"/>
   <p:notesSz cx="6858000" cy="9144000"/>
@@ -3365,7 +3366,7 @@
           <a:p>
             <a:pPr/>
             <a:r>
-              <a:rPr sz="1600">
+              <a:rPr sz="1500">
                 <a:solidFill>
                   <a:srgbClr val="1A1A1A"/>
                 </a:solidFill>
@@ -3377,7 +3378,7 @@
           <a:p>
             <a:pPr/>
             <a:r>
-              <a:rPr sz="1600">
+              <a:rPr sz="1500">
                 <a:solidFill>
                   <a:srgbClr val="1A1A1A"/>
                 </a:solidFill>
@@ -3389,7 +3390,7 @@
           <a:p>
             <a:pPr/>
             <a:r>
-              <a:rPr sz="1600">
+              <a:rPr sz="1500">
                 <a:solidFill>
                   <a:srgbClr val="1A1A1A"/>
                 </a:solidFill>
@@ -3580,7 +3581,7 @@
           <a:p>
             <a:pPr/>
             <a:r>
-              <a:rPr sz="1500">
+              <a:rPr sz="1400">
                 <a:solidFill>
                   <a:srgbClr val="1A1A1A"/>
                 </a:solidFill>
@@ -3592,7 +3593,7 @@
           <a:p>
             <a:pPr lvl="1"/>
             <a:r>
-              <a:rPr sz="1200">
+              <a:rPr sz="1100">
                 <a:solidFill>
                   <a:srgbClr val="555555"/>
                 </a:solidFill>
@@ -3604,7 +3605,7 @@
           <a:p>
             <a:pPr lvl="1"/>
             <a:r>
-              <a:rPr sz="1200">
+              <a:rPr sz="1100">
                 <a:solidFill>
                   <a:srgbClr val="555555"/>
                 </a:solidFill>
@@ -3616,7 +3617,7 @@
           <a:p>
             <a:pPr/>
             <a:r>
-              <a:rPr sz="1500">
+              <a:rPr sz="1400">
                 <a:solidFill>
                   <a:srgbClr val="1A1A1A"/>
                 </a:solidFill>
@@ -3628,7 +3629,7 @@
           <a:p>
             <a:pPr lvl="1"/>
             <a:r>
-              <a:rPr sz="1200">
+              <a:rPr sz="1100">
                 <a:solidFill>
                   <a:srgbClr val="555555"/>
                 </a:solidFill>
@@ -3640,7 +3641,7 @@
           <a:p>
             <a:pPr lvl="1"/>
             <a:r>
-              <a:rPr sz="1200">
+              <a:rPr sz="1100">
                 <a:solidFill>
                   <a:srgbClr val="555555"/>
                 </a:solidFill>
@@ -3652,7 +3653,7 @@
           <a:p>
             <a:pPr/>
             <a:r>
-              <a:rPr sz="1500">
+              <a:rPr sz="1400">
                 <a:solidFill>
                   <a:srgbClr val="1A1A1A"/>
                 </a:solidFill>
@@ -3664,7 +3665,7 @@
           <a:p>
             <a:pPr lvl="1"/>
             <a:r>
-              <a:rPr sz="1200">
+              <a:rPr sz="1100">
                 <a:solidFill>
                   <a:srgbClr val="555555"/>
                 </a:solidFill>
@@ -3676,7 +3677,7 @@
           <a:p>
             <a:pPr lvl="1"/>
             <a:r>
-              <a:rPr sz="1200">
+              <a:rPr sz="1100">
                 <a:solidFill>
                   <a:srgbClr val="555555"/>
                 </a:solidFill>
@@ -3867,7 +3868,7 @@
           <a:p>
             <a:pPr/>
             <a:r>
-              <a:rPr sz="1400">
+              <a:rPr sz="1300">
                 <a:solidFill>
                   <a:srgbClr val="1A1A1A"/>
                 </a:solidFill>
@@ -3879,7 +3880,7 @@
           <a:p>
             <a:pPr lvl="1"/>
             <a:r>
-              <a:rPr sz="1200">
+              <a:rPr sz="1100">
                 <a:solidFill>
                   <a:srgbClr val="555555"/>
                 </a:solidFill>
@@ -3891,7 +3892,7 @@
           <a:p>
             <a:pPr lvl="1"/>
             <a:r>
-              <a:rPr sz="1200">
+              <a:rPr sz="1100">
                 <a:solidFill>
                   <a:srgbClr val="555555"/>
                 </a:solidFill>
@@ -3903,7 +3904,7 @@
           <a:p>
             <a:pPr lvl="1"/>
             <a:r>
-              <a:rPr sz="1200">
+              <a:rPr sz="1100">
                 <a:solidFill>
                   <a:srgbClr val="555555"/>
                 </a:solidFill>
@@ -3915,7 +3916,7 @@
           <a:p>
             <a:pPr/>
             <a:r>
-              <a:rPr sz="1400">
+              <a:rPr sz="1300">
                 <a:solidFill>
                   <a:srgbClr val="1A1A1A"/>
                 </a:solidFill>
@@ -3927,7 +3928,7 @@
           <a:p>
             <a:pPr lvl="1"/>
             <a:r>
-              <a:rPr sz="1200">
+              <a:rPr sz="1100">
                 <a:solidFill>
                   <a:srgbClr val="555555"/>
                 </a:solidFill>
@@ -3939,7 +3940,7 @@
           <a:p>
             <a:pPr lvl="1"/>
             <a:r>
-              <a:rPr sz="1200">
+              <a:rPr sz="1100">
                 <a:solidFill>
                   <a:srgbClr val="555555"/>
                 </a:solidFill>
@@ -3951,7 +3952,7 @@
           <a:p>
             <a:pPr lvl="1"/>
             <a:r>
-              <a:rPr sz="1200">
+              <a:rPr sz="1100">
                 <a:solidFill>
                   <a:srgbClr val="555555"/>
                 </a:solidFill>
@@ -3963,7 +3964,7 @@
           <a:p>
             <a:pPr/>
             <a:r>
-              <a:rPr sz="1400">
+              <a:rPr sz="1300">
                 <a:solidFill>
                   <a:srgbClr val="1A1A1A"/>
                 </a:solidFill>
@@ -3975,7 +3976,7 @@
           <a:p>
             <a:pPr lvl="1"/>
             <a:r>
-              <a:rPr sz="1200">
+              <a:rPr sz="1100">
                 <a:solidFill>
                   <a:srgbClr val="555555"/>
                 </a:solidFill>
@@ -3987,7 +3988,7 @@
           <a:p>
             <a:pPr lvl="1"/>
             <a:r>
-              <a:rPr sz="1200">
+              <a:rPr sz="1100">
                 <a:solidFill>
                   <a:srgbClr val="555555"/>
                 </a:solidFill>
@@ -3999,13 +4000,13 @@
           <a:p>
             <a:pPr lvl="1"/>
             <a:r>
-              <a:rPr sz="1200">
-                <a:solidFill>
-                  <a:srgbClr val="555555"/>
-                </a:solidFill>
-                <a:latin typeface="Calibri"/>
-              </a:rPr>
-              <a:t>–  Federal data shows opioid mortality rose sharply across Canada from 2020 onward; the size and timing of Alberta's shift have not been quantified at this resolution in public analysis</a:t>
+              <a:rPr sz="1100">
+                <a:solidFill>
+                  <a:srgbClr val="555555"/>
+                </a:solidFill>
+                <a:latin typeface="Calibri"/>
+              </a:rPr>
+              <a:t>–  Federal data shows opioid mortality rose sharply across Canada from 2020 onward; the size and timing of Alberta's specific shift have not been quantified at this resolution in publicly available analysis</a:t>
             </a:r>
           </a:p>
         </p:txBody>
@@ -4126,7 +4127,7 @@
                 </a:solidFill>
                 <a:latin typeface="Calibri"/>
               </a:rPr>
-              <a:t>Approach</a:t>
+              <a:t>Research Question</a:t>
             </a:r>
           </a:p>
         </p:txBody>
@@ -4196,43 +4197,43 @@
                 </a:solidFill>
                 <a:latin typeface="Calibri"/>
               </a:rPr>
-              <a:t>•  Method: interrupted time series (segmented regression)</a:t>
-            </a:r>
-          </a:p>
-          <a:p>
-            <a:pPr lvl="1"/>
-            <a:r>
-              <a:rPr sz="1200">
-                <a:solidFill>
-                  <a:srgbClr val="555555"/>
-                </a:solidFill>
-                <a:latin typeface="Calibri"/>
-              </a:rPr>
-              <a:t>–  Fits one trend to the pre-COVID years, another to the post-COVID years</a:t>
-            </a:r>
-          </a:p>
-          <a:p>
-            <a:pPr lvl="1"/>
-            <a:r>
-              <a:rPr sz="1200">
-                <a:solidFill>
-                  <a:srgbClr val="555555"/>
-                </a:solidFill>
-                <a:latin typeface="Calibri"/>
-              </a:rPr>
-              <a:t>–  Measures the gap between them at the cutoff (2020 Q2, first full quarter under the emergency)</a:t>
-            </a:r>
-          </a:p>
-          <a:p>
-            <a:pPr lvl="1"/>
-            <a:r>
-              <a:rPr sz="1200">
-                <a:solidFill>
-                  <a:srgbClr val="555555"/>
-                </a:solidFill>
-                <a:latin typeface="Calibri"/>
-              </a:rPr>
-              <a:t>–  Tests whether that gap is meaningfully larger than the natural noise in the data</a:t>
+              <a:t>•  Did Alberta's opioid death rate shift at the COVID-19 cutoff (2020 Q2) in a way the pre-COVID period cannot explain?</a:t>
+            </a:r>
+          </a:p>
+          <a:p>
+            <a:pPr lvl="1"/>
+            <a:r>
+              <a:rPr sz="1100">
+                <a:solidFill>
+                  <a:srgbClr val="555555"/>
+                </a:solidFill>
+                <a:latin typeface="Calibri"/>
+              </a:rPr>
+              <a:t>–  This is a 'break' question, not a 'cause' question: we ask whether the post-cutoff data are inconsistent with the pre-period pattern</a:t>
+            </a:r>
+          </a:p>
+          <a:p>
+            <a:pPr lvl="1"/>
+            <a:r>
+              <a:rPr sz="1100">
+                <a:solidFill>
+                  <a:srgbClr val="555555"/>
+                </a:solidFill>
+                <a:latin typeface="Calibri"/>
+              </a:rPr>
+              <a:t>–  The pre-COVID period gives us a model of how the rate behaved (level, trend, seasonality); extrapolating that model forward gives a counterfactual for what we would expect post-cutoff if nothing had changed</a:t>
+            </a:r>
+          </a:p>
+          <a:p>
+            <a:pPr lvl="1"/>
+            <a:r>
+              <a:rPr sz="1100">
+                <a:solidFill>
+                  <a:srgbClr val="555555"/>
+                </a:solidFill>
+                <a:latin typeface="Calibri"/>
+              </a:rPr>
+              <a:t>–  If observed post-cutoff data depart materially from that extrapolation, the shift is real</a:t>
             </a:r>
           </a:p>
           <a:p>
@@ -4244,91 +4245,31 @@
                 </a:solidFill>
                 <a:latin typeface="Calibri"/>
               </a:rPr>
-              <a:t>•  Data</a:t>
-            </a:r>
-          </a:p>
-          <a:p>
-            <a:pPr lvl="1"/>
-            <a:r>
-              <a:rPr sz="1200">
-                <a:solidFill>
-                  <a:srgbClr val="555555"/>
-                </a:solidFill>
-                <a:latin typeface="Calibri"/>
-              </a:rPr>
-              <a:t>–  Opioid deaths: Public Health Agency of Canada, Health Infobase, Alberta quarterly, 2016 Q1 to 2025 Q3</a:t>
-            </a:r>
-          </a:p>
-          <a:p>
-            <a:pPr lvl="1"/>
-            <a:r>
-              <a:rPr sz="1200">
-                <a:solidFill>
-                  <a:srgbClr val="555555"/>
-                </a:solidFill>
-                <a:latin typeface="Calibri"/>
-              </a:rPr>
-              <a:t>–  Population: Statistics Canada Table 17-10-0009-01, used to convert counts to a rate per 100,000</a:t>
-            </a:r>
-          </a:p>
-          <a:p>
-            <a:pPr lvl="1"/>
-            <a:r>
-              <a:rPr sz="1200">
-                <a:solidFill>
-                  <a:srgbClr val="555555"/>
-                </a:solidFill>
-                <a:latin typeface="Calibri"/>
-              </a:rPr>
-              <a:t>–  No internal Government of Alberta data is used; all sources are public</a:t>
-            </a:r>
-          </a:p>
-          <a:p>
-            <a:pPr/>
-            <a:r>
-              <a:rPr sz="1400">
-                <a:solidFill>
-                  <a:srgbClr val="1A1A1A"/>
-                </a:solidFill>
-                <a:latin typeface="Calibri"/>
-              </a:rPr>
-              <a:t>•  Robustness checks confirm the result is not an artefact of method choices</a:t>
-            </a:r>
-          </a:p>
-          <a:p>
-            <a:pPr lvl="1"/>
-            <a:r>
-              <a:rPr sz="1200">
-                <a:solidFill>
-                  <a:srgbClr val="555555"/>
-                </a:solidFill>
-                <a:latin typeface="Calibri"/>
-              </a:rPr>
-              <a:t>–  Placebo cutoffs placed in the pre-period (should produce no jump if the design is credible)</a:t>
-            </a:r>
-          </a:p>
-          <a:p>
-            <a:pPr lvl="1"/>
-            <a:r>
-              <a:rPr sz="1200">
-                <a:solidFill>
-                  <a:srgbClr val="555555"/>
-                </a:solidFill>
-                <a:latin typeface="Calibri"/>
-              </a:rPr>
-              <a:t>–  Drop the quarter that straddles the cutoff and refit</a:t>
-            </a:r>
-          </a:p>
-          <a:p>
-            <a:pPr lvl="1"/>
-            <a:r>
-              <a:rPr sz="1200">
-                <a:solidFill>
-                  <a:srgbClr val="555555"/>
-                </a:solidFill>
-                <a:latin typeface="Calibri"/>
-              </a:rPr>
-              <a:t>–  Cross-check using a count model with a population offset</a:t>
+              <a:t>•  If a shift exists, two sub-questions follow</a:t>
+            </a:r>
+          </a:p>
+          <a:p>
+            <a:pPr lvl="1"/>
+            <a:r>
+              <a:rPr sz="1100">
+                <a:solidFill>
+                  <a:srgbClr val="555555"/>
+                </a:solidFill>
+                <a:latin typeface="Calibri"/>
+              </a:rPr>
+              <a:t>–  How large is it, in deaths per 100,000 per quarter, and how large is it relative to pre-period variation?</a:t>
+            </a:r>
+          </a:p>
+          <a:p>
+            <a:pPr lvl="1"/>
+            <a:r>
+              <a:rPr sz="1100">
+                <a:solidFill>
+                  <a:srgbClr val="555555"/>
+                </a:solidFill>
+                <a:latin typeface="Calibri"/>
+              </a:rPr>
+              <a:t>–  Could a pattern of this size arise from normal fluctuation in a noisy series? This is a precision question, not yet a policy question</a:t>
             </a:r>
           </a:p>
         </p:txBody>
@@ -4411,6 +4352,341 @@
 </file>
 
 <file path=ppt/slides/slide6.xml><?xml version="1.0" encoding="utf-8"?>
+<p:sld xmlns:a="http://schemas.openxmlformats.org/drawingml/2006/main" xmlns:p="http://schemas.openxmlformats.org/presentationml/2006/main" xmlns:r="http://schemas.openxmlformats.org/officeDocument/2006/relationships">
+  <p:cSld>
+    <p:spTree>
+      <p:nvGrpSpPr>
+        <p:cNvPr id="1" name=""/>
+        <p:cNvGrpSpPr/>
+        <p:nvPr/>
+      </p:nvGrpSpPr>
+      <p:grpSpPr/>
+      <p:sp>
+        <p:nvSpPr>
+          <p:cNvPr id="2" name="TextBox 1"/>
+          <p:cNvSpPr txBox="1"/>
+          <p:nvPr/>
+        </p:nvSpPr>
+        <p:spPr>
+          <a:xfrm>
+            <a:off x="548640" y="320040"/>
+            <a:ext cx="11064240" cy="640080"/>
+          </a:xfrm>
+          <a:prstGeom prst="rect">
+            <a:avLst/>
+          </a:prstGeom>
+          <a:noFill/>
+        </p:spPr>
+        <p:txBody>
+          <a:bodyPr wrap="none">
+            <a:spAutoFit/>
+          </a:bodyPr>
+          <a:lstStyle/>
+          <a:p>
+            <a:r>
+              <a:rPr sz="2600" b="1">
+                <a:solidFill>
+                  <a:srgbClr val="000000"/>
+                </a:solidFill>
+                <a:latin typeface="Calibri"/>
+              </a:rPr>
+              <a:t>Approach</a:t>
+            </a:r>
+          </a:p>
+        </p:txBody>
+      </p:sp>
+      <p:cxnSp>
+        <p:nvCxnSpPr>
+          <p:cNvPr id="3" name="Connector 2"/>
+          <p:cNvCxnSpPr/>
+          <p:nvPr/>
+        </p:nvCxnSpPr>
+        <p:spPr>
+          <a:xfrm>
+            <a:off x="548640" y="960120"/>
+            <a:ext cx="11064240" cy="0"/>
+          </a:xfrm>
+          <a:prstGeom prst="line">
+            <a:avLst/>
+          </a:prstGeom>
+          <a:ln w="9525">
+            <a:solidFill>
+              <a:srgbClr val="000000"/>
+            </a:solidFill>
+          </a:ln>
+        </p:spPr>
+        <p:style>
+          <a:lnRef idx="2">
+            <a:schemeClr val="accent1"/>
+          </a:lnRef>
+          <a:fillRef idx="0">
+            <a:schemeClr val="accent1"/>
+          </a:fillRef>
+          <a:effectRef idx="1">
+            <a:schemeClr val="accent1"/>
+          </a:effectRef>
+          <a:fontRef idx="minor">
+            <a:schemeClr val="tx1"/>
+          </a:fontRef>
+        </p:style>
+      </p:cxnSp>
+      <p:sp>
+        <p:nvSpPr>
+          <p:cNvPr id="4" name="TextBox 3"/>
+          <p:cNvSpPr txBox="1"/>
+          <p:nvPr/>
+        </p:nvSpPr>
+        <p:spPr>
+          <a:xfrm>
+            <a:off x="640080" y="1280160"/>
+            <a:ext cx="10972800" cy="4754880"/>
+          </a:xfrm>
+          <a:prstGeom prst="rect">
+            <a:avLst/>
+          </a:prstGeom>
+          <a:noFill/>
+        </p:spPr>
+        <p:txBody>
+          <a:bodyPr wrap="square">
+            <a:spAutoFit/>
+          </a:bodyPr>
+          <a:lstStyle/>
+          <a:p>
+            <a:pPr/>
+            <a:r>
+              <a:rPr sz="1300">
+                <a:solidFill>
+                  <a:srgbClr val="1A1A1A"/>
+                </a:solidFill>
+                <a:latin typeface="Calibri"/>
+              </a:rPr>
+              <a:t>•  To answer this research question I used interrupted time series (segmented regression)</a:t>
+            </a:r>
+          </a:p>
+          <a:p>
+            <a:pPr lvl="1"/>
+            <a:r>
+              <a:rPr sz="1000">
+                <a:solidFill>
+                  <a:srgbClr val="555555"/>
+                </a:solidFill>
+                <a:latin typeface="Calibri"/>
+              </a:rPr>
+              <a:t>–  The method directly tests for a level shift at a known cutoff, with the pre-period model (intercept, slope, seasonality) extrapolated forward as the counterfactual</a:t>
+            </a:r>
+          </a:p>
+          <a:p>
+            <a:pPr lvl="1"/>
+            <a:r>
+              <a:rPr sz="1000">
+                <a:solidFill>
+                  <a:srgbClr val="555555"/>
+                </a:solidFill>
+                <a:latin typeface="Calibri"/>
+              </a:rPr>
+              <a:t>–  It estimates three things separately: the existing trajectory before the cutoff, the level gap at the cutoff, and any change in trajectory after</a:t>
+            </a:r>
+          </a:p>
+          <a:p>
+            <a:pPr lvl="1"/>
+            <a:r>
+              <a:rPr sz="1000">
+                <a:solidFill>
+                  <a:srgbClr val="555555"/>
+                </a:solidFill>
+                <a:latin typeface="Calibri"/>
+              </a:rPr>
+              <a:t>–  Standard tool in health policy and public health epidemiology for exactly this kind of pre/post comparison</a:t>
+            </a:r>
+          </a:p>
+          <a:p>
+            <a:pPr/>
+            <a:r>
+              <a:rPr sz="1300">
+                <a:solidFill>
+                  <a:srgbClr val="1A1A1A"/>
+                </a:solidFill>
+                <a:latin typeface="Calibri"/>
+              </a:rPr>
+              <a:t>•  I used federal public data because the analysis must be independent and reproducible</a:t>
+            </a:r>
+          </a:p>
+          <a:p>
+            <a:pPr lvl="1"/>
+            <a:r>
+              <a:rPr sz="1000">
+                <a:solidFill>
+                  <a:srgbClr val="555555"/>
+                </a:solidFill>
+                <a:latin typeface="Calibri"/>
+              </a:rPr>
+              <a:t>–  Quarterly opioid deaths from the Public Health Agency of Canada, 2016 Q1 to 2025 Q3</a:t>
+            </a:r>
+          </a:p>
+          <a:p>
+            <a:pPr lvl="1"/>
+            <a:r>
+              <a:rPr sz="1000">
+                <a:solidFill>
+                  <a:srgbClr val="555555"/>
+                </a:solidFill>
+                <a:latin typeface="Calibri"/>
+              </a:rPr>
+              <a:t>–  Quarterly population from Statistics Canada, used to convert counts to a rate per 100,000 so the result is not driven by Alberta's population growth (about 12 per cent over the period)</a:t>
+            </a:r>
+          </a:p>
+          <a:p>
+            <a:pPr lvl="1"/>
+            <a:r>
+              <a:rPr sz="1000">
+                <a:solidFill>
+                  <a:srgbClr val="555555"/>
+                </a:solidFill>
+                <a:latin typeface="Calibri"/>
+              </a:rPr>
+              <a:t>–  No internal Government of Alberta data was used</a:t>
+            </a:r>
+          </a:p>
+          <a:p>
+            <a:pPr/>
+            <a:r>
+              <a:rPr sz="1300">
+                <a:solidFill>
+                  <a:srgbClr val="1A1A1A"/>
+                </a:solidFill>
+                <a:latin typeface="Calibri"/>
+              </a:rPr>
+              <a:t>•  I added four robustness checks because a single estimate from one specification is not enough to defend a finding</a:t>
+            </a:r>
+          </a:p>
+          <a:p>
+            <a:pPr lvl="1"/>
+            <a:r>
+              <a:rPr sz="1000">
+                <a:solidFill>
+                  <a:srgbClr val="555555"/>
+                </a:solidFill>
+                <a:latin typeface="Calibri"/>
+              </a:rPr>
+              <a:t>–  Placebo cutoffs in the pre-period: re-running the model with fake cutoffs at pre-COVID dates generates a reference distribution for the size of 'jumps' the method finds when nothing has happened; the real cutoff should lie outside that distribution</a:t>
+            </a:r>
+          </a:p>
+          <a:p>
+            <a:pPr lvl="1"/>
+            <a:r>
+              <a:rPr sz="1000">
+                <a:solidFill>
+                  <a:srgbClr val="555555"/>
+                </a:solidFill>
+                <a:latin typeface="Calibri"/>
+              </a:rPr>
+              <a:t>–  HAC lag sensitivity: re-estimate the standard errors with different lag lengths so the inference does not depend on a single tuning choice</a:t>
+            </a:r>
+          </a:p>
+          <a:p>
+            <a:pPr lvl="1"/>
+            <a:r>
+              <a:rPr sz="1000">
+                <a:solidFill>
+                  <a:srgbClr val="555555"/>
+                </a:solidFill>
+                <a:latin typeface="Calibri"/>
+              </a:rPr>
+              <a:t>–  Donut: drop the partial-exposure quarter (2020 Q1) and refit, to confirm the estimate is not driven by one transitional observation</a:t>
+            </a:r>
+          </a:p>
+          <a:p>
+            <a:pPr lvl="1"/>
+            <a:r>
+              <a:rPr sz="1000">
+                <a:solidFill>
+                  <a:srgbClr val="555555"/>
+                </a:solidFill>
+                <a:latin typeface="Calibri"/>
+              </a:rPr>
+              <a:t>–  Negative binomial cross-check with population offset: tests both the linear-additive functional form and the OLS Gaussian distributional assumption against a count model better matched to mortality data</a:t>
+            </a:r>
+          </a:p>
+        </p:txBody>
+      </p:sp>
+      <p:sp>
+        <p:nvSpPr>
+          <p:cNvPr id="5" name="TextBox 4"/>
+          <p:cNvSpPr txBox="1"/>
+          <p:nvPr/>
+        </p:nvSpPr>
+        <p:spPr>
+          <a:xfrm>
+            <a:off x="548640" y="6446520"/>
+            <a:ext cx="10058400" cy="274320"/>
+          </a:xfrm>
+          <a:prstGeom prst="rect">
+            <a:avLst/>
+          </a:prstGeom>
+          <a:noFill/>
+        </p:spPr>
+        <p:txBody>
+          <a:bodyPr wrap="none">
+            <a:spAutoFit/>
+          </a:bodyPr>
+          <a:lstStyle/>
+          <a:p>
+            <a:r>
+              <a:rPr sz="900">
+                <a:solidFill>
+                  <a:srgbClr val="999999"/>
+                </a:solidFill>
+                <a:latin typeface="Calibri"/>
+              </a:rPr>
+              <a:t>Alberta opioid mortality around COVID-19  |  independent project</a:t>
+            </a:r>
+          </a:p>
+        </p:txBody>
+      </p:sp>
+      <p:sp>
+        <p:nvSpPr>
+          <p:cNvPr id="6" name="TextBox 5"/>
+          <p:cNvSpPr txBox="1"/>
+          <p:nvPr/>
+        </p:nvSpPr>
+        <p:spPr>
+          <a:xfrm>
+            <a:off x="11521440" y="6446520"/>
+            <a:ext cx="548640" cy="274320"/>
+          </a:xfrm>
+          <a:prstGeom prst="rect">
+            <a:avLst/>
+          </a:prstGeom>
+          <a:noFill/>
+        </p:spPr>
+        <p:txBody>
+          <a:bodyPr wrap="none">
+            <a:spAutoFit/>
+          </a:bodyPr>
+          <a:lstStyle/>
+          <a:p>
+            <a:pPr algn="r"/>
+            <a:r>
+              <a:rPr sz="1000">
+                <a:solidFill>
+                  <a:srgbClr val="999999"/>
+                </a:solidFill>
+                <a:latin typeface="Calibri"/>
+              </a:rPr>
+              <a:t>6</a:t>
+            </a:r>
+          </a:p>
+        </p:txBody>
+      </p:sp>
+    </p:spTree>
+  </p:cSld>
+  <p:clrMapOvr>
+    <a:masterClrMapping/>
+  </p:clrMapOvr>
+</p:sld>
+</file>
+
+<file path=ppt/slides/slide7.xml><?xml version="1.0" encoding="utf-8"?>
 <p:sld xmlns:a="http://schemas.openxmlformats.org/drawingml/2006/main" xmlns:p="http://schemas.openxmlformats.org/presentationml/2006/main" xmlns:r="http://schemas.openxmlformats.org/officeDocument/2006/relationships">
   <p:cSld>
     <p:spTree>
@@ -4537,169 +4813,181 @@
           <a:p>
             <a:pPr/>
             <a:r>
-              <a:rPr sz="1200">
+              <a:rPr sz="1100">
                 <a:solidFill>
                   <a:srgbClr val="1A1A1A"/>
                 </a:solidFill>
                 <a:latin typeface="Calibri"/>
               </a:rPr>
-              <a:t>•  Pre-COVID average</a:t>
-            </a:r>
-          </a:p>
-          <a:p>
-            <a:pPr lvl="1"/>
-            <a:r>
-              <a:rPr sz="1000">
-                <a:solidFill>
-                  <a:srgbClr val="555555"/>
-                </a:solidFill>
-                <a:latin typeface="Calibri"/>
-              </a:rPr>
-              <a:t>–  About 4 deaths per 100,000 per quarter</a:t>
+              <a:t>•  Pre-COVID baseline was flat</a:t>
+            </a:r>
+          </a:p>
+          <a:p>
+            <a:pPr lvl="1"/>
+            <a:r>
+              <a:rPr sz="900">
+                <a:solidFill>
+                  <a:srgbClr val="555555"/>
+                </a:solidFill>
+                <a:latin typeface="Calibri"/>
+              </a:rPr>
+              <a:t>–  Quarterly rate sat around 4 per 100,000 from 2016 through early 2020</a:t>
+            </a:r>
+          </a:p>
+          <a:p>
+            <a:pPr lvl="1"/>
+            <a:r>
+              <a:rPr sz="900">
+                <a:solidFill>
+                  <a:srgbClr val="555555"/>
+                </a:solidFill>
+                <a:latin typeface="Calibri"/>
+              </a:rPr>
+              <a:t>–  Pre-COVID slope essentially zero (p = 0.94)</a:t>
             </a:r>
           </a:p>
           <a:p>
             <a:pPr/>
             <a:r>
-              <a:rPr sz="1200">
+              <a:rPr sz="1100">
                 <a:solidFill>
                   <a:srgbClr val="1A1A1A"/>
                 </a:solidFill>
                 <a:latin typeface="Calibri"/>
               </a:rPr>
-              <a:t>•  Post-COVID average</a:t>
-            </a:r>
-          </a:p>
-          <a:p>
-            <a:pPr lvl="1"/>
-            <a:r>
-              <a:rPr sz="1000">
-                <a:solidFill>
-                  <a:srgbClr val="555555"/>
-                </a:solidFill>
-                <a:latin typeface="Calibri"/>
-              </a:rPr>
-              <a:t>–  About 8 deaths per 100,000 per quarter</a:t>
+              <a:t>•  Level shift at 2020 Q2</a:t>
+            </a:r>
+          </a:p>
+          <a:p>
+            <a:pPr lvl="1"/>
+            <a:r>
+              <a:rPr sz="900">
+                <a:solidFill>
+                  <a:srgbClr val="555555"/>
+                </a:solidFill>
+                <a:latin typeface="Calibri"/>
+              </a:rPr>
+              <a:t>–  About +5.5 per 100,000 per quarter (95% CI +3.6 to +7.4)</a:t>
+            </a:r>
+          </a:p>
+          <a:p>
+            <a:pPr lvl="1"/>
+            <a:r>
+              <a:rPr sz="900">
+                <a:solidFill>
+                  <a:srgbClr val="555555"/>
+                </a:solidFill>
+                <a:latin typeface="Calibri"/>
+              </a:rPr>
+              <a:t>–  Equivalent to a rate ratio of 2.4 (count-model cross-check)</a:t>
+            </a:r>
+          </a:p>
+          <a:p>
+            <a:pPr lvl="1"/>
+            <a:r>
+              <a:rPr sz="900">
+                <a:solidFill>
+                  <a:srgbClr val="555555"/>
+                </a:solidFill>
+                <a:latin typeface="Calibri"/>
+              </a:rPr>
+              <a:t>–  The rate roughly doubled (~4 per 100k to ~9.5 immediately post-cutoff)</a:t>
+            </a:r>
+          </a:p>
+          <a:p>
+            <a:pPr lvl="1"/>
+            <a:r>
+              <a:rPr sz="900">
+                <a:solidFill>
+                  <a:srgbClr val="555555"/>
+                </a:solidFill>
+                <a:latin typeface="Calibri"/>
+              </a:rPr>
+              <a:t>–  At Alberta's mean population over the period, this is ~246 additional deaths per quarter, evaluated at the cutoff</a:t>
             </a:r>
           </a:p>
           <a:p>
             <a:pPr/>
             <a:r>
-              <a:rPr sz="1200">
+              <a:rPr sz="1100">
                 <a:solidFill>
                   <a:srgbClr val="1A1A1A"/>
                 </a:solidFill>
                 <a:latin typeface="Calibri"/>
               </a:rPr>
-              <a:t>•  Level shift at the cutoff</a:t>
-            </a:r>
-          </a:p>
-          <a:p>
-            <a:pPr lvl="1"/>
-            <a:r>
-              <a:rPr sz="1000">
-                <a:solidFill>
-                  <a:srgbClr val="555555"/>
-                </a:solidFill>
-                <a:latin typeface="Calibri"/>
-              </a:rPr>
-              <a:t>–  About 5.5 per 100,000 per quarter</a:t>
-            </a:r>
-          </a:p>
-          <a:p>
-            <a:pPr lvl="1"/>
-            <a:r>
-              <a:rPr sz="1000">
-                <a:solidFill>
-                  <a:srgbClr val="555555"/>
-                </a:solidFill>
-                <a:latin typeface="Calibri"/>
-              </a:rPr>
-              <a:t>–  Roughly a doubling of the rate</a:t>
-            </a:r>
-          </a:p>
-          <a:p>
-            <a:pPr lvl="1"/>
-            <a:r>
-              <a:rPr sz="1000">
-                <a:solidFill>
-                  <a:srgbClr val="555555"/>
-                </a:solidFill>
-                <a:latin typeface="Calibri"/>
-              </a:rPr>
-              <a:t>–  Statistically very strong (p &lt; 0.001)</a:t>
+              <a:t>•  Inference is strong</a:t>
+            </a:r>
+          </a:p>
+          <a:p>
+            <a:pPr lvl="1"/>
+            <a:r>
+              <a:rPr sz="900">
+                <a:solidFill>
+                  <a:srgbClr val="555555"/>
+                </a:solidFill>
+                <a:latin typeface="Calibri"/>
+              </a:rPr>
+              <a:t>–  p &lt; 0.001 in the main spec</a:t>
+            </a:r>
+          </a:p>
+          <a:p>
+            <a:pPr lvl="1"/>
+            <a:r>
+              <a:rPr sz="900">
+                <a:solidFill>
+                  <a:srgbClr val="555555"/>
+                </a:solidFill>
+                <a:latin typeface="Calibri"/>
+              </a:rPr>
+              <a:t>–  Placebo cutoffs in the pre-period maxed out at about one third of the real estimate, in the opposite direction; the real shift is far outside the placebo distribution</a:t>
             </a:r>
           </a:p>
           <a:p>
             <a:pPr/>
             <a:r>
-              <a:rPr sz="1200">
+              <a:rPr sz="1100">
                 <a:solidFill>
                   <a:srgbClr val="1A1A1A"/>
                 </a:solidFill>
                 <a:latin typeface="Calibri"/>
               </a:rPr>
-              <a:t>•  Pre-COVID trend was flat</a:t>
-            </a:r>
-          </a:p>
-          <a:p>
-            <a:pPr lvl="1"/>
-            <a:r>
-              <a:rPr sz="1000">
-                <a:solidFill>
-                  <a:srgbClr val="555555"/>
-                </a:solidFill>
-                <a:latin typeface="Calibri"/>
-              </a:rPr>
-              <a:t>–  The jump is not part of an existing rise</a:t>
-            </a:r>
-          </a:p>
-          <a:p>
-            <a:pPr/>
-            <a:r>
-              <a:rPr sz="1200">
-                <a:solidFill>
-                  <a:srgbClr val="1A1A1A"/>
-                </a:solidFill>
-                <a:latin typeface="Calibri"/>
-              </a:rPr>
-              <a:t>•  All robustness checks hold</a:t>
-            </a:r>
-          </a:p>
-          <a:p>
-            <a:pPr lvl="1"/>
-            <a:r>
-              <a:rPr sz="1000">
-                <a:solidFill>
-                  <a:srgbClr val="555555"/>
-                </a:solidFill>
-                <a:latin typeface="Calibri"/>
-              </a:rPr>
-              <a:t>–  Placebos produce no jump</a:t>
-            </a:r>
-          </a:p>
-          <a:p>
-            <a:pPr lvl="1"/>
-            <a:r>
-              <a:rPr sz="1000">
-                <a:solidFill>
-                  <a:srgbClr val="555555"/>
-                </a:solidFill>
-                <a:latin typeface="Calibri"/>
-              </a:rPr>
-              <a:t>–  Drop-quarter estimate moves &lt;3%</a:t>
-            </a:r>
-          </a:p>
-          <a:p>
-            <a:pPr lvl="1"/>
-            <a:r>
-              <a:rPr sz="1000">
-                <a:solidFill>
-                  <a:srgbClr val="555555"/>
-                </a:solidFill>
-                <a:latin typeface="Calibri"/>
-              </a:rPr>
-              <a:t>–  Cross-check confirms</a:t>
+              <a:t>•  Robustness checks all hold</a:t>
+            </a:r>
+          </a:p>
+          <a:p>
+            <a:pPr lvl="1"/>
+            <a:r>
+              <a:rPr sz="900">
+                <a:solidFill>
+                  <a:srgbClr val="555555"/>
+                </a:solidFill>
+                <a:latin typeface="Calibri"/>
+              </a:rPr>
+              <a:t>–  HAC lag sensitivity: estimate stable across lag choices</a:t>
+            </a:r>
+          </a:p>
+          <a:p>
+            <a:pPr lvl="1"/>
+            <a:r>
+              <a:rPr sz="900">
+                <a:solidFill>
+                  <a:srgbClr val="555555"/>
+                </a:solidFill>
+                <a:latin typeface="Calibri"/>
+              </a:rPr>
+              <a:t>–  Donut: drops the transitional quarter, estimate moves &lt;3%</a:t>
+            </a:r>
+          </a:p>
+          <a:p>
+            <a:pPr lvl="1"/>
+            <a:r>
+              <a:rPr sz="900">
+                <a:solidFill>
+                  <a:srgbClr val="555555"/>
+                </a:solidFill>
+                <a:latin typeface="Calibri"/>
+              </a:rPr>
+              <a:t>–  NB cross-check confirms the rate-ratio interpretation</a:t>
             </a:r>
           </a:p>
         </p:txBody>
@@ -4741,305 +5029,6 @@
       <p:sp>
         <p:nvSpPr>
           <p:cNvPr id="7" name="TextBox 6"/>
-          <p:cNvSpPr txBox="1"/>
-          <p:nvPr/>
-        </p:nvSpPr>
-        <p:spPr>
-          <a:xfrm>
-            <a:off x="11521440" y="6446520"/>
-            <a:ext cx="548640" cy="274320"/>
-          </a:xfrm>
-          <a:prstGeom prst="rect">
-            <a:avLst/>
-          </a:prstGeom>
-          <a:noFill/>
-        </p:spPr>
-        <p:txBody>
-          <a:bodyPr wrap="none">
-            <a:spAutoFit/>
-          </a:bodyPr>
-          <a:lstStyle/>
-          <a:p>
-            <a:pPr algn="r"/>
-            <a:r>
-              <a:rPr sz="1000">
-                <a:solidFill>
-                  <a:srgbClr val="999999"/>
-                </a:solidFill>
-                <a:latin typeface="Calibri"/>
-              </a:rPr>
-              <a:t>6</a:t>
-            </a:r>
-          </a:p>
-        </p:txBody>
-      </p:sp>
-    </p:spTree>
-  </p:cSld>
-  <p:clrMapOvr>
-    <a:masterClrMapping/>
-  </p:clrMapOvr>
-</p:sld>
-</file>
-
-<file path=ppt/slides/slide7.xml><?xml version="1.0" encoding="utf-8"?>
-<p:sld xmlns:a="http://schemas.openxmlformats.org/drawingml/2006/main" xmlns:p="http://schemas.openxmlformats.org/presentationml/2006/main" xmlns:r="http://schemas.openxmlformats.org/officeDocument/2006/relationships">
-  <p:cSld>
-    <p:spTree>
-      <p:nvGrpSpPr>
-        <p:cNvPr id="1" name=""/>
-        <p:cNvGrpSpPr/>
-        <p:nvPr/>
-      </p:nvGrpSpPr>
-      <p:grpSpPr/>
-      <p:sp>
-        <p:nvSpPr>
-          <p:cNvPr id="2" name="TextBox 1"/>
-          <p:cNvSpPr txBox="1"/>
-          <p:nvPr/>
-        </p:nvSpPr>
-        <p:spPr>
-          <a:xfrm>
-            <a:off x="548640" y="320040"/>
-            <a:ext cx="11064240" cy="640080"/>
-          </a:xfrm>
-          <a:prstGeom prst="rect">
-            <a:avLst/>
-          </a:prstGeom>
-          <a:noFill/>
-        </p:spPr>
-        <p:txBody>
-          <a:bodyPr wrap="none">
-            <a:spAutoFit/>
-          </a:bodyPr>
-          <a:lstStyle/>
-          <a:p>
-            <a:r>
-              <a:rPr sz="2600" b="1">
-                <a:solidFill>
-                  <a:srgbClr val="000000"/>
-                </a:solidFill>
-                <a:latin typeface="Calibri"/>
-              </a:rPr>
-              <a:t>What This Means</a:t>
-            </a:r>
-          </a:p>
-        </p:txBody>
-      </p:sp>
-      <p:cxnSp>
-        <p:nvCxnSpPr>
-          <p:cNvPr id="3" name="Connector 2"/>
-          <p:cNvCxnSpPr/>
-          <p:nvPr/>
-        </p:nvCxnSpPr>
-        <p:spPr>
-          <a:xfrm>
-            <a:off x="548640" y="960120"/>
-            <a:ext cx="11064240" cy="0"/>
-          </a:xfrm>
-          <a:prstGeom prst="line">
-            <a:avLst/>
-          </a:prstGeom>
-          <a:ln w="9525">
-            <a:solidFill>
-              <a:srgbClr val="000000"/>
-            </a:solidFill>
-          </a:ln>
-        </p:spPr>
-        <p:style>
-          <a:lnRef idx="2">
-            <a:schemeClr val="accent1"/>
-          </a:lnRef>
-          <a:fillRef idx="0">
-            <a:schemeClr val="accent1"/>
-          </a:fillRef>
-          <a:effectRef idx="1">
-            <a:schemeClr val="accent1"/>
-          </a:effectRef>
-          <a:fontRef idx="minor">
-            <a:schemeClr val="tx1"/>
-          </a:fontRef>
-        </p:style>
-      </p:cxnSp>
-      <p:sp>
-        <p:nvSpPr>
-          <p:cNvPr id="4" name="TextBox 3"/>
-          <p:cNvSpPr txBox="1"/>
-          <p:nvPr/>
-        </p:nvSpPr>
-        <p:spPr>
-          <a:xfrm>
-            <a:off x="640080" y="1371600"/>
-            <a:ext cx="10972800" cy="4572000"/>
-          </a:xfrm>
-          <a:prstGeom prst="rect">
-            <a:avLst/>
-          </a:prstGeom>
-          <a:noFill/>
-        </p:spPr>
-        <p:txBody>
-          <a:bodyPr wrap="square">
-            <a:spAutoFit/>
-          </a:bodyPr>
-          <a:lstStyle/>
-          <a:p>
-            <a:pPr/>
-            <a:r>
-              <a:rPr sz="1400">
-                <a:solidFill>
-                  <a:srgbClr val="1A1A1A"/>
-                </a:solidFill>
-                <a:latin typeface="Calibri"/>
-              </a:rPr>
-              <a:t>•  The analysis identifies the total effect of the COVID-19 pandemic on Alberta opioid mortality</a:t>
-            </a:r>
-          </a:p>
-          <a:p>
-            <a:pPr lvl="1"/>
-            <a:r>
-              <a:rPr sz="1200">
-                <a:solidFill>
-                  <a:srgbClr val="555555"/>
-                </a:solidFill>
-                <a:latin typeface="Calibri"/>
-              </a:rPr>
-              <a:t>–  This includes the virus, the public health response, drug supply chain disruption, harm reduction service impacts, mental health service impacts, isolation, and the economic shock</a:t>
-            </a:r>
-          </a:p>
-          <a:p>
-            <a:pPr lvl="1"/>
-            <a:r>
-              <a:rPr sz="1200">
-                <a:solidFill>
-                  <a:srgbClr val="555555"/>
-                </a:solidFill>
-                <a:latin typeface="Calibri"/>
-              </a:rPr>
-              <a:t>–  These are downstream consequences of the pandemic, not independent causes</a:t>
-            </a:r>
-          </a:p>
-          <a:p>
-            <a:pPr/>
-            <a:r>
-              <a:rPr sz="1400">
-                <a:solidFill>
-                  <a:srgbClr val="1A1A1A"/>
-                </a:solidFill>
-                <a:latin typeface="Calibri"/>
-              </a:rPr>
-              <a:t>•  The analysis does NOT separate the virus from everything else the pandemic brought together</a:t>
-            </a:r>
-          </a:p>
-          <a:p>
-            <a:pPr lvl="1"/>
-            <a:r>
-              <a:rPr sz="1200">
-                <a:solidFill>
-                  <a:srgbClr val="555555"/>
-                </a:solidFill>
-                <a:latin typeface="Calibri"/>
-              </a:rPr>
-              <a:t>–  What share came from supply versus services versus isolation versus economic shock is a separate, mechanism-level question</a:t>
-            </a:r>
-          </a:p>
-          <a:p>
-            <a:pPr lvl="1"/>
-            <a:r>
-              <a:rPr sz="1200">
-                <a:solidFill>
-                  <a:srgbClr val="555555"/>
-                </a:solidFill>
-                <a:latin typeface="Calibri"/>
-              </a:rPr>
-              <a:t>–  Comparing Alberta to other provinces would not solve this, because all provinces faced COVID and its policy response at the same time</a:t>
-            </a:r>
-          </a:p>
-          <a:p>
-            <a:pPr/>
-            <a:r>
-              <a:rPr sz="1400">
-                <a:solidFill>
-                  <a:srgbClr val="1A1A1A"/>
-                </a:solidFill>
-                <a:latin typeface="Calibri"/>
-              </a:rPr>
-              <a:t>•  For Recovery Model performance measurement, the baseline matters</a:t>
-            </a:r>
-          </a:p>
-          <a:p>
-            <a:pPr lvl="1"/>
-            <a:r>
-              <a:rPr sz="1200">
-                <a:solidFill>
-                  <a:srgbClr val="555555"/>
-                </a:solidFill>
-                <a:latin typeface="Calibri"/>
-              </a:rPr>
-              <a:t>–  The post-COVID baseline is roughly double the pre-COVID baseline</a:t>
-            </a:r>
-          </a:p>
-          <a:p>
-            <a:pPr lvl="1"/>
-            <a:r>
-              <a:rPr sz="1200">
-                <a:solidFill>
-                  <a:srgbClr val="555555"/>
-                </a:solidFill>
-                <a:latin typeface="Calibri"/>
-              </a:rPr>
-              <a:t>–  Any 'return to baseline' framing needs to be explicit about which baseline</a:t>
-            </a:r>
-          </a:p>
-          <a:p>
-            <a:pPr lvl="1"/>
-            <a:r>
-              <a:rPr sz="1200">
-                <a:solidFill>
-                  <a:srgbClr val="555555"/>
-                </a:solidFill>
-                <a:latin typeface="Calibri"/>
-              </a:rPr>
-              <a:t>–  The post-COVID trajectory is already declining since 2024, suggesting a real recovery is underway</a:t>
-            </a:r>
-          </a:p>
-        </p:txBody>
-      </p:sp>
-      <p:sp>
-        <p:nvSpPr>
-          <p:cNvPr id="5" name="TextBox 4"/>
-          <p:cNvSpPr txBox="1"/>
-          <p:nvPr/>
-        </p:nvSpPr>
-        <p:spPr>
-          <a:xfrm>
-            <a:off x="548640" y="6446520"/>
-            <a:ext cx="10058400" cy="274320"/>
-          </a:xfrm>
-          <a:prstGeom prst="rect">
-            <a:avLst/>
-          </a:prstGeom>
-          <a:noFill/>
-        </p:spPr>
-        <p:txBody>
-          <a:bodyPr wrap="none">
-            <a:spAutoFit/>
-          </a:bodyPr>
-          <a:lstStyle/>
-          <a:p>
-            <a:r>
-              <a:rPr sz="900">
-                <a:solidFill>
-                  <a:srgbClr val="999999"/>
-                </a:solidFill>
-                <a:latin typeface="Calibri"/>
-              </a:rPr>
-              <a:t>Alberta opioid mortality around COVID-19  |  independent project</a:t>
-            </a:r>
-          </a:p>
-        </p:txBody>
-      </p:sp>
-      <p:sp>
-        <p:nvSpPr>
-          <p:cNvPr id="6" name="TextBox 5"/>
           <p:cNvSpPr txBox="1"/>
           <p:nvPr/>
         </p:nvSpPr>
@@ -5119,7 +5108,7 @@
                 </a:solidFill>
                 <a:latin typeface="Calibri"/>
               </a:rPr>
-              <a:t>Limitations and Next Steps</a:t>
+              <a:t>What This Means</a:t>
             </a:r>
           </a:p>
         </p:txBody>
@@ -5167,8 +5156,8 @@
         </p:nvSpPr>
         <p:spPr>
           <a:xfrm>
-            <a:off x="640080" y="1371600"/>
-            <a:ext cx="10972800" cy="4572000"/>
+            <a:off x="640080" y="1280160"/>
+            <a:ext cx="10972800" cy="4754880"/>
           </a:xfrm>
           <a:prstGeom prst="rect">
             <a:avLst/>
@@ -5183,133 +5172,145 @@
           <a:p>
             <a:pPr/>
             <a:r>
-              <a:rPr sz="1400">
+              <a:rPr sz="1200">
                 <a:solidFill>
                   <a:srgbClr val="1A1A1A"/>
                 </a:solidFill>
                 <a:latin typeface="Calibri"/>
               </a:rPr>
-              <a:t>•  Limitations</a:t>
-            </a:r>
-          </a:p>
-          <a:p>
-            <a:pPr lvl="1"/>
+              <a:t>•  The analysis identifies the level shift at 2020 Q2 that the pre-period trend and seasonality cannot explain</a:t>
+            </a:r>
+          </a:p>
+          <a:p>
+            <a:pPr lvl="1"/>
+            <a:r>
+              <a:rPr sz="1000">
+                <a:solidFill>
+                  <a:srgbClr val="555555"/>
+                </a:solidFill>
+                <a:latin typeface="Calibri"/>
+              </a:rPr>
+              <a:t>–  This is what the statistics support directly; everything below is interpretation</a:t>
+            </a:r>
+          </a:p>
+          <a:p>
+            <a:pPr/>
             <a:r>
               <a:rPr sz="1200">
                 <a:solidFill>
-                  <a:srgbClr val="555555"/>
-                </a:solidFill>
-                <a:latin typeface="Calibri"/>
-              </a:rPr>
-              <a:t>–  Single province, single outcome (opioid deaths) - no decomposition by substance type, age, sex, or zone</a:t>
-            </a:r>
-          </a:p>
-          <a:p>
-            <a:pPr lvl="1"/>
+                  <a:srgbClr val="1A1A1A"/>
+                </a:solidFill>
+                <a:latin typeface="Calibri"/>
+              </a:rPr>
+              <a:t>•  I interpret that shift as the total joint effect of the COVID-19 pandemic bundle</a:t>
+            </a:r>
+          </a:p>
+          <a:p>
+            <a:pPr lvl="1"/>
+            <a:r>
+              <a:rPr sz="1000">
+                <a:solidFill>
+                  <a:srgbClr val="555555"/>
+                </a:solidFill>
+                <a:latin typeface="Calibri"/>
+              </a:rPr>
+              <a:t>–  'Pandemic' here means everything that came together at the cutoff: virus circulation, the public health emergency response, drug supply chain disruption, harm reduction service capacity, mental health and addiction service capacity, isolation, and the economic shock</a:t>
+            </a:r>
+          </a:p>
+          <a:p>
+            <a:pPr lvl="1"/>
+            <a:r>
+              <a:rPr sz="1000">
+                <a:solidFill>
+                  <a:srgbClr val="555555"/>
+                </a:solidFill>
+                <a:latin typeface="Calibri"/>
+              </a:rPr>
+              <a:t>–  These are downstream consequences of the pandemic; they did not align by coincidence</a:t>
+            </a:r>
+          </a:p>
+          <a:p>
+            <a:pPr lvl="1"/>
+            <a:r>
+              <a:rPr sz="1000">
+                <a:solidFill>
+                  <a:srgbClr val="555555"/>
+                </a:solidFill>
+                <a:latin typeface="Calibri"/>
+              </a:rPr>
+              <a:t>–  This is an interpretive choice, not a statistical claim. The design cannot separate the channels, and the channels cannot meaningfully be removed from 'COVID' without losing the concept itself</a:t>
+            </a:r>
+          </a:p>
+          <a:p>
+            <a:pPr/>
             <a:r>
               <a:rPr sz="1200">
                 <a:solidFill>
-                  <a:srgbClr val="555555"/>
-                </a:solidFill>
-                <a:latin typeface="Calibri"/>
-              </a:rPr>
-              <a:t>–  Quarterly data is small for inference (39 observations); reliance on robustness checks rather than asymptotic theory alone</a:t>
-            </a:r>
-          </a:p>
-          <a:p>
-            <a:pPr lvl="1"/>
+                  <a:srgbClr val="1A1A1A"/>
+                </a:solidFill>
+                <a:latin typeface="Calibri"/>
+              </a:rPr>
+              <a:t>•  The analysis does NOT identify which channel caused most of the damage</a:t>
+            </a:r>
+          </a:p>
+          <a:p>
+            <a:pPr lvl="1"/>
+            <a:r>
+              <a:rPr sz="1000">
+                <a:solidFill>
+                  <a:srgbClr val="555555"/>
+                </a:solidFill>
+                <a:latin typeface="Calibri"/>
+              </a:rPr>
+              <a:t>–  That is a different question (mechanism, not break) and needs different data: drug-checking composition, service utilization records, fentanyl share of toxicology, and so on</a:t>
+            </a:r>
+          </a:p>
+          <a:p>
+            <a:pPr lvl="1"/>
+            <a:r>
+              <a:rPr sz="1000">
+                <a:solidFill>
+                  <a:srgbClr val="555555"/>
+                </a:solidFill>
+                <a:latin typeface="Calibri"/>
+              </a:rPr>
+              <a:t>–  Comparing Alberta to other provinces would not solve this: every Canadian province faced COVID and its policy response at the same time, so peer comparison identifies Alberta-specific deviation, not a virus-only channel</a:t>
+            </a:r>
+          </a:p>
+          <a:p>
+            <a:pPr/>
             <a:r>
               <a:rPr sz="1200">
                 <a:solidFill>
-                  <a:srgbClr val="555555"/>
-                </a:solidFill>
-                <a:latin typeface="Calibri"/>
-              </a:rPr>
-              <a:t>–  Reporting lag and revisions: the most recent quarters may move as data is updated</a:t>
-            </a:r>
-          </a:p>
-          <a:p>
-            <a:pPr/>
-            <a:r>
-              <a:rPr sz="1400">
-                <a:solidFill>
                   <a:srgbClr val="1A1A1A"/>
                 </a:solidFill>
                 <a:latin typeface="Calibri"/>
               </a:rPr>
-              <a:t>•  Realistic next analytical work</a:t>
-            </a:r>
-          </a:p>
-          <a:p>
-            <a:pPr lvl="1"/>
-            <a:r>
-              <a:rPr sz="1200">
-                <a:solidFill>
-                  <a:srgbClr val="555555"/>
-                </a:solidFill>
-                <a:latin typeface="Calibri"/>
-              </a:rPr>
-              <a:t>–  Mechanism decomposition: bring in supply-side, service-capacity, and outcome data to attribute share to each channel</a:t>
-            </a:r>
-          </a:p>
-          <a:p>
-            <a:pPr lvl="1"/>
-            <a:r>
-              <a:rPr sz="1200">
-                <a:solidFill>
-                  <a:srgbClr val="555555"/>
-                </a:solidFill>
-                <a:latin typeface="Calibri"/>
-              </a:rPr>
-              <a:t>–  Heterogeneity: by age, sex, zone, and substance type (fentanyl, carfentanil, other)</a:t>
-            </a:r>
-          </a:p>
-          <a:p>
-            <a:pPr lvl="1"/>
-            <a:r>
-              <a:rPr sz="1200">
-                <a:solidFill>
-                  <a:srgbClr val="555555"/>
-                </a:solidFill>
-                <a:latin typeface="Calibri"/>
-              </a:rPr>
-              <a:t>–  Post-period dynamics: model the rise-to-peak-and-decline shape directly</a:t>
-            </a:r>
-          </a:p>
-          <a:p>
-            <a:pPr lvl="1"/>
-            <a:r>
-              <a:rPr sz="1200">
-                <a:solidFill>
-                  <a:srgbClr val="555555"/>
-                </a:solidFill>
-                <a:latin typeface="Calibri"/>
-              </a:rPr>
-              <a:t>–  Cumulative excess deaths through end-of-sample as a policy-relevant total</a:t>
-            </a:r>
-          </a:p>
-          <a:p>
-            <a:pPr/>
-            <a:r>
-              <a:rPr sz="1400">
-                <a:solidFill>
-                  <a:srgbClr val="1A1A1A"/>
-                </a:solidFill>
-                <a:latin typeface="Calibri"/>
-              </a:rPr>
-              <a:t>•  Code, data, and full documentation</a:t>
-            </a:r>
-          </a:p>
-          <a:p>
-            <a:pPr lvl="1"/>
-            <a:r>
-              <a:rPr sz="1200">
-                <a:solidFill>
-                  <a:srgbClr val="555555"/>
-                </a:solidFill>
-                <a:latin typeface="Calibri"/>
-              </a:rPr>
-              <a:t>–  github.com/Adilbek123/alberta-substance-use-trends</a:t>
+              <a:t>•  The post-cutoff series has been declining since 2024</a:t>
+            </a:r>
+          </a:p>
+          <a:p>
+            <a:pPr lvl="1"/>
+            <a:r>
+              <a:rPr sz="1000">
+                <a:solidFill>
+                  <a:srgbClr val="555555"/>
+                </a:solidFill>
+                <a:latin typeface="Calibri"/>
+              </a:rPr>
+              <a:t>–  This analysis does not test that decline formally; doing so is a natural next step</a:t>
+            </a:r>
+          </a:p>
+          <a:p>
+            <a:pPr lvl="1"/>
+            <a:r>
+              <a:rPr sz="1000">
+                <a:solidFill>
+                  <a:srgbClr val="555555"/>
+                </a:solidFill>
+                <a:latin typeface="Calibri"/>
+              </a:rPr>
+              <a:t>–  The Recovery Model's performance framing should be explicit about which baseline it compares to: pre-COVID, post-cutoff peak, or current</a:t>
             </a:r>
           </a:p>
         </p:txBody>
@@ -5379,6 +5380,353 @@
                 <a:latin typeface="Calibri"/>
               </a:rPr>
               <a:t>8</a:t>
+            </a:r>
+          </a:p>
+        </p:txBody>
+      </p:sp>
+    </p:spTree>
+  </p:cSld>
+  <p:clrMapOvr>
+    <a:masterClrMapping/>
+  </p:clrMapOvr>
+</p:sld>
+</file>
+
+<file path=ppt/slides/slide9.xml><?xml version="1.0" encoding="utf-8"?>
+<p:sld xmlns:a="http://schemas.openxmlformats.org/drawingml/2006/main" xmlns:p="http://schemas.openxmlformats.org/presentationml/2006/main" xmlns:r="http://schemas.openxmlformats.org/officeDocument/2006/relationships">
+  <p:cSld>
+    <p:spTree>
+      <p:nvGrpSpPr>
+        <p:cNvPr id="1" name=""/>
+        <p:cNvGrpSpPr/>
+        <p:nvPr/>
+      </p:nvGrpSpPr>
+      <p:grpSpPr/>
+      <p:sp>
+        <p:nvSpPr>
+          <p:cNvPr id="2" name="TextBox 1"/>
+          <p:cNvSpPr txBox="1"/>
+          <p:nvPr/>
+        </p:nvSpPr>
+        <p:spPr>
+          <a:xfrm>
+            <a:off x="548640" y="320040"/>
+            <a:ext cx="11064240" cy="640080"/>
+          </a:xfrm>
+          <a:prstGeom prst="rect">
+            <a:avLst/>
+          </a:prstGeom>
+          <a:noFill/>
+        </p:spPr>
+        <p:txBody>
+          <a:bodyPr wrap="none">
+            <a:spAutoFit/>
+          </a:bodyPr>
+          <a:lstStyle/>
+          <a:p>
+            <a:r>
+              <a:rPr sz="2600" b="1">
+                <a:solidFill>
+                  <a:srgbClr val="000000"/>
+                </a:solidFill>
+                <a:latin typeface="Calibri"/>
+              </a:rPr>
+              <a:t>Limitations and Next Steps</a:t>
+            </a:r>
+          </a:p>
+        </p:txBody>
+      </p:sp>
+      <p:cxnSp>
+        <p:nvCxnSpPr>
+          <p:cNvPr id="3" name="Connector 2"/>
+          <p:cNvCxnSpPr/>
+          <p:nvPr/>
+        </p:nvCxnSpPr>
+        <p:spPr>
+          <a:xfrm>
+            <a:off x="548640" y="960120"/>
+            <a:ext cx="11064240" cy="0"/>
+          </a:xfrm>
+          <a:prstGeom prst="line">
+            <a:avLst/>
+          </a:prstGeom>
+          <a:ln w="9525">
+            <a:solidFill>
+              <a:srgbClr val="000000"/>
+            </a:solidFill>
+          </a:ln>
+        </p:spPr>
+        <p:style>
+          <a:lnRef idx="2">
+            <a:schemeClr val="accent1"/>
+          </a:lnRef>
+          <a:fillRef idx="0">
+            <a:schemeClr val="accent1"/>
+          </a:fillRef>
+          <a:effectRef idx="1">
+            <a:schemeClr val="accent1"/>
+          </a:effectRef>
+          <a:fontRef idx="minor">
+            <a:schemeClr val="tx1"/>
+          </a:fontRef>
+        </p:style>
+      </p:cxnSp>
+      <p:sp>
+        <p:nvSpPr>
+          <p:cNvPr id="4" name="TextBox 3"/>
+          <p:cNvSpPr txBox="1"/>
+          <p:nvPr/>
+        </p:nvSpPr>
+        <p:spPr>
+          <a:xfrm>
+            <a:off x="640080" y="1280160"/>
+            <a:ext cx="10972800" cy="4754880"/>
+          </a:xfrm>
+          <a:prstGeom prst="rect">
+            <a:avLst/>
+          </a:prstGeom>
+          <a:noFill/>
+        </p:spPr>
+        <p:txBody>
+          <a:bodyPr wrap="square">
+            <a:spAutoFit/>
+          </a:bodyPr>
+          <a:lstStyle/>
+          <a:p>
+            <a:pPr/>
+            <a:r>
+              <a:rPr sz="1200">
+                <a:solidFill>
+                  <a:srgbClr val="1A1A1A"/>
+                </a:solidFill>
+                <a:latin typeface="Calibri"/>
+              </a:rPr>
+              <a:t>•  Limitations to keep in mind</a:t>
+            </a:r>
+          </a:p>
+          <a:p>
+            <a:pPr lvl="1"/>
+            <a:r>
+              <a:rPr sz="1000">
+                <a:solidFill>
+                  <a:srgbClr val="555555"/>
+                </a:solidFill>
+                <a:latin typeface="Calibri"/>
+              </a:rPr>
+              <a:t>–  Single province, single outcome (opioid deaths) - no decomposition by age, sex, zone, or substance type</a:t>
+            </a:r>
+          </a:p>
+          <a:p>
+            <a:pPr lvl="1"/>
+            <a:r>
+              <a:rPr sz="1000">
+                <a:solidFill>
+                  <a:srgbClr val="555555"/>
+                </a:solidFill>
+                <a:latin typeface="Calibri"/>
+              </a:rPr>
+              <a:t>–  Small sample for asymptotic inference (n = 39 quarters); n is at the lower end of where Newey-West asymptotics are reasonable, which is why placebos serve as a partial substitute</a:t>
+            </a:r>
+          </a:p>
+          <a:p>
+            <a:pPr lvl="1"/>
+            <a:r>
+              <a:rPr sz="1000">
+                <a:solidFill>
+                  <a:srgbClr val="555555"/>
+                </a:solidFill>
+                <a:latin typeface="Calibri"/>
+              </a:rPr>
+              <a:t>–  The cutoff (2020 Q2) was chosen because the emergency was declared 17 March 2020; 2020 Q1 is partial-exposure, the donut robustness confirms the choice does not drive the result</a:t>
+            </a:r>
+          </a:p>
+          <a:p>
+            <a:pPr lvl="1"/>
+            <a:r>
+              <a:rPr sz="1000">
+                <a:solidFill>
+                  <a:srgbClr val="555555"/>
+                </a:solidFill>
+                <a:latin typeface="Calibri"/>
+              </a:rPr>
+              <a:t>–  Beta-2 is the level shift conditional on a linear post-trend; the post-period is non-monotonic (peak in 2021 Q4, decline since 2024), so a single level shift does not capture the full dynamic</a:t>
+            </a:r>
+          </a:p>
+          <a:p>
+            <a:pPr lvl="1"/>
+            <a:r>
+              <a:rPr sz="1000">
+                <a:solidFill>
+                  <a:srgbClr val="555555"/>
+                </a:solidFill>
+                <a:latin typeface="Calibri"/>
+              </a:rPr>
+              <a:t>–  Seasonality is modelled as additive quarter fixed effects, assumed constant across years (likely fine but not formally tested)</a:t>
+            </a:r>
+          </a:p>
+          <a:p>
+            <a:pPr lvl="1"/>
+            <a:r>
+              <a:rPr sz="1000">
+                <a:solidFill>
+                  <a:srgbClr val="555555"/>
+                </a:solidFill>
+                <a:latin typeface="Calibri"/>
+              </a:rPr>
+              <a:t>–  Reporting lag and revisions: the most recent quarters may move when PHAC updates the data</a:t>
+            </a:r>
+          </a:p>
+          <a:p>
+            <a:pPr/>
+            <a:r>
+              <a:rPr sz="1200">
+                <a:solidFill>
+                  <a:srgbClr val="1A1A1A"/>
+                </a:solidFill>
+                <a:latin typeface="Calibri"/>
+              </a:rPr>
+              <a:t>•  What I would do next</a:t>
+            </a:r>
+          </a:p>
+          <a:p>
+            <a:pPr lvl="1"/>
+            <a:r>
+              <a:rPr sz="1000">
+                <a:solidFill>
+                  <a:srgbClr val="555555"/>
+                </a:solidFill>
+                <a:latin typeface="Calibri"/>
+              </a:rPr>
+              <a:t>–  Mechanism decomposition: bring in supply-side, service-capacity, and outcome data to attribute share of the shift to each channel</a:t>
+            </a:r>
+          </a:p>
+          <a:p>
+            <a:pPr lvl="1"/>
+            <a:r>
+              <a:rPr sz="1000">
+                <a:solidFill>
+                  <a:srgbClr val="555555"/>
+                </a:solidFill>
+                <a:latin typeface="Calibri"/>
+              </a:rPr>
+              <a:t>–  Heterogeneity: by age, sex, zone (Edmonton, Calgary, rural), and substance type (fentanyl, carfentanil, other)</a:t>
+            </a:r>
+          </a:p>
+          <a:p>
+            <a:pPr lvl="1"/>
+            <a:r>
+              <a:rPr sz="1000">
+                <a:solidFill>
+                  <a:srgbClr val="555555"/>
+                </a:solidFill>
+                <a:latin typeface="Calibri"/>
+              </a:rPr>
+              <a:t>–  Post-period dynamics: model the rise-to-peak-and-decline shape directly, rather than collapsing it into a single level shift</a:t>
+            </a:r>
+          </a:p>
+          <a:p>
+            <a:pPr lvl="1"/>
+            <a:r>
+              <a:rPr sz="1000">
+                <a:solidFill>
+                  <a:srgbClr val="555555"/>
+                </a:solidFill>
+                <a:latin typeface="Calibri"/>
+              </a:rPr>
+              <a:t>–  Cumulative excess deaths through end-of-sample as a policy-relevant total</a:t>
+            </a:r>
+          </a:p>
+          <a:p>
+            <a:pPr/>
+            <a:r>
+              <a:rPr sz="1200">
+                <a:solidFill>
+                  <a:srgbClr val="1A1A1A"/>
+                </a:solidFill>
+                <a:latin typeface="Calibri"/>
+              </a:rPr>
+              <a:t>•  Reproducibility</a:t>
+            </a:r>
+          </a:p>
+          <a:p>
+            <a:pPr lvl="1"/>
+            <a:r>
+              <a:rPr sz="1000">
+                <a:solidFill>
+                  <a:srgbClr val="555555"/>
+                </a:solidFill>
+                <a:latin typeface="Calibri"/>
+              </a:rPr>
+              <a:t>–  Code, data, and full documentation: github.com/Adilbek123/alberta-substance-use-trends</a:t>
+            </a:r>
+          </a:p>
+        </p:txBody>
+      </p:sp>
+      <p:sp>
+        <p:nvSpPr>
+          <p:cNvPr id="5" name="TextBox 4"/>
+          <p:cNvSpPr txBox="1"/>
+          <p:nvPr/>
+        </p:nvSpPr>
+        <p:spPr>
+          <a:xfrm>
+            <a:off x="548640" y="6446520"/>
+            <a:ext cx="10058400" cy="274320"/>
+          </a:xfrm>
+          <a:prstGeom prst="rect">
+            <a:avLst/>
+          </a:prstGeom>
+          <a:noFill/>
+        </p:spPr>
+        <p:txBody>
+          <a:bodyPr wrap="none">
+            <a:spAutoFit/>
+          </a:bodyPr>
+          <a:lstStyle/>
+          <a:p>
+            <a:r>
+              <a:rPr sz="900">
+                <a:solidFill>
+                  <a:srgbClr val="999999"/>
+                </a:solidFill>
+                <a:latin typeface="Calibri"/>
+              </a:rPr>
+              <a:t>Alberta opioid mortality around COVID-19  |  independent project</a:t>
+            </a:r>
+          </a:p>
+        </p:txBody>
+      </p:sp>
+      <p:sp>
+        <p:nvSpPr>
+          <p:cNvPr id="6" name="TextBox 5"/>
+          <p:cNvSpPr txBox="1"/>
+          <p:nvPr/>
+        </p:nvSpPr>
+        <p:spPr>
+          <a:xfrm>
+            <a:off x="11521440" y="6446520"/>
+            <a:ext cx="548640" cy="274320"/>
+          </a:xfrm>
+          <a:prstGeom prst="rect">
+            <a:avLst/>
+          </a:prstGeom>
+          <a:noFill/>
+        </p:spPr>
+        <p:txBody>
+          <a:bodyPr wrap="none">
+            <a:spAutoFit/>
+          </a:bodyPr>
+          <a:lstStyle/>
+          <a:p>
+            <a:pPr algn="r"/>
+            <a:r>
+              <a:rPr sz="1000">
+                <a:solidFill>
+                  <a:srgbClr val="999999"/>
+                </a:solidFill>
+                <a:latin typeface="Calibri"/>
+              </a:rPr>
+              <a:t>9</a:t>
             </a:r>
           </a:p>
         </p:txBody>

</xml_diff>